<commit_message>
feat: complete owner readiness and action plan preparation
</commit_message>
<xml_diff>
--- a/docs/leadership/MICROSOFT_RUST_INVESTMENT_DECK.pptx
+++ b/docs/leadership/MICROSOFT_RUST_INVESTMENT_DECK.pptx
@@ -140,7 +140,7 @@
           <p:cNvPr id="2" name="Title 1">
             <a:extLst>
               <a:ext uri="{FF2B5EF4-FFF2-40B4-BE49-F238E27FC236}">
-                <a16:creationId xmlns:a16="http://schemas.microsoft.com/office/drawing/2014/main" id="{9994BF1D-5388-FB74-6F30-3921261206AF}"/>
+                <a16:creationId xmlns:a16="http://schemas.microsoft.com/office/drawing/2014/main" id="{AF617C83-D5F1-F284-4A39-F08D30E42F5A}"/>
               </a:ext>
             </a:extLst>
           </p:cNvPr>
@@ -177,7 +177,7 @@
           <p:cNvPr id="3" name="Subtitle 2">
             <a:extLst>
               <a:ext uri="{FF2B5EF4-FFF2-40B4-BE49-F238E27FC236}">
-                <a16:creationId xmlns:a16="http://schemas.microsoft.com/office/drawing/2014/main" id="{5F61A21A-6F7E-CDDC-AB7B-B605258AC312}"/>
+                <a16:creationId xmlns:a16="http://schemas.microsoft.com/office/drawing/2014/main" id="{A53764F9-E2EB-7FFE-ADAA-6AF0B7ADEA0D}"/>
               </a:ext>
             </a:extLst>
           </p:cNvPr>
@@ -247,7 +247,7 @@
           <p:cNvPr id="4" name="Date Placeholder 3">
             <a:extLst>
               <a:ext uri="{FF2B5EF4-FFF2-40B4-BE49-F238E27FC236}">
-                <a16:creationId xmlns:a16="http://schemas.microsoft.com/office/drawing/2014/main" id="{2D14E37C-37FE-FF7D-667E-517DC0A8D8C0}"/>
+                <a16:creationId xmlns:a16="http://schemas.microsoft.com/office/drawing/2014/main" id="{C7E82373-F1A7-8AE1-CE2E-8BB833E9F23C}"/>
               </a:ext>
             </a:extLst>
           </p:cNvPr>
@@ -263,9 +263,9 @@
           <a:bodyPr/>
           <a:lstStyle/>
           <a:p>
-            <a:fld id="{33959005-B26C-4F66-8525-6755711030AC}" type="datetimeFigureOut">
+            <a:fld id="{EE8B46EF-BC55-43A4-9BE9-7DF2F9C6E933}" type="datetimeFigureOut">
               <a:rPr lang="en-US" smtClean="0"/>
-              <a:t>8/19/2026</a:t>
+              <a:t>9/21/2026</a:t>
             </a:fld>
             <a:endParaRPr lang="en-US"/>
           </a:p>
@@ -276,7 +276,7 @@
           <p:cNvPr id="5" name="Footer Placeholder 4">
             <a:extLst>
               <a:ext uri="{FF2B5EF4-FFF2-40B4-BE49-F238E27FC236}">
-                <a16:creationId xmlns:a16="http://schemas.microsoft.com/office/drawing/2014/main" id="{2B2A7E0A-B2C2-79C9-0872-23583E763C6B}"/>
+                <a16:creationId xmlns:a16="http://schemas.microsoft.com/office/drawing/2014/main" id="{2F13C0E3-A0E5-1A77-3F3B-4F20269B5090}"/>
               </a:ext>
             </a:extLst>
           </p:cNvPr>
@@ -301,7 +301,7 @@
           <p:cNvPr id="6" name="Slide Number Placeholder 5">
             <a:extLst>
               <a:ext uri="{FF2B5EF4-FFF2-40B4-BE49-F238E27FC236}">
-                <a16:creationId xmlns:a16="http://schemas.microsoft.com/office/drawing/2014/main" id="{E8987516-C392-0FE5-E4AA-10D67550F6E9}"/>
+                <a16:creationId xmlns:a16="http://schemas.microsoft.com/office/drawing/2014/main" id="{C949B1F2-1CAE-DE27-7D41-21049EA4EC27}"/>
               </a:ext>
             </a:extLst>
           </p:cNvPr>
@@ -317,7 +317,7 @@
           <a:bodyPr/>
           <a:lstStyle/>
           <a:p>
-            <a:fld id="{877D9784-4EBE-4E69-A4A0-9CB0C6271F0B}" type="slidenum">
+            <a:fld id="{596BC448-00DA-4911-8130-CC0B5B7DAEAC}" type="slidenum">
               <a:rPr lang="en-US" smtClean="0"/>
               <a:t>‹#›</a:t>
             </a:fld>
@@ -328,7 +328,7 @@
     </p:spTree>
     <p:extLst>
       <p:ext uri="{BB962C8B-B14F-4D97-AF65-F5344CB8AC3E}">
-        <p14:creationId xmlns:p14="http://schemas.microsoft.com/office/powerpoint/2010/main" val="2587093594"/>
+        <p14:creationId xmlns:p14="http://schemas.microsoft.com/office/powerpoint/2010/main" val="385327057"/>
       </p:ext>
     </p:extLst>
   </p:cSld>
@@ -360,7 +360,7 @@
           <p:cNvPr id="2" name="Title 1">
             <a:extLst>
               <a:ext uri="{FF2B5EF4-FFF2-40B4-BE49-F238E27FC236}">
-                <a16:creationId xmlns:a16="http://schemas.microsoft.com/office/drawing/2014/main" id="{77507FBA-98A2-3E52-B1A8-6A7E264933E8}"/>
+                <a16:creationId xmlns:a16="http://schemas.microsoft.com/office/drawing/2014/main" id="{81BF08CC-AC96-DD9F-60D9-16C2B620F0A2}"/>
               </a:ext>
             </a:extLst>
           </p:cNvPr>
@@ -388,7 +388,7 @@
           <p:cNvPr id="3" name="Vertical Text Placeholder 2">
             <a:extLst>
               <a:ext uri="{FF2B5EF4-FFF2-40B4-BE49-F238E27FC236}">
-                <a16:creationId xmlns:a16="http://schemas.microsoft.com/office/drawing/2014/main" id="{C6CE615B-F59E-21FE-9CFB-5C2325182DE2}"/>
+                <a16:creationId xmlns:a16="http://schemas.microsoft.com/office/drawing/2014/main" id="{0EFD8A8C-C02C-2DE3-02A3-E5AE4FC93409}"/>
               </a:ext>
             </a:extLst>
           </p:cNvPr>
@@ -445,7 +445,7 @@
           <p:cNvPr id="4" name="Date Placeholder 3">
             <a:extLst>
               <a:ext uri="{FF2B5EF4-FFF2-40B4-BE49-F238E27FC236}">
-                <a16:creationId xmlns:a16="http://schemas.microsoft.com/office/drawing/2014/main" id="{F48B6732-A129-5DFA-F97A-EBD76B84E7AA}"/>
+                <a16:creationId xmlns:a16="http://schemas.microsoft.com/office/drawing/2014/main" id="{AC540E32-7020-B056-0495-76635DC0F109}"/>
               </a:ext>
             </a:extLst>
           </p:cNvPr>
@@ -461,9 +461,9 @@
           <a:bodyPr/>
           <a:lstStyle/>
           <a:p>
-            <a:fld id="{33959005-B26C-4F66-8525-6755711030AC}" type="datetimeFigureOut">
+            <a:fld id="{EE8B46EF-BC55-43A4-9BE9-7DF2F9C6E933}" type="datetimeFigureOut">
               <a:rPr lang="en-US" smtClean="0"/>
-              <a:t>8/19/2026</a:t>
+              <a:t>9/21/2026</a:t>
             </a:fld>
             <a:endParaRPr lang="en-US"/>
           </a:p>
@@ -474,7 +474,7 @@
           <p:cNvPr id="5" name="Footer Placeholder 4">
             <a:extLst>
               <a:ext uri="{FF2B5EF4-FFF2-40B4-BE49-F238E27FC236}">
-                <a16:creationId xmlns:a16="http://schemas.microsoft.com/office/drawing/2014/main" id="{3580CAB2-FDA6-B34B-24E6-7A0FE6A3AA1E}"/>
+                <a16:creationId xmlns:a16="http://schemas.microsoft.com/office/drawing/2014/main" id="{F8CE858E-2917-EB73-A02E-5E34C737A12A}"/>
               </a:ext>
             </a:extLst>
           </p:cNvPr>
@@ -499,7 +499,7 @@
           <p:cNvPr id="6" name="Slide Number Placeholder 5">
             <a:extLst>
               <a:ext uri="{FF2B5EF4-FFF2-40B4-BE49-F238E27FC236}">
-                <a16:creationId xmlns:a16="http://schemas.microsoft.com/office/drawing/2014/main" id="{8FDDB554-19CF-00F2-CF27-8A2396CDB357}"/>
+                <a16:creationId xmlns:a16="http://schemas.microsoft.com/office/drawing/2014/main" id="{C93295D9-D0EF-3759-7A8C-03F895A3964A}"/>
               </a:ext>
             </a:extLst>
           </p:cNvPr>
@@ -515,7 +515,7 @@
           <a:bodyPr/>
           <a:lstStyle/>
           <a:p>
-            <a:fld id="{877D9784-4EBE-4E69-A4A0-9CB0C6271F0B}" type="slidenum">
+            <a:fld id="{596BC448-00DA-4911-8130-CC0B5B7DAEAC}" type="slidenum">
               <a:rPr lang="en-US" smtClean="0"/>
               <a:t>‹#›</a:t>
             </a:fld>
@@ -526,7 +526,7 @@
     </p:spTree>
     <p:extLst>
       <p:ext uri="{BB962C8B-B14F-4D97-AF65-F5344CB8AC3E}">
-        <p14:creationId xmlns:p14="http://schemas.microsoft.com/office/powerpoint/2010/main" val="1414840168"/>
+        <p14:creationId xmlns:p14="http://schemas.microsoft.com/office/powerpoint/2010/main" val="1220911824"/>
       </p:ext>
     </p:extLst>
   </p:cSld>
@@ -558,7 +558,7 @@
           <p:cNvPr id="2" name="Vertical Title 1">
             <a:extLst>
               <a:ext uri="{FF2B5EF4-FFF2-40B4-BE49-F238E27FC236}">
-                <a16:creationId xmlns:a16="http://schemas.microsoft.com/office/drawing/2014/main" id="{8F82619D-9C1D-3729-4315-25EA65CB0D62}"/>
+                <a16:creationId xmlns:a16="http://schemas.microsoft.com/office/drawing/2014/main" id="{3403EE68-052D-0F22-16EE-68E34B38964B}"/>
               </a:ext>
             </a:extLst>
           </p:cNvPr>
@@ -591,7 +591,7 @@
           <p:cNvPr id="3" name="Vertical Text Placeholder 2">
             <a:extLst>
               <a:ext uri="{FF2B5EF4-FFF2-40B4-BE49-F238E27FC236}">
-                <a16:creationId xmlns:a16="http://schemas.microsoft.com/office/drawing/2014/main" id="{028AEBB4-E247-59BE-9358-ECFF25594014}"/>
+                <a16:creationId xmlns:a16="http://schemas.microsoft.com/office/drawing/2014/main" id="{0D74C7C3-52A5-7ADA-4593-1B0F35954E06}"/>
               </a:ext>
             </a:extLst>
           </p:cNvPr>
@@ -653,7 +653,7 @@
           <p:cNvPr id="4" name="Date Placeholder 3">
             <a:extLst>
               <a:ext uri="{FF2B5EF4-FFF2-40B4-BE49-F238E27FC236}">
-                <a16:creationId xmlns:a16="http://schemas.microsoft.com/office/drawing/2014/main" id="{97CC676E-A570-A137-CE38-D01D898869A3}"/>
+                <a16:creationId xmlns:a16="http://schemas.microsoft.com/office/drawing/2014/main" id="{F99192E0-15EF-11E0-FB29-E095930ED0CA}"/>
               </a:ext>
             </a:extLst>
           </p:cNvPr>
@@ -669,9 +669,9 @@
           <a:bodyPr/>
           <a:lstStyle/>
           <a:p>
-            <a:fld id="{33959005-B26C-4F66-8525-6755711030AC}" type="datetimeFigureOut">
+            <a:fld id="{EE8B46EF-BC55-43A4-9BE9-7DF2F9C6E933}" type="datetimeFigureOut">
               <a:rPr lang="en-US" smtClean="0"/>
-              <a:t>8/19/2026</a:t>
+              <a:t>9/21/2026</a:t>
             </a:fld>
             <a:endParaRPr lang="en-US"/>
           </a:p>
@@ -682,7 +682,7 @@
           <p:cNvPr id="5" name="Footer Placeholder 4">
             <a:extLst>
               <a:ext uri="{FF2B5EF4-FFF2-40B4-BE49-F238E27FC236}">
-                <a16:creationId xmlns:a16="http://schemas.microsoft.com/office/drawing/2014/main" id="{1970EE54-2B92-CD78-8B2A-3272CD11FA8A}"/>
+                <a16:creationId xmlns:a16="http://schemas.microsoft.com/office/drawing/2014/main" id="{A8F1F39E-D55A-1430-D645-4E28FA73268A}"/>
               </a:ext>
             </a:extLst>
           </p:cNvPr>
@@ -707,7 +707,7 @@
           <p:cNvPr id="6" name="Slide Number Placeholder 5">
             <a:extLst>
               <a:ext uri="{FF2B5EF4-FFF2-40B4-BE49-F238E27FC236}">
-                <a16:creationId xmlns:a16="http://schemas.microsoft.com/office/drawing/2014/main" id="{ECAA9119-1212-AEAA-891D-A79AC496EBB5}"/>
+                <a16:creationId xmlns:a16="http://schemas.microsoft.com/office/drawing/2014/main" id="{17B9D19D-0B47-2B17-73BA-7F658C5BBC87}"/>
               </a:ext>
             </a:extLst>
           </p:cNvPr>
@@ -723,7 +723,7 @@
           <a:bodyPr/>
           <a:lstStyle/>
           <a:p>
-            <a:fld id="{877D9784-4EBE-4E69-A4A0-9CB0C6271F0B}" type="slidenum">
+            <a:fld id="{596BC448-00DA-4911-8130-CC0B5B7DAEAC}" type="slidenum">
               <a:rPr lang="en-US" smtClean="0"/>
               <a:t>‹#›</a:t>
             </a:fld>
@@ -734,7 +734,7 @@
     </p:spTree>
     <p:extLst>
       <p:ext uri="{BB962C8B-B14F-4D97-AF65-F5344CB8AC3E}">
-        <p14:creationId xmlns:p14="http://schemas.microsoft.com/office/powerpoint/2010/main" val="3316132120"/>
+        <p14:creationId xmlns:p14="http://schemas.microsoft.com/office/powerpoint/2010/main" val="108901134"/>
       </p:ext>
     </p:extLst>
   </p:cSld>
@@ -766,7 +766,7 @@
           <p:cNvPr id="2" name="Title 1">
             <a:extLst>
               <a:ext uri="{FF2B5EF4-FFF2-40B4-BE49-F238E27FC236}">
-                <a16:creationId xmlns:a16="http://schemas.microsoft.com/office/drawing/2014/main" id="{2011CE4D-3065-899C-2BE2-06C9C810021B}"/>
+                <a16:creationId xmlns:a16="http://schemas.microsoft.com/office/drawing/2014/main" id="{269E850F-2E55-B7FF-55F1-7F84B7FAE5CF}"/>
               </a:ext>
             </a:extLst>
           </p:cNvPr>
@@ -794,7 +794,7 @@
           <p:cNvPr id="3" name="Content Placeholder 2">
             <a:extLst>
               <a:ext uri="{FF2B5EF4-FFF2-40B4-BE49-F238E27FC236}">
-                <a16:creationId xmlns:a16="http://schemas.microsoft.com/office/drawing/2014/main" id="{F5413661-E3C1-3727-C08E-E66F0F58774C}"/>
+                <a16:creationId xmlns:a16="http://schemas.microsoft.com/office/drawing/2014/main" id="{08A7EBE0-ACF0-9313-BA29-6CBE961215E5}"/>
               </a:ext>
             </a:extLst>
           </p:cNvPr>
@@ -851,7 +851,7 @@
           <p:cNvPr id="4" name="Date Placeholder 3">
             <a:extLst>
               <a:ext uri="{FF2B5EF4-FFF2-40B4-BE49-F238E27FC236}">
-                <a16:creationId xmlns:a16="http://schemas.microsoft.com/office/drawing/2014/main" id="{65D29190-37F4-900F-DCBC-8D04D552569E}"/>
+                <a16:creationId xmlns:a16="http://schemas.microsoft.com/office/drawing/2014/main" id="{EBA38A24-F3F0-9E33-CA98-744B79E7BDD6}"/>
               </a:ext>
             </a:extLst>
           </p:cNvPr>
@@ -867,9 +867,9 @@
           <a:bodyPr/>
           <a:lstStyle/>
           <a:p>
-            <a:fld id="{33959005-B26C-4F66-8525-6755711030AC}" type="datetimeFigureOut">
+            <a:fld id="{EE8B46EF-BC55-43A4-9BE9-7DF2F9C6E933}" type="datetimeFigureOut">
               <a:rPr lang="en-US" smtClean="0"/>
-              <a:t>8/19/2026</a:t>
+              <a:t>9/21/2026</a:t>
             </a:fld>
             <a:endParaRPr lang="en-US"/>
           </a:p>
@@ -880,7 +880,7 @@
           <p:cNvPr id="5" name="Footer Placeholder 4">
             <a:extLst>
               <a:ext uri="{FF2B5EF4-FFF2-40B4-BE49-F238E27FC236}">
-                <a16:creationId xmlns:a16="http://schemas.microsoft.com/office/drawing/2014/main" id="{5B512AFE-C667-47CD-2A9F-82E04EE05FB9}"/>
+                <a16:creationId xmlns:a16="http://schemas.microsoft.com/office/drawing/2014/main" id="{A7B1C9F9-8623-90FD-81E4-B2D2FF3FF3CE}"/>
               </a:ext>
             </a:extLst>
           </p:cNvPr>
@@ -905,7 +905,7 @@
           <p:cNvPr id="6" name="Slide Number Placeholder 5">
             <a:extLst>
               <a:ext uri="{FF2B5EF4-FFF2-40B4-BE49-F238E27FC236}">
-                <a16:creationId xmlns:a16="http://schemas.microsoft.com/office/drawing/2014/main" id="{F85753AC-5B8F-B355-866C-ECD4EDBBD861}"/>
+                <a16:creationId xmlns:a16="http://schemas.microsoft.com/office/drawing/2014/main" id="{4FE5B84C-7581-0A4F-BCBD-B76F7E68F401}"/>
               </a:ext>
             </a:extLst>
           </p:cNvPr>
@@ -921,7 +921,7 @@
           <a:bodyPr/>
           <a:lstStyle/>
           <a:p>
-            <a:fld id="{877D9784-4EBE-4E69-A4A0-9CB0C6271F0B}" type="slidenum">
+            <a:fld id="{596BC448-00DA-4911-8130-CC0B5B7DAEAC}" type="slidenum">
               <a:rPr lang="en-US" smtClean="0"/>
               <a:t>‹#›</a:t>
             </a:fld>
@@ -932,7 +932,7 @@
     </p:spTree>
     <p:extLst>
       <p:ext uri="{BB962C8B-B14F-4D97-AF65-F5344CB8AC3E}">
-        <p14:creationId xmlns:p14="http://schemas.microsoft.com/office/powerpoint/2010/main" val="3552403539"/>
+        <p14:creationId xmlns:p14="http://schemas.microsoft.com/office/powerpoint/2010/main" val="752423695"/>
       </p:ext>
     </p:extLst>
   </p:cSld>
@@ -964,7 +964,7 @@
           <p:cNvPr id="2" name="Title 1">
             <a:extLst>
               <a:ext uri="{FF2B5EF4-FFF2-40B4-BE49-F238E27FC236}">
-                <a16:creationId xmlns:a16="http://schemas.microsoft.com/office/drawing/2014/main" id="{6D966CFB-4B2A-1E21-C724-F5DACCA4D01B}"/>
+                <a16:creationId xmlns:a16="http://schemas.microsoft.com/office/drawing/2014/main" id="{2C0FF5EB-72B4-CCEE-4C18-1318C265D0AB}"/>
               </a:ext>
             </a:extLst>
           </p:cNvPr>
@@ -1001,7 +1001,7 @@
           <p:cNvPr id="3" name="Text Placeholder 2">
             <a:extLst>
               <a:ext uri="{FF2B5EF4-FFF2-40B4-BE49-F238E27FC236}">
-                <a16:creationId xmlns:a16="http://schemas.microsoft.com/office/drawing/2014/main" id="{E5AA3D84-8A49-B0A5-38F6-91072D10F1E2}"/>
+                <a16:creationId xmlns:a16="http://schemas.microsoft.com/office/drawing/2014/main" id="{85E3C02E-79A3-6227-2744-299DD76841C4}"/>
               </a:ext>
             </a:extLst>
           </p:cNvPr>
@@ -1126,7 +1126,7 @@
           <p:cNvPr id="4" name="Date Placeholder 3">
             <a:extLst>
               <a:ext uri="{FF2B5EF4-FFF2-40B4-BE49-F238E27FC236}">
-                <a16:creationId xmlns:a16="http://schemas.microsoft.com/office/drawing/2014/main" id="{602E8954-79D8-0534-6265-D8F90E06A714}"/>
+                <a16:creationId xmlns:a16="http://schemas.microsoft.com/office/drawing/2014/main" id="{7BDE8956-EC1D-457C-D8D5-DC0490DFCB43}"/>
               </a:ext>
             </a:extLst>
           </p:cNvPr>
@@ -1142,9 +1142,9 @@
           <a:bodyPr/>
           <a:lstStyle/>
           <a:p>
-            <a:fld id="{33959005-B26C-4F66-8525-6755711030AC}" type="datetimeFigureOut">
+            <a:fld id="{EE8B46EF-BC55-43A4-9BE9-7DF2F9C6E933}" type="datetimeFigureOut">
               <a:rPr lang="en-US" smtClean="0"/>
-              <a:t>8/19/2026</a:t>
+              <a:t>9/21/2026</a:t>
             </a:fld>
             <a:endParaRPr lang="en-US"/>
           </a:p>
@@ -1155,7 +1155,7 @@
           <p:cNvPr id="5" name="Footer Placeholder 4">
             <a:extLst>
               <a:ext uri="{FF2B5EF4-FFF2-40B4-BE49-F238E27FC236}">
-                <a16:creationId xmlns:a16="http://schemas.microsoft.com/office/drawing/2014/main" id="{FC232549-B2F8-9C25-D08A-18118DE8D8B0}"/>
+                <a16:creationId xmlns:a16="http://schemas.microsoft.com/office/drawing/2014/main" id="{AEEE6D95-B73E-BF7F-27BC-134FC6428213}"/>
               </a:ext>
             </a:extLst>
           </p:cNvPr>
@@ -1180,7 +1180,7 @@
           <p:cNvPr id="6" name="Slide Number Placeholder 5">
             <a:extLst>
               <a:ext uri="{FF2B5EF4-FFF2-40B4-BE49-F238E27FC236}">
-                <a16:creationId xmlns:a16="http://schemas.microsoft.com/office/drawing/2014/main" id="{D5F1016D-D143-AF64-D852-C3938C858B33}"/>
+                <a16:creationId xmlns:a16="http://schemas.microsoft.com/office/drawing/2014/main" id="{CEBA9A90-0D02-4129-3AB4-5C40E9DE23EE}"/>
               </a:ext>
             </a:extLst>
           </p:cNvPr>
@@ -1196,7 +1196,7 @@
           <a:bodyPr/>
           <a:lstStyle/>
           <a:p>
-            <a:fld id="{877D9784-4EBE-4E69-A4A0-9CB0C6271F0B}" type="slidenum">
+            <a:fld id="{596BC448-00DA-4911-8130-CC0B5B7DAEAC}" type="slidenum">
               <a:rPr lang="en-US" smtClean="0"/>
               <a:t>‹#›</a:t>
             </a:fld>
@@ -1207,7 +1207,7 @@
     </p:spTree>
     <p:extLst>
       <p:ext uri="{BB962C8B-B14F-4D97-AF65-F5344CB8AC3E}">
-        <p14:creationId xmlns:p14="http://schemas.microsoft.com/office/powerpoint/2010/main" val="3862813258"/>
+        <p14:creationId xmlns:p14="http://schemas.microsoft.com/office/powerpoint/2010/main" val="2718525595"/>
       </p:ext>
     </p:extLst>
   </p:cSld>
@@ -1239,7 +1239,7 @@
           <p:cNvPr id="2" name="Title 1">
             <a:extLst>
               <a:ext uri="{FF2B5EF4-FFF2-40B4-BE49-F238E27FC236}">
-                <a16:creationId xmlns:a16="http://schemas.microsoft.com/office/drawing/2014/main" id="{6CD4E0C1-F3C4-4BE8-60B1-A06EA492DECA}"/>
+                <a16:creationId xmlns:a16="http://schemas.microsoft.com/office/drawing/2014/main" id="{CBEA0B3B-1E54-4400-F0A5-53666FEAA0A3}"/>
               </a:ext>
             </a:extLst>
           </p:cNvPr>
@@ -1267,7 +1267,7 @@
           <p:cNvPr id="3" name="Content Placeholder 2">
             <a:extLst>
               <a:ext uri="{FF2B5EF4-FFF2-40B4-BE49-F238E27FC236}">
-                <a16:creationId xmlns:a16="http://schemas.microsoft.com/office/drawing/2014/main" id="{2B6AB636-9B48-1D60-7205-D80AD6B4AE0F}"/>
+                <a16:creationId xmlns:a16="http://schemas.microsoft.com/office/drawing/2014/main" id="{E77DBB69-17D9-825A-81B2-3CA04CDC51D4}"/>
               </a:ext>
             </a:extLst>
           </p:cNvPr>
@@ -1329,7 +1329,7 @@
           <p:cNvPr id="4" name="Content Placeholder 3">
             <a:extLst>
               <a:ext uri="{FF2B5EF4-FFF2-40B4-BE49-F238E27FC236}">
-                <a16:creationId xmlns:a16="http://schemas.microsoft.com/office/drawing/2014/main" id="{842D426E-728E-4093-EB84-293882421EE2}"/>
+                <a16:creationId xmlns:a16="http://schemas.microsoft.com/office/drawing/2014/main" id="{75A6AF9C-3A59-B665-9B21-C7EAB0E3DB85}"/>
               </a:ext>
             </a:extLst>
           </p:cNvPr>
@@ -1391,7 +1391,7 @@
           <p:cNvPr id="5" name="Date Placeholder 4">
             <a:extLst>
               <a:ext uri="{FF2B5EF4-FFF2-40B4-BE49-F238E27FC236}">
-                <a16:creationId xmlns:a16="http://schemas.microsoft.com/office/drawing/2014/main" id="{977CFB8E-69C8-2FF5-AF3C-172F5A2DEC74}"/>
+                <a16:creationId xmlns:a16="http://schemas.microsoft.com/office/drawing/2014/main" id="{18AACC47-E032-1CF7-20F3-990E76EFBBFE}"/>
               </a:ext>
             </a:extLst>
           </p:cNvPr>
@@ -1407,9 +1407,9 @@
           <a:bodyPr/>
           <a:lstStyle/>
           <a:p>
-            <a:fld id="{33959005-B26C-4F66-8525-6755711030AC}" type="datetimeFigureOut">
+            <a:fld id="{EE8B46EF-BC55-43A4-9BE9-7DF2F9C6E933}" type="datetimeFigureOut">
               <a:rPr lang="en-US" smtClean="0"/>
-              <a:t>8/19/2026</a:t>
+              <a:t>9/21/2026</a:t>
             </a:fld>
             <a:endParaRPr lang="en-US"/>
           </a:p>
@@ -1420,7 +1420,7 @@
           <p:cNvPr id="6" name="Footer Placeholder 5">
             <a:extLst>
               <a:ext uri="{FF2B5EF4-FFF2-40B4-BE49-F238E27FC236}">
-                <a16:creationId xmlns:a16="http://schemas.microsoft.com/office/drawing/2014/main" id="{74807B01-6349-1428-39D7-0D99D8FAF369}"/>
+                <a16:creationId xmlns:a16="http://schemas.microsoft.com/office/drawing/2014/main" id="{A3F10675-A0B8-916C-81C4-2F0AE8F57BC0}"/>
               </a:ext>
             </a:extLst>
           </p:cNvPr>
@@ -1445,7 +1445,7 @@
           <p:cNvPr id="7" name="Slide Number Placeholder 6">
             <a:extLst>
               <a:ext uri="{FF2B5EF4-FFF2-40B4-BE49-F238E27FC236}">
-                <a16:creationId xmlns:a16="http://schemas.microsoft.com/office/drawing/2014/main" id="{C97706E6-A390-5B7A-65B5-D69AC864E339}"/>
+                <a16:creationId xmlns:a16="http://schemas.microsoft.com/office/drawing/2014/main" id="{7E367AE9-41D1-3A70-312A-52F7491DD919}"/>
               </a:ext>
             </a:extLst>
           </p:cNvPr>
@@ -1461,7 +1461,7 @@
           <a:bodyPr/>
           <a:lstStyle/>
           <a:p>
-            <a:fld id="{877D9784-4EBE-4E69-A4A0-9CB0C6271F0B}" type="slidenum">
+            <a:fld id="{596BC448-00DA-4911-8130-CC0B5B7DAEAC}" type="slidenum">
               <a:rPr lang="en-US" smtClean="0"/>
               <a:t>‹#›</a:t>
             </a:fld>
@@ -1472,7 +1472,7 @@
     </p:spTree>
     <p:extLst>
       <p:ext uri="{BB962C8B-B14F-4D97-AF65-F5344CB8AC3E}">
-        <p14:creationId xmlns:p14="http://schemas.microsoft.com/office/powerpoint/2010/main" val="895699447"/>
+        <p14:creationId xmlns:p14="http://schemas.microsoft.com/office/powerpoint/2010/main" val="1850834625"/>
       </p:ext>
     </p:extLst>
   </p:cSld>
@@ -1504,7 +1504,7 @@
           <p:cNvPr id="2" name="Title 1">
             <a:extLst>
               <a:ext uri="{FF2B5EF4-FFF2-40B4-BE49-F238E27FC236}">
-                <a16:creationId xmlns:a16="http://schemas.microsoft.com/office/drawing/2014/main" id="{24CAFA56-9056-1593-DF4B-587DCD9A1A2A}"/>
+                <a16:creationId xmlns:a16="http://schemas.microsoft.com/office/drawing/2014/main" id="{5FE68720-9F8B-7D4A-A0F4-D662F685E691}"/>
               </a:ext>
             </a:extLst>
           </p:cNvPr>
@@ -1537,7 +1537,7 @@
           <p:cNvPr id="3" name="Text Placeholder 2">
             <a:extLst>
               <a:ext uri="{FF2B5EF4-FFF2-40B4-BE49-F238E27FC236}">
-                <a16:creationId xmlns:a16="http://schemas.microsoft.com/office/drawing/2014/main" id="{F493E48C-490A-318E-8248-6C7F6237BF94}"/>
+                <a16:creationId xmlns:a16="http://schemas.microsoft.com/office/drawing/2014/main" id="{AA876895-EC1E-DD60-29E8-CF0B7167DB1E}"/>
               </a:ext>
             </a:extLst>
           </p:cNvPr>
@@ -1608,7 +1608,7 @@
           <p:cNvPr id="4" name="Content Placeholder 3">
             <a:extLst>
               <a:ext uri="{FF2B5EF4-FFF2-40B4-BE49-F238E27FC236}">
-                <a16:creationId xmlns:a16="http://schemas.microsoft.com/office/drawing/2014/main" id="{1B0157A6-4CA0-0F5D-4AEE-C685920928FA}"/>
+                <a16:creationId xmlns:a16="http://schemas.microsoft.com/office/drawing/2014/main" id="{15A0AD77-7D0C-08F2-F54D-D3477BD00868}"/>
               </a:ext>
             </a:extLst>
           </p:cNvPr>
@@ -1670,7 +1670,7 @@
           <p:cNvPr id="5" name="Text Placeholder 4">
             <a:extLst>
               <a:ext uri="{FF2B5EF4-FFF2-40B4-BE49-F238E27FC236}">
-                <a16:creationId xmlns:a16="http://schemas.microsoft.com/office/drawing/2014/main" id="{203AFAC2-504D-E773-2213-4B210D1DB57D}"/>
+                <a16:creationId xmlns:a16="http://schemas.microsoft.com/office/drawing/2014/main" id="{FE92F472-96F4-0326-DC88-08362B35F845}"/>
               </a:ext>
             </a:extLst>
           </p:cNvPr>
@@ -1741,7 +1741,7 @@
           <p:cNvPr id="6" name="Content Placeholder 5">
             <a:extLst>
               <a:ext uri="{FF2B5EF4-FFF2-40B4-BE49-F238E27FC236}">
-                <a16:creationId xmlns:a16="http://schemas.microsoft.com/office/drawing/2014/main" id="{8438E3E6-D271-6096-F61A-53FB24716949}"/>
+                <a16:creationId xmlns:a16="http://schemas.microsoft.com/office/drawing/2014/main" id="{2B26F31A-D1EF-C8AE-C09E-EED56DDF40CC}"/>
               </a:ext>
             </a:extLst>
           </p:cNvPr>
@@ -1803,7 +1803,7 @@
           <p:cNvPr id="7" name="Date Placeholder 6">
             <a:extLst>
               <a:ext uri="{FF2B5EF4-FFF2-40B4-BE49-F238E27FC236}">
-                <a16:creationId xmlns:a16="http://schemas.microsoft.com/office/drawing/2014/main" id="{AEDB853F-1CF1-E2AD-63A0-0B1444BDC516}"/>
+                <a16:creationId xmlns:a16="http://schemas.microsoft.com/office/drawing/2014/main" id="{A3FC8175-829C-1841-9631-1743BBA3D59E}"/>
               </a:ext>
             </a:extLst>
           </p:cNvPr>
@@ -1819,9 +1819,9 @@
           <a:bodyPr/>
           <a:lstStyle/>
           <a:p>
-            <a:fld id="{33959005-B26C-4F66-8525-6755711030AC}" type="datetimeFigureOut">
+            <a:fld id="{EE8B46EF-BC55-43A4-9BE9-7DF2F9C6E933}" type="datetimeFigureOut">
               <a:rPr lang="en-US" smtClean="0"/>
-              <a:t>8/19/2026</a:t>
+              <a:t>9/21/2026</a:t>
             </a:fld>
             <a:endParaRPr lang="en-US"/>
           </a:p>
@@ -1832,7 +1832,7 @@
           <p:cNvPr id="8" name="Footer Placeholder 7">
             <a:extLst>
               <a:ext uri="{FF2B5EF4-FFF2-40B4-BE49-F238E27FC236}">
-                <a16:creationId xmlns:a16="http://schemas.microsoft.com/office/drawing/2014/main" id="{6D4AAB27-EDC7-33C3-FC19-31DFB5CCD7D8}"/>
+                <a16:creationId xmlns:a16="http://schemas.microsoft.com/office/drawing/2014/main" id="{69A38BE6-D269-D587-FEE5-8A6A5B3D2697}"/>
               </a:ext>
             </a:extLst>
           </p:cNvPr>
@@ -1857,7 +1857,7 @@
           <p:cNvPr id="9" name="Slide Number Placeholder 8">
             <a:extLst>
               <a:ext uri="{FF2B5EF4-FFF2-40B4-BE49-F238E27FC236}">
-                <a16:creationId xmlns:a16="http://schemas.microsoft.com/office/drawing/2014/main" id="{2F2B6103-C9FD-175A-D947-4678A7AF21B1}"/>
+                <a16:creationId xmlns:a16="http://schemas.microsoft.com/office/drawing/2014/main" id="{B75E0887-BC78-5825-F445-B87A717B0ECD}"/>
               </a:ext>
             </a:extLst>
           </p:cNvPr>
@@ -1873,7 +1873,7 @@
           <a:bodyPr/>
           <a:lstStyle/>
           <a:p>
-            <a:fld id="{877D9784-4EBE-4E69-A4A0-9CB0C6271F0B}" type="slidenum">
+            <a:fld id="{596BC448-00DA-4911-8130-CC0B5B7DAEAC}" type="slidenum">
               <a:rPr lang="en-US" smtClean="0"/>
               <a:t>‹#›</a:t>
             </a:fld>
@@ -1884,7 +1884,7 @@
     </p:spTree>
     <p:extLst>
       <p:ext uri="{BB962C8B-B14F-4D97-AF65-F5344CB8AC3E}">
-        <p14:creationId xmlns:p14="http://schemas.microsoft.com/office/powerpoint/2010/main" val="1757074486"/>
+        <p14:creationId xmlns:p14="http://schemas.microsoft.com/office/powerpoint/2010/main" val="3149121756"/>
       </p:ext>
     </p:extLst>
   </p:cSld>
@@ -1916,7 +1916,7 @@
           <p:cNvPr id="2" name="Title 1">
             <a:extLst>
               <a:ext uri="{FF2B5EF4-FFF2-40B4-BE49-F238E27FC236}">
-                <a16:creationId xmlns:a16="http://schemas.microsoft.com/office/drawing/2014/main" id="{6D65A5CE-B1C3-95E3-BF31-F153FF8D3512}"/>
+                <a16:creationId xmlns:a16="http://schemas.microsoft.com/office/drawing/2014/main" id="{36DD47BB-FED4-0D6E-A094-FFBB697A02C7}"/>
               </a:ext>
             </a:extLst>
           </p:cNvPr>
@@ -1944,7 +1944,7 @@
           <p:cNvPr id="3" name="Date Placeholder 2">
             <a:extLst>
               <a:ext uri="{FF2B5EF4-FFF2-40B4-BE49-F238E27FC236}">
-                <a16:creationId xmlns:a16="http://schemas.microsoft.com/office/drawing/2014/main" id="{6986EEB4-6B1F-6DE7-0781-94CE7ED91413}"/>
+                <a16:creationId xmlns:a16="http://schemas.microsoft.com/office/drawing/2014/main" id="{0AD2E7E7-5379-C0A2-6C1D-44A33C1BB16C}"/>
               </a:ext>
             </a:extLst>
           </p:cNvPr>
@@ -1960,9 +1960,9 @@
           <a:bodyPr/>
           <a:lstStyle/>
           <a:p>
-            <a:fld id="{33959005-B26C-4F66-8525-6755711030AC}" type="datetimeFigureOut">
+            <a:fld id="{EE8B46EF-BC55-43A4-9BE9-7DF2F9C6E933}" type="datetimeFigureOut">
               <a:rPr lang="en-US" smtClean="0"/>
-              <a:t>8/19/2026</a:t>
+              <a:t>9/21/2026</a:t>
             </a:fld>
             <a:endParaRPr lang="en-US"/>
           </a:p>
@@ -1973,7 +1973,7 @@
           <p:cNvPr id="4" name="Footer Placeholder 3">
             <a:extLst>
               <a:ext uri="{FF2B5EF4-FFF2-40B4-BE49-F238E27FC236}">
-                <a16:creationId xmlns:a16="http://schemas.microsoft.com/office/drawing/2014/main" id="{7156AE62-1C8F-6C08-C423-62AFE21E7612}"/>
+                <a16:creationId xmlns:a16="http://schemas.microsoft.com/office/drawing/2014/main" id="{B889533D-346C-CD12-BC8D-1F07B15A87A0}"/>
               </a:ext>
             </a:extLst>
           </p:cNvPr>
@@ -1998,7 +1998,7 @@
           <p:cNvPr id="5" name="Slide Number Placeholder 4">
             <a:extLst>
               <a:ext uri="{FF2B5EF4-FFF2-40B4-BE49-F238E27FC236}">
-                <a16:creationId xmlns:a16="http://schemas.microsoft.com/office/drawing/2014/main" id="{1F214686-634C-0862-53C7-B59D902781AB}"/>
+                <a16:creationId xmlns:a16="http://schemas.microsoft.com/office/drawing/2014/main" id="{818B8C4B-CA10-AFDD-5254-28B58C29048F}"/>
               </a:ext>
             </a:extLst>
           </p:cNvPr>
@@ -2014,7 +2014,7 @@
           <a:bodyPr/>
           <a:lstStyle/>
           <a:p>
-            <a:fld id="{877D9784-4EBE-4E69-A4A0-9CB0C6271F0B}" type="slidenum">
+            <a:fld id="{596BC448-00DA-4911-8130-CC0B5B7DAEAC}" type="slidenum">
               <a:rPr lang="en-US" smtClean="0"/>
               <a:t>‹#›</a:t>
             </a:fld>
@@ -2025,7 +2025,7 @@
     </p:spTree>
     <p:extLst>
       <p:ext uri="{BB962C8B-B14F-4D97-AF65-F5344CB8AC3E}">
-        <p14:creationId xmlns:p14="http://schemas.microsoft.com/office/powerpoint/2010/main" val="1497765542"/>
+        <p14:creationId xmlns:p14="http://schemas.microsoft.com/office/powerpoint/2010/main" val="2316318184"/>
       </p:ext>
     </p:extLst>
   </p:cSld>
@@ -2057,7 +2057,7 @@
           <p:cNvPr id="2" name="Date Placeholder 1">
             <a:extLst>
               <a:ext uri="{FF2B5EF4-FFF2-40B4-BE49-F238E27FC236}">
-                <a16:creationId xmlns:a16="http://schemas.microsoft.com/office/drawing/2014/main" id="{90EFD5EA-3C25-19DA-1119-A7AA154DEA29}"/>
+                <a16:creationId xmlns:a16="http://schemas.microsoft.com/office/drawing/2014/main" id="{7C7C9F0D-1158-D5B3-B497-C96A6CE065C2}"/>
               </a:ext>
             </a:extLst>
           </p:cNvPr>
@@ -2073,9 +2073,9 @@
           <a:bodyPr/>
           <a:lstStyle/>
           <a:p>
-            <a:fld id="{33959005-B26C-4F66-8525-6755711030AC}" type="datetimeFigureOut">
+            <a:fld id="{EE8B46EF-BC55-43A4-9BE9-7DF2F9C6E933}" type="datetimeFigureOut">
               <a:rPr lang="en-US" smtClean="0"/>
-              <a:t>8/19/2026</a:t>
+              <a:t>9/21/2026</a:t>
             </a:fld>
             <a:endParaRPr lang="en-US"/>
           </a:p>
@@ -2086,7 +2086,7 @@
           <p:cNvPr id="3" name="Footer Placeholder 2">
             <a:extLst>
               <a:ext uri="{FF2B5EF4-FFF2-40B4-BE49-F238E27FC236}">
-                <a16:creationId xmlns:a16="http://schemas.microsoft.com/office/drawing/2014/main" id="{4DAB7DBE-BFE1-2DAF-1348-A568E7351341}"/>
+                <a16:creationId xmlns:a16="http://schemas.microsoft.com/office/drawing/2014/main" id="{2E6C1F34-096A-4310-51B3-7845A76C4ACA}"/>
               </a:ext>
             </a:extLst>
           </p:cNvPr>
@@ -2111,7 +2111,7 @@
           <p:cNvPr id="4" name="Slide Number Placeholder 3">
             <a:extLst>
               <a:ext uri="{FF2B5EF4-FFF2-40B4-BE49-F238E27FC236}">
-                <a16:creationId xmlns:a16="http://schemas.microsoft.com/office/drawing/2014/main" id="{A1E733B0-977D-9635-B6B8-920CE37A6227}"/>
+                <a16:creationId xmlns:a16="http://schemas.microsoft.com/office/drawing/2014/main" id="{780FE047-6282-7A30-E37F-2C6E2CF32595}"/>
               </a:ext>
             </a:extLst>
           </p:cNvPr>
@@ -2127,7 +2127,7 @@
           <a:bodyPr/>
           <a:lstStyle/>
           <a:p>
-            <a:fld id="{877D9784-4EBE-4E69-A4A0-9CB0C6271F0B}" type="slidenum">
+            <a:fld id="{596BC448-00DA-4911-8130-CC0B5B7DAEAC}" type="slidenum">
               <a:rPr lang="en-US" smtClean="0"/>
               <a:t>‹#›</a:t>
             </a:fld>
@@ -2138,7 +2138,7 @@
     </p:spTree>
     <p:extLst>
       <p:ext uri="{BB962C8B-B14F-4D97-AF65-F5344CB8AC3E}">
-        <p14:creationId xmlns:p14="http://schemas.microsoft.com/office/powerpoint/2010/main" val="907021651"/>
+        <p14:creationId xmlns:p14="http://schemas.microsoft.com/office/powerpoint/2010/main" val="3154760214"/>
       </p:ext>
     </p:extLst>
   </p:cSld>
@@ -2170,7 +2170,7 @@
           <p:cNvPr id="2" name="Title 1">
             <a:extLst>
               <a:ext uri="{FF2B5EF4-FFF2-40B4-BE49-F238E27FC236}">
-                <a16:creationId xmlns:a16="http://schemas.microsoft.com/office/drawing/2014/main" id="{EDA0D5F4-220C-3D15-B00A-B7606510F917}"/>
+                <a16:creationId xmlns:a16="http://schemas.microsoft.com/office/drawing/2014/main" id="{52D35B79-1E29-3D0C-5FBE-B0A09281EB8F}"/>
               </a:ext>
             </a:extLst>
           </p:cNvPr>
@@ -2207,7 +2207,7 @@
           <p:cNvPr id="3" name="Content Placeholder 2">
             <a:extLst>
               <a:ext uri="{FF2B5EF4-FFF2-40B4-BE49-F238E27FC236}">
-                <a16:creationId xmlns:a16="http://schemas.microsoft.com/office/drawing/2014/main" id="{B6D9363C-63C4-798F-163A-B9DB135205AD}"/>
+                <a16:creationId xmlns:a16="http://schemas.microsoft.com/office/drawing/2014/main" id="{1A9380A3-3E9F-2269-2118-E301B74E019E}"/>
               </a:ext>
             </a:extLst>
           </p:cNvPr>
@@ -2297,7 +2297,7 @@
           <p:cNvPr id="4" name="Text Placeholder 3">
             <a:extLst>
               <a:ext uri="{FF2B5EF4-FFF2-40B4-BE49-F238E27FC236}">
-                <a16:creationId xmlns:a16="http://schemas.microsoft.com/office/drawing/2014/main" id="{2FE54E12-D25A-C16D-CE00-4AECE589B8A8}"/>
+                <a16:creationId xmlns:a16="http://schemas.microsoft.com/office/drawing/2014/main" id="{0A8564DD-B108-AC3E-C63A-4379299CBE92}"/>
               </a:ext>
             </a:extLst>
           </p:cNvPr>
@@ -2368,7 +2368,7 @@
           <p:cNvPr id="5" name="Date Placeholder 4">
             <a:extLst>
               <a:ext uri="{FF2B5EF4-FFF2-40B4-BE49-F238E27FC236}">
-                <a16:creationId xmlns:a16="http://schemas.microsoft.com/office/drawing/2014/main" id="{F629EA75-A07F-260C-F3F3-5DE141A970B4}"/>
+                <a16:creationId xmlns:a16="http://schemas.microsoft.com/office/drawing/2014/main" id="{AC6706A9-507F-66D4-6C64-1D8BFE0F5EDE}"/>
               </a:ext>
             </a:extLst>
           </p:cNvPr>
@@ -2384,9 +2384,9 @@
           <a:bodyPr/>
           <a:lstStyle/>
           <a:p>
-            <a:fld id="{33959005-B26C-4F66-8525-6755711030AC}" type="datetimeFigureOut">
+            <a:fld id="{EE8B46EF-BC55-43A4-9BE9-7DF2F9C6E933}" type="datetimeFigureOut">
               <a:rPr lang="en-US" smtClean="0"/>
-              <a:t>8/19/2026</a:t>
+              <a:t>9/21/2026</a:t>
             </a:fld>
             <a:endParaRPr lang="en-US"/>
           </a:p>
@@ -2397,7 +2397,7 @@
           <p:cNvPr id="6" name="Footer Placeholder 5">
             <a:extLst>
               <a:ext uri="{FF2B5EF4-FFF2-40B4-BE49-F238E27FC236}">
-                <a16:creationId xmlns:a16="http://schemas.microsoft.com/office/drawing/2014/main" id="{5DF50589-B611-EFDD-4758-F56263A39511}"/>
+                <a16:creationId xmlns:a16="http://schemas.microsoft.com/office/drawing/2014/main" id="{79B993C8-1258-B378-3988-B394479CB8C3}"/>
               </a:ext>
             </a:extLst>
           </p:cNvPr>
@@ -2422,7 +2422,7 @@
           <p:cNvPr id="7" name="Slide Number Placeholder 6">
             <a:extLst>
               <a:ext uri="{FF2B5EF4-FFF2-40B4-BE49-F238E27FC236}">
-                <a16:creationId xmlns:a16="http://schemas.microsoft.com/office/drawing/2014/main" id="{C902412D-7F0B-329D-2CE6-DB261ED8CBEE}"/>
+                <a16:creationId xmlns:a16="http://schemas.microsoft.com/office/drawing/2014/main" id="{411140C5-AB3B-A2D4-CC2D-9F226C28C514}"/>
               </a:ext>
             </a:extLst>
           </p:cNvPr>
@@ -2438,7 +2438,7 @@
           <a:bodyPr/>
           <a:lstStyle/>
           <a:p>
-            <a:fld id="{877D9784-4EBE-4E69-A4A0-9CB0C6271F0B}" type="slidenum">
+            <a:fld id="{596BC448-00DA-4911-8130-CC0B5B7DAEAC}" type="slidenum">
               <a:rPr lang="en-US" smtClean="0"/>
               <a:t>‹#›</a:t>
             </a:fld>
@@ -2449,7 +2449,7 @@
     </p:spTree>
     <p:extLst>
       <p:ext uri="{BB962C8B-B14F-4D97-AF65-F5344CB8AC3E}">
-        <p14:creationId xmlns:p14="http://schemas.microsoft.com/office/powerpoint/2010/main" val="1218507352"/>
+        <p14:creationId xmlns:p14="http://schemas.microsoft.com/office/powerpoint/2010/main" val="3486216994"/>
       </p:ext>
     </p:extLst>
   </p:cSld>
@@ -2481,7 +2481,7 @@
           <p:cNvPr id="2" name="Title 1">
             <a:extLst>
               <a:ext uri="{FF2B5EF4-FFF2-40B4-BE49-F238E27FC236}">
-                <a16:creationId xmlns:a16="http://schemas.microsoft.com/office/drawing/2014/main" id="{58D641DF-C152-8C68-6E2F-FA4B67BFAA26}"/>
+                <a16:creationId xmlns:a16="http://schemas.microsoft.com/office/drawing/2014/main" id="{C80C9175-A235-E051-C70C-45BDE2A726B9}"/>
               </a:ext>
             </a:extLst>
           </p:cNvPr>
@@ -2518,7 +2518,7 @@
           <p:cNvPr id="3" name="Picture Placeholder 2">
             <a:extLst>
               <a:ext uri="{FF2B5EF4-FFF2-40B4-BE49-F238E27FC236}">
-                <a16:creationId xmlns:a16="http://schemas.microsoft.com/office/drawing/2014/main" id="{0A2AC9C6-D076-D535-66AE-1FDD64B1E058}"/>
+                <a16:creationId xmlns:a16="http://schemas.microsoft.com/office/drawing/2014/main" id="{4FA10015-6954-166B-A689-908D40C3E5B6}"/>
               </a:ext>
             </a:extLst>
           </p:cNvPr>
@@ -2585,7 +2585,7 @@
           <p:cNvPr id="4" name="Text Placeholder 3">
             <a:extLst>
               <a:ext uri="{FF2B5EF4-FFF2-40B4-BE49-F238E27FC236}">
-                <a16:creationId xmlns:a16="http://schemas.microsoft.com/office/drawing/2014/main" id="{EDEE2466-46A1-E322-6645-C56E08117565}"/>
+                <a16:creationId xmlns:a16="http://schemas.microsoft.com/office/drawing/2014/main" id="{C54113A6-9874-3B68-315C-A8D4AF453722}"/>
               </a:ext>
             </a:extLst>
           </p:cNvPr>
@@ -2656,7 +2656,7 @@
           <p:cNvPr id="5" name="Date Placeholder 4">
             <a:extLst>
               <a:ext uri="{FF2B5EF4-FFF2-40B4-BE49-F238E27FC236}">
-                <a16:creationId xmlns:a16="http://schemas.microsoft.com/office/drawing/2014/main" id="{C4185AFB-6CFB-E466-E88E-9A4593BE6A47}"/>
+                <a16:creationId xmlns:a16="http://schemas.microsoft.com/office/drawing/2014/main" id="{0CF6E98D-2730-7999-8C7C-6CC5027B8675}"/>
               </a:ext>
             </a:extLst>
           </p:cNvPr>
@@ -2672,9 +2672,9 @@
           <a:bodyPr/>
           <a:lstStyle/>
           <a:p>
-            <a:fld id="{33959005-B26C-4F66-8525-6755711030AC}" type="datetimeFigureOut">
+            <a:fld id="{EE8B46EF-BC55-43A4-9BE9-7DF2F9C6E933}" type="datetimeFigureOut">
               <a:rPr lang="en-US" smtClean="0"/>
-              <a:t>8/19/2026</a:t>
+              <a:t>9/21/2026</a:t>
             </a:fld>
             <a:endParaRPr lang="en-US"/>
           </a:p>
@@ -2685,7 +2685,7 @@
           <p:cNvPr id="6" name="Footer Placeholder 5">
             <a:extLst>
               <a:ext uri="{FF2B5EF4-FFF2-40B4-BE49-F238E27FC236}">
-                <a16:creationId xmlns:a16="http://schemas.microsoft.com/office/drawing/2014/main" id="{275A24A1-C7CB-0012-CF6C-75F14E9A6CCF}"/>
+                <a16:creationId xmlns:a16="http://schemas.microsoft.com/office/drawing/2014/main" id="{7E4A11BB-273F-BB74-724F-C0B6526B8521}"/>
               </a:ext>
             </a:extLst>
           </p:cNvPr>
@@ -2710,7 +2710,7 @@
           <p:cNvPr id="7" name="Slide Number Placeholder 6">
             <a:extLst>
               <a:ext uri="{FF2B5EF4-FFF2-40B4-BE49-F238E27FC236}">
-                <a16:creationId xmlns:a16="http://schemas.microsoft.com/office/drawing/2014/main" id="{BDF62B7F-7E0A-3F1D-A3AC-DB16B41BBEB1}"/>
+                <a16:creationId xmlns:a16="http://schemas.microsoft.com/office/drawing/2014/main" id="{635D30E4-FEDB-8FEC-E812-EC7507021630}"/>
               </a:ext>
             </a:extLst>
           </p:cNvPr>
@@ -2726,7 +2726,7 @@
           <a:bodyPr/>
           <a:lstStyle/>
           <a:p>
-            <a:fld id="{877D9784-4EBE-4E69-A4A0-9CB0C6271F0B}" type="slidenum">
+            <a:fld id="{596BC448-00DA-4911-8130-CC0B5B7DAEAC}" type="slidenum">
               <a:rPr lang="en-US" smtClean="0"/>
               <a:t>‹#›</a:t>
             </a:fld>
@@ -2737,7 +2737,7 @@
     </p:spTree>
     <p:extLst>
       <p:ext uri="{BB962C8B-B14F-4D97-AF65-F5344CB8AC3E}">
-        <p14:creationId xmlns:p14="http://schemas.microsoft.com/office/powerpoint/2010/main" val="587403155"/>
+        <p14:creationId xmlns:p14="http://schemas.microsoft.com/office/powerpoint/2010/main" val="3914864888"/>
       </p:ext>
     </p:extLst>
   </p:cSld>
@@ -2774,7 +2774,7 @@
           <p:cNvPr id="2" name="Title Placeholder 1">
             <a:extLst>
               <a:ext uri="{FF2B5EF4-FFF2-40B4-BE49-F238E27FC236}">
-                <a16:creationId xmlns:a16="http://schemas.microsoft.com/office/drawing/2014/main" id="{3D54AC99-60FE-7AF2-35FD-60A48F26F17E}"/>
+                <a16:creationId xmlns:a16="http://schemas.microsoft.com/office/drawing/2014/main" id="{84DB7412-1AD8-C51D-70C0-3D4D2D9D2D78}"/>
               </a:ext>
             </a:extLst>
           </p:cNvPr>
@@ -2812,7 +2812,7 @@
           <p:cNvPr id="3" name="Text Placeholder 2">
             <a:extLst>
               <a:ext uri="{FF2B5EF4-FFF2-40B4-BE49-F238E27FC236}">
-                <a16:creationId xmlns:a16="http://schemas.microsoft.com/office/drawing/2014/main" id="{8CB17BF9-D898-CEBB-C21A-C8679A19D197}"/>
+                <a16:creationId xmlns:a16="http://schemas.microsoft.com/office/drawing/2014/main" id="{4547801C-A4A7-5AEE-CFD1-D05A0C7E23D7}"/>
               </a:ext>
             </a:extLst>
           </p:cNvPr>
@@ -2879,7 +2879,7 @@
           <p:cNvPr id="4" name="Date Placeholder 3">
             <a:extLst>
               <a:ext uri="{FF2B5EF4-FFF2-40B4-BE49-F238E27FC236}">
-                <a16:creationId xmlns:a16="http://schemas.microsoft.com/office/drawing/2014/main" id="{00C23057-7E20-2E12-8A27-0B6CC325F7B4}"/>
+                <a16:creationId xmlns:a16="http://schemas.microsoft.com/office/drawing/2014/main" id="{0A9539C0-996C-EDCF-157F-222A77D57B37}"/>
               </a:ext>
             </a:extLst>
           </p:cNvPr>
@@ -2913,9 +2913,9 @@
             </a:lvl1pPr>
           </a:lstStyle>
           <a:p>
-            <a:fld id="{33959005-B26C-4F66-8525-6755711030AC}" type="datetimeFigureOut">
+            <a:fld id="{EE8B46EF-BC55-43A4-9BE9-7DF2F9C6E933}" type="datetimeFigureOut">
               <a:rPr lang="en-US" smtClean="0"/>
-              <a:t>8/19/2026</a:t>
+              <a:t>9/21/2026</a:t>
             </a:fld>
             <a:endParaRPr lang="en-US"/>
           </a:p>
@@ -2926,7 +2926,7 @@
           <p:cNvPr id="5" name="Footer Placeholder 4">
             <a:extLst>
               <a:ext uri="{FF2B5EF4-FFF2-40B4-BE49-F238E27FC236}">
-                <a16:creationId xmlns:a16="http://schemas.microsoft.com/office/drawing/2014/main" id="{0C3705AB-F51E-0AFF-8597-7E999D943734}"/>
+                <a16:creationId xmlns:a16="http://schemas.microsoft.com/office/drawing/2014/main" id="{D1CD4972-6FDD-9D34-3279-DB3A7BF6AE2E}"/>
               </a:ext>
             </a:extLst>
           </p:cNvPr>
@@ -2969,7 +2969,7 @@
           <p:cNvPr id="6" name="Slide Number Placeholder 5">
             <a:extLst>
               <a:ext uri="{FF2B5EF4-FFF2-40B4-BE49-F238E27FC236}">
-                <a16:creationId xmlns:a16="http://schemas.microsoft.com/office/drawing/2014/main" id="{E635B3F8-02F2-1E26-D326-5CDC2E5C7521}"/>
+                <a16:creationId xmlns:a16="http://schemas.microsoft.com/office/drawing/2014/main" id="{F2D9A100-55CA-089E-B4F2-7479BFE146A8}"/>
               </a:ext>
             </a:extLst>
           </p:cNvPr>
@@ -3003,7 +3003,7 @@
             </a:lvl1pPr>
           </a:lstStyle>
           <a:p>
-            <a:fld id="{877D9784-4EBE-4E69-A4A0-9CB0C6271F0B}" type="slidenum">
+            <a:fld id="{596BC448-00DA-4911-8130-CC0B5B7DAEAC}" type="slidenum">
               <a:rPr lang="en-US" smtClean="0"/>
               <a:t>‹#›</a:t>
             </a:fld>
@@ -3014,7 +3014,7 @@
     </p:spTree>
     <p:extLst>
       <p:ext uri="{BB962C8B-B14F-4D97-AF65-F5344CB8AC3E}">
-        <p14:creationId xmlns:p14="http://schemas.microsoft.com/office/powerpoint/2010/main" val="3603390750"/>
+        <p14:creationId xmlns:p14="http://schemas.microsoft.com/office/powerpoint/2010/main" val="3357160850"/>
       </p:ext>
     </p:extLst>
   </p:cSld>
@@ -3337,7 +3337,7 @@
           <p:cNvPr id="2" name="Rectangle 1">
             <a:extLst>
               <a:ext uri="{FF2B5EF4-FFF2-40B4-BE49-F238E27FC236}">
-                <a16:creationId xmlns:a16="http://schemas.microsoft.com/office/drawing/2014/main" id="{E2E3C812-D6A6-3AA1-909A-B5A470909209}"/>
+                <a16:creationId xmlns:a16="http://schemas.microsoft.com/office/drawing/2014/main" id="{E1618377-D676-2C2C-5557-0C424B73EDA9}"/>
               </a:ext>
             </a:extLst>
           </p:cNvPr>
@@ -3397,7 +3397,7 @@
           <p:cNvPr id="3" name="Oval 2">
             <a:extLst>
               <a:ext uri="{FF2B5EF4-FFF2-40B4-BE49-F238E27FC236}">
-                <a16:creationId xmlns:a16="http://schemas.microsoft.com/office/drawing/2014/main" id="{9029C471-5EEF-3182-F32E-78AD50910323}"/>
+                <a16:creationId xmlns:a16="http://schemas.microsoft.com/office/drawing/2014/main" id="{BBD5E582-76FA-BFC1-4075-64C3252B8742}"/>
               </a:ext>
             </a:extLst>
           </p:cNvPr>
@@ -3458,7 +3458,7 @@
           <p:cNvPr id="4" name="Oval 3">
             <a:extLst>
               <a:ext uri="{FF2B5EF4-FFF2-40B4-BE49-F238E27FC236}">
-                <a16:creationId xmlns:a16="http://schemas.microsoft.com/office/drawing/2014/main" id="{45AE7200-7385-1B3D-1E76-E235A2F58726}"/>
+                <a16:creationId xmlns:a16="http://schemas.microsoft.com/office/drawing/2014/main" id="{BA6417F8-EA2C-B7CC-8FAB-2688021B8C39}"/>
               </a:ext>
             </a:extLst>
           </p:cNvPr>
@@ -3519,7 +3519,7 @@
           <p:cNvPr id="5" name="Oval 4">
             <a:extLst>
               <a:ext uri="{FF2B5EF4-FFF2-40B4-BE49-F238E27FC236}">
-                <a16:creationId xmlns:a16="http://schemas.microsoft.com/office/drawing/2014/main" id="{A71802D7-17D6-476C-416E-136E1007A378}"/>
+                <a16:creationId xmlns:a16="http://schemas.microsoft.com/office/drawing/2014/main" id="{FE2D1CA5-C114-FF3A-71E2-DEEF46053B32}"/>
               </a:ext>
             </a:extLst>
           </p:cNvPr>
@@ -3580,7 +3580,7 @@
           <p:cNvPr id="6" name="TextBox 5">
             <a:extLst>
               <a:ext uri="{FF2B5EF4-FFF2-40B4-BE49-F238E27FC236}">
-                <a16:creationId xmlns:a16="http://schemas.microsoft.com/office/drawing/2014/main" id="{E937B9A5-8339-0E75-22ED-11613E30E3F0}"/>
+                <a16:creationId xmlns:a16="http://schemas.microsoft.com/office/drawing/2014/main" id="{A81AB5C8-7A62-EB11-545F-80C7280527EF}"/>
               </a:ext>
             </a:extLst>
           </p:cNvPr>
@@ -3620,7 +3620,7 @@
           <p:cNvPr id="7" name="TextBox 6">
             <a:extLst>
               <a:ext uri="{FF2B5EF4-FFF2-40B4-BE49-F238E27FC236}">
-                <a16:creationId xmlns:a16="http://schemas.microsoft.com/office/drawing/2014/main" id="{D411D57D-8F42-CC06-5D5E-E9B064DD0EDE}"/>
+                <a16:creationId xmlns:a16="http://schemas.microsoft.com/office/drawing/2014/main" id="{5D70D817-CA27-71E8-63A2-7DA33FE09999}"/>
               </a:ext>
             </a:extLst>
           </p:cNvPr>
@@ -3660,7 +3660,7 @@
           <p:cNvPr id="8" name="TextBox 7">
             <a:extLst>
               <a:ext uri="{FF2B5EF4-FFF2-40B4-BE49-F238E27FC236}">
-                <a16:creationId xmlns:a16="http://schemas.microsoft.com/office/drawing/2014/main" id="{58742AB4-6D60-67B8-2245-8B6EDC38B843}"/>
+                <a16:creationId xmlns:a16="http://schemas.microsoft.com/office/drawing/2014/main" id="{14150993-B8ED-ABEF-9644-69E893027A50}"/>
               </a:ext>
             </a:extLst>
           </p:cNvPr>
@@ -3700,7 +3700,7 @@
           <p:cNvPr id="9" name="Rectangle: Rounded Corners 8">
             <a:extLst>
               <a:ext uri="{FF2B5EF4-FFF2-40B4-BE49-F238E27FC236}">
-                <a16:creationId xmlns:a16="http://schemas.microsoft.com/office/drawing/2014/main" id="{D98FBA8C-DC5C-02B1-2835-3B410514745C}"/>
+                <a16:creationId xmlns:a16="http://schemas.microsoft.com/office/drawing/2014/main" id="{CEF85F27-0B4C-DF29-93FB-A474611B8075}"/>
               </a:ext>
             </a:extLst>
           </p:cNvPr>
@@ -3760,7 +3760,7 @@
           <p:cNvPr id="10" name="TextBox 9">
             <a:extLst>
               <a:ext uri="{FF2B5EF4-FFF2-40B4-BE49-F238E27FC236}">
-                <a16:creationId xmlns:a16="http://schemas.microsoft.com/office/drawing/2014/main" id="{7D4C61AD-441B-9CA1-47B4-CDD50F7281EC}"/>
+                <a16:creationId xmlns:a16="http://schemas.microsoft.com/office/drawing/2014/main" id="{A8C5CA90-8F23-643A-EE92-D4677F37C2A5}"/>
               </a:ext>
             </a:extLst>
           </p:cNvPr>
@@ -3790,7 +3790,7 @@
                 </a:solidFill>
                 <a:latin typeface="Aptos" panose="020B0004020202020204" pitchFamily="34" charset="0"/>
               </a:rPr>
-              <a:t>Leadership discussion draft | 19 Aug 2026</a:t>
+              <a:t>Leadership discussion draft | 21 Sep 2026</a:t>
             </a:r>
           </a:p>
         </p:txBody>
@@ -3800,7 +3800,7 @@
           <p:cNvPr id="11" name="TextBox 10">
             <a:extLst>
               <a:ext uri="{FF2B5EF4-FFF2-40B4-BE49-F238E27FC236}">
-                <a16:creationId xmlns:a16="http://schemas.microsoft.com/office/drawing/2014/main" id="{83C6AFB2-B764-AB8C-9FB1-115144A47DD1}"/>
+                <a16:creationId xmlns:a16="http://schemas.microsoft.com/office/drawing/2014/main" id="{678D489B-C75C-B572-13BE-D124728AB0F4}"/>
               </a:ext>
             </a:extLst>
           </p:cNvPr>
@@ -3838,7 +3838,7 @@
     </p:spTree>
     <p:extLst>
       <p:ext uri="{BB962C8B-B14F-4D97-AF65-F5344CB8AC3E}">
-        <p14:creationId xmlns:p14="http://schemas.microsoft.com/office/powerpoint/2010/main" val="3587928578"/>
+        <p14:creationId xmlns:p14="http://schemas.microsoft.com/office/powerpoint/2010/main" val="3221785765"/>
       </p:ext>
     </p:extLst>
   </p:cSld>
@@ -3870,7 +3870,7 @@
           <p:cNvPr id="2" name="TextBox 1">
             <a:extLst>
               <a:ext uri="{FF2B5EF4-FFF2-40B4-BE49-F238E27FC236}">
-                <a16:creationId xmlns:a16="http://schemas.microsoft.com/office/drawing/2014/main" id="{87D81B0D-41F8-59CF-A243-E3BCC0953B94}"/>
+                <a16:creationId xmlns:a16="http://schemas.microsoft.com/office/drawing/2014/main" id="{B4E2DF23-7601-8FA1-8324-CD584644F90D}"/>
               </a:ext>
             </a:extLst>
           </p:cNvPr>
@@ -3900,7 +3900,7 @@
                 </a:solidFill>
                 <a:latin typeface="Aptos" panose="020B0004020202020204" pitchFamily="34" charset="0"/>
               </a:rPr>
-              <a:t>PROOF TO PILOT</a:t>
+              <a:t>CURRENT GATE STATUS</a:t>
             </a:r>
           </a:p>
         </p:txBody>
@@ -3910,7 +3910,7 @@
           <p:cNvPr id="3" name="TextBox 2">
             <a:extLst>
               <a:ext uri="{FF2B5EF4-FFF2-40B4-BE49-F238E27FC236}">
-                <a16:creationId xmlns:a16="http://schemas.microsoft.com/office/drawing/2014/main" id="{101901F8-4054-748A-CF85-412C09111514}"/>
+                <a16:creationId xmlns:a16="http://schemas.microsoft.com/office/drawing/2014/main" id="{A4996C9C-84ED-0303-903E-F53C152BE530}"/>
               </a:ext>
             </a:extLst>
           </p:cNvPr>
@@ -3940,7 +3940,7 @@
                 </a:solidFill>
                 <a:latin typeface="Aptos Display" panose="020B0004020202020204" pitchFamily="34" charset="0"/>
               </a:rPr>
-              <a:t>The foundation is real; the application proof is next</a:t>
+              <a:t>One enterprise gate passed; measured value remains the blocker</a:t>
             </a:r>
           </a:p>
         </p:txBody>
@@ -3950,7 +3950,7 @@
           <p:cNvPr id="4" name="Rectangle: Rounded Corners 3">
             <a:extLst>
               <a:ext uri="{FF2B5EF4-FFF2-40B4-BE49-F238E27FC236}">
-                <a16:creationId xmlns:a16="http://schemas.microsoft.com/office/drawing/2014/main" id="{BAE77EE4-EC39-2974-5A32-C2E6CFACCC81}"/>
+                <a16:creationId xmlns:a16="http://schemas.microsoft.com/office/drawing/2014/main" id="{253748DB-E1AD-0F5D-4A06-122BEEAE691F}"/>
               </a:ext>
             </a:extLst>
           </p:cNvPr>
@@ -4008,7 +4008,7 @@
           <p:cNvPr id="5" name="Oval 4">
             <a:extLst>
               <a:ext uri="{FF2B5EF4-FFF2-40B4-BE49-F238E27FC236}">
-                <a16:creationId xmlns:a16="http://schemas.microsoft.com/office/drawing/2014/main" id="{BE3CE910-B5C3-6F88-F836-38BACB262FA6}"/>
+                <a16:creationId xmlns:a16="http://schemas.microsoft.com/office/drawing/2014/main" id="{69B3CF56-F68C-C1EF-6355-63D34E17502A}"/>
               </a:ext>
             </a:extLst>
           </p:cNvPr>
@@ -4069,7 +4069,7 @@
           <p:cNvPr id="6" name="TextBox 5">
             <a:extLst>
               <a:ext uri="{FF2B5EF4-FFF2-40B4-BE49-F238E27FC236}">
-                <a16:creationId xmlns:a16="http://schemas.microsoft.com/office/drawing/2014/main" id="{A9E90675-9AF3-DE7E-DC3C-F2AF8D9208BF}"/>
+                <a16:creationId xmlns:a16="http://schemas.microsoft.com/office/drawing/2014/main" id="{3E6D2D2A-547D-45B0-989A-86FC7B73DD7F}"/>
               </a:ext>
             </a:extLst>
           </p:cNvPr>
@@ -4110,7 +4110,7 @@
           <p:cNvPr id="7" name="TextBox 6">
             <a:extLst>
               <a:ext uri="{FF2B5EF4-FFF2-40B4-BE49-F238E27FC236}">
-                <a16:creationId xmlns:a16="http://schemas.microsoft.com/office/drawing/2014/main" id="{CAA9FDC5-A468-6303-84F9-5DCFF78038C1}"/>
+                <a16:creationId xmlns:a16="http://schemas.microsoft.com/office/drawing/2014/main" id="{5C4843F9-1C6A-8F81-C825-42079786D0F8}"/>
               </a:ext>
             </a:extLst>
           </p:cNvPr>
@@ -4140,7 +4140,7 @@
                 </a:solidFill>
                 <a:latin typeface="Aptos" panose="020B0004020202020204" pitchFamily="34" charset="0"/>
               </a:rPr>
-              <a:t>PROVEN</a:t>
+              <a:t>PASSED</a:t>
             </a:r>
           </a:p>
         </p:txBody>
@@ -4150,7 +4150,7 @@
           <p:cNvPr id="8" name="TextBox 7">
             <a:extLst>
               <a:ext uri="{FF2B5EF4-FFF2-40B4-BE49-F238E27FC236}">
-                <a16:creationId xmlns:a16="http://schemas.microsoft.com/office/drawing/2014/main" id="{2A63BE8F-AA97-6BE5-2B92-85675EB29CB8}"/>
+                <a16:creationId xmlns:a16="http://schemas.microsoft.com/office/drawing/2014/main" id="{6FB5CEF3-208C-B30E-7AA4-58E158BFDB84}"/>
               </a:ext>
             </a:extLst>
           </p:cNvPr>
@@ -4180,7 +4180,7 @@
                 </a:solidFill>
                 <a:latin typeface="Aptos" panose="020B0004020202020204" pitchFamily="34" charset="0"/>
               </a:rPr>
-              <a:t>Cargo-native discovery</a:t>
+              <a:t>Gate 1: onboarding + removal</a:t>
             </a:r>
           </a:p>
         </p:txBody>
@@ -4190,7 +4190,7 @@
           <p:cNvPr id="9" name="Rectangle: Rounded Corners 8">
             <a:extLst>
               <a:ext uri="{FF2B5EF4-FFF2-40B4-BE49-F238E27FC236}">
-                <a16:creationId xmlns:a16="http://schemas.microsoft.com/office/drawing/2014/main" id="{DBEA666A-3A78-7025-0BA6-741EF99E9652}"/>
+                <a16:creationId xmlns:a16="http://schemas.microsoft.com/office/drawing/2014/main" id="{528200E5-CB28-C188-86E7-18116FDE28B9}"/>
               </a:ext>
             </a:extLst>
           </p:cNvPr>
@@ -4248,7 +4248,7 @@
           <p:cNvPr id="10" name="Oval 9">
             <a:extLst>
               <a:ext uri="{FF2B5EF4-FFF2-40B4-BE49-F238E27FC236}">
-                <a16:creationId xmlns:a16="http://schemas.microsoft.com/office/drawing/2014/main" id="{62E140C1-E629-4DD9-31B8-839AB249C7E6}"/>
+                <a16:creationId xmlns:a16="http://schemas.microsoft.com/office/drawing/2014/main" id="{D94E8FE5-1C8C-2E2B-BE08-2DED049F6830}"/>
               </a:ext>
             </a:extLst>
           </p:cNvPr>
@@ -4309,7 +4309,7 @@
           <p:cNvPr id="11" name="TextBox 10">
             <a:extLst>
               <a:ext uri="{FF2B5EF4-FFF2-40B4-BE49-F238E27FC236}">
-                <a16:creationId xmlns:a16="http://schemas.microsoft.com/office/drawing/2014/main" id="{984BA787-FA93-7075-68F9-D2F28A74C814}"/>
+                <a16:creationId xmlns:a16="http://schemas.microsoft.com/office/drawing/2014/main" id="{3E72D408-B236-E1DF-ACB2-618D553C5B8C}"/>
               </a:ext>
             </a:extLst>
           </p:cNvPr>
@@ -4350,7 +4350,7 @@
           <p:cNvPr id="12" name="TextBox 11">
             <a:extLst>
               <a:ext uri="{FF2B5EF4-FFF2-40B4-BE49-F238E27FC236}">
-                <a16:creationId xmlns:a16="http://schemas.microsoft.com/office/drawing/2014/main" id="{D6594ED0-3A63-BC11-FA0D-A931E382832E}"/>
+                <a16:creationId xmlns:a16="http://schemas.microsoft.com/office/drawing/2014/main" id="{B2AA4E08-805E-0676-FCDC-F2B745CBB01C}"/>
               </a:ext>
             </a:extLst>
           </p:cNvPr>
@@ -4380,7 +4380,7 @@
                 </a:solidFill>
                 <a:latin typeface="Aptos" panose="020B0004020202020204" pitchFamily="34" charset="0"/>
               </a:rPr>
-              <a:t>PROVEN</a:t>
+              <a:t>PROOF</a:t>
             </a:r>
           </a:p>
         </p:txBody>
@@ -4390,7 +4390,7 @@
           <p:cNvPr id="13" name="TextBox 12">
             <a:extLst>
               <a:ext uri="{FF2B5EF4-FFF2-40B4-BE49-F238E27FC236}">
-                <a16:creationId xmlns:a16="http://schemas.microsoft.com/office/drawing/2014/main" id="{00D03F02-1263-E69A-894C-CC144B225AB6}"/>
+                <a16:creationId xmlns:a16="http://schemas.microsoft.com/office/drawing/2014/main" id="{39EADB20-B29D-3CC0-977D-85ECFBFEFD14}"/>
               </a:ext>
             </a:extLst>
           </p:cNvPr>
@@ -4420,7 +4420,7 @@
                 </a:solidFill>
                 <a:latin typeface="Aptos" panose="020B0004020202020204" pitchFamily="34" charset="0"/>
               </a:rPr>
-              <a:t>Conservative validation scope</a:t>
+              <a:t>Windows/Linux owner execution</a:t>
             </a:r>
           </a:p>
         </p:txBody>
@@ -4430,7 +4430,7 @@
           <p:cNvPr id="14" name="Rectangle: Rounded Corners 13">
             <a:extLst>
               <a:ext uri="{FF2B5EF4-FFF2-40B4-BE49-F238E27FC236}">
-                <a16:creationId xmlns:a16="http://schemas.microsoft.com/office/drawing/2014/main" id="{8C1FAC30-C0A3-507F-4F3E-19D3A6961CDF}"/>
+                <a16:creationId xmlns:a16="http://schemas.microsoft.com/office/drawing/2014/main" id="{F25D6500-60F0-7444-6B8F-AB9F56E77201}"/>
               </a:ext>
             </a:extLst>
           </p:cNvPr>
@@ -4488,7 +4488,7 @@
           <p:cNvPr id="15" name="Oval 14">
             <a:extLst>
               <a:ext uri="{FF2B5EF4-FFF2-40B4-BE49-F238E27FC236}">
-                <a16:creationId xmlns:a16="http://schemas.microsoft.com/office/drawing/2014/main" id="{412A569A-3001-21A6-0F1D-86104C65D3F2}"/>
+                <a16:creationId xmlns:a16="http://schemas.microsoft.com/office/drawing/2014/main" id="{ACE14314-A3B9-39C3-67C8-30C1F9236FBD}"/>
               </a:ext>
             </a:extLst>
           </p:cNvPr>
@@ -4549,7 +4549,7 @@
           <p:cNvPr id="16" name="TextBox 15">
             <a:extLst>
               <a:ext uri="{FF2B5EF4-FFF2-40B4-BE49-F238E27FC236}">
-                <a16:creationId xmlns:a16="http://schemas.microsoft.com/office/drawing/2014/main" id="{D602774E-F0F7-0C3F-DB2C-79070E6E7046}"/>
+                <a16:creationId xmlns:a16="http://schemas.microsoft.com/office/drawing/2014/main" id="{308865CB-C123-640F-04EE-05E719461570}"/>
               </a:ext>
             </a:extLst>
           </p:cNvPr>
@@ -4590,7 +4590,7 @@
           <p:cNvPr id="17" name="TextBox 16">
             <a:extLst>
               <a:ext uri="{FF2B5EF4-FFF2-40B4-BE49-F238E27FC236}">
-                <a16:creationId xmlns:a16="http://schemas.microsoft.com/office/drawing/2014/main" id="{88FA58F1-B300-E03D-BA43-6A3B5FAE8924}"/>
+                <a16:creationId xmlns:a16="http://schemas.microsoft.com/office/drawing/2014/main" id="{DF57D32E-DADD-245F-B9F9-6E68E7EE065B}"/>
               </a:ext>
             </a:extLst>
           </p:cNvPr>
@@ -4620,7 +4620,7 @@
                 </a:solidFill>
                 <a:latin typeface="Aptos" panose="020B0004020202020204" pitchFamily="34" charset="0"/>
               </a:rPr>
-              <a:t>PROVEN</a:t>
+              <a:t>PROOF</a:t>
             </a:r>
           </a:p>
         </p:txBody>
@@ -4630,7 +4630,7 @@
           <p:cNvPr id="18" name="TextBox 17">
             <a:extLst>
               <a:ext uri="{FF2B5EF4-FFF2-40B4-BE49-F238E27FC236}">
-                <a16:creationId xmlns:a16="http://schemas.microsoft.com/office/drawing/2014/main" id="{3A4B6A4F-6F20-515D-0D57-11C4439B21BF}"/>
+                <a16:creationId xmlns:a16="http://schemas.microsoft.com/office/drawing/2014/main" id="{77476826-9251-25A3-50D6-09CB2C8F73F8}"/>
               </a:ext>
             </a:extLst>
           </p:cNvPr>
@@ -4660,7 +4660,7 @@
                 </a:solidFill>
                 <a:latin typeface="Aptos" panose="020B0004020202020204" pitchFamily="34" charset="0"/>
               </a:rPr>
-              <a:t>2-16 workspace federation</a:t>
+              <a:t>Receipts + clean post-removal runs</a:t>
             </a:r>
           </a:p>
         </p:txBody>
@@ -4670,7 +4670,7 @@
           <p:cNvPr id="19" name="Rectangle: Rounded Corners 18">
             <a:extLst>
               <a:ext uri="{FF2B5EF4-FFF2-40B4-BE49-F238E27FC236}">
-                <a16:creationId xmlns:a16="http://schemas.microsoft.com/office/drawing/2014/main" id="{E18A7B4C-0C79-DC77-6FD2-A3FBFE3B038A}"/>
+                <a16:creationId xmlns:a16="http://schemas.microsoft.com/office/drawing/2014/main" id="{6C58D97C-3CE1-8B6D-A9C4-B3B71616C13D}"/>
               </a:ext>
             </a:extLst>
           </p:cNvPr>
@@ -4728,7 +4728,7 @@
           <p:cNvPr id="20" name="Oval 19">
             <a:extLst>
               <a:ext uri="{FF2B5EF4-FFF2-40B4-BE49-F238E27FC236}">
-                <a16:creationId xmlns:a16="http://schemas.microsoft.com/office/drawing/2014/main" id="{0405EF9B-A749-243C-FFB7-122B30726914}"/>
+                <a16:creationId xmlns:a16="http://schemas.microsoft.com/office/drawing/2014/main" id="{28F1F34B-6FCD-ED11-1631-7F8DC0541705}"/>
               </a:ext>
             </a:extLst>
           </p:cNvPr>
@@ -4738,246 +4738,6 @@
         <p:spPr>
           <a:xfrm>
             <a:off x="863600" y="2959100"/>
-            <a:ext cx="431800" cy="431800"/>
-          </a:xfrm>
-          <a:prstGeom prst="ellipse">
-            <a:avLst/>
-          </a:prstGeom>
-          <a:solidFill>
-            <a:srgbClr val="52B8C8"/>
-          </a:solidFill>
-          <a:ln w="19050" cap="flat" cmpd="sng" algn="ctr">
-            <a:solidFill>
-              <a:schemeClr val="accent1">
-                <a:shade val="15000"/>
-                <a:alpha val="0"/>
-              </a:schemeClr>
-            </a:solidFill>
-            <a:prstDash val="solid"/>
-            <a:miter lim="800000"/>
-            <a:headEnd type="none" w="med" len="med"/>
-            <a:tailEnd type="none" w="med" len="med"/>
-          </a:ln>
-        </p:spPr>
-        <p:style>
-          <a:lnRef idx="2">
-            <a:schemeClr val="accent1">
-              <a:shade val="15000"/>
-            </a:schemeClr>
-          </a:lnRef>
-          <a:fillRef idx="1">
-            <a:schemeClr val="accent1"/>
-          </a:fillRef>
-          <a:effectRef idx="0">
-            <a:schemeClr val="accent1"/>
-          </a:effectRef>
-          <a:fontRef idx="minor">
-            <a:schemeClr val="lt1"/>
-          </a:fontRef>
-        </p:style>
-        <p:txBody>
-          <a:bodyPr rtlCol="0" anchor="ctr"/>
-          <a:lstStyle/>
-          <a:p>
-            <a:pPr algn="ctr"/>
-            <a:endParaRPr lang="en-US"/>
-          </a:p>
-        </p:txBody>
-      </p:sp>
-      <p:sp>
-        <p:nvSpPr>
-          <p:cNvPr id="21" name="TextBox 20">
-            <a:extLst>
-              <a:ext uri="{FF2B5EF4-FFF2-40B4-BE49-F238E27FC236}">
-                <a16:creationId xmlns:a16="http://schemas.microsoft.com/office/drawing/2014/main" id="{3B50F7E5-18B9-0CF9-4EF4-E3E6321B96D2}"/>
-              </a:ext>
-            </a:extLst>
-          </p:cNvPr>
-          <p:cNvSpPr txBox="1"/>
-          <p:nvPr/>
-        </p:nvSpPr>
-        <p:spPr>
-          <a:xfrm>
-            <a:off x="914400" y="3048000"/>
-            <a:ext cx="330200" cy="276999"/>
-          </a:xfrm>
-          <a:prstGeom prst="rect">
-            <a:avLst/>
-          </a:prstGeom>
-          <a:noFill/>
-        </p:spPr>
-        <p:txBody>
-          <a:bodyPr vert="horz" wrap="square" lIns="0" tIns="0" rIns="0" bIns="0" rtlCol="0">
-            <a:noAutofit/>
-          </a:bodyPr>
-          <a:lstStyle/>
-          <a:p>
-            <a:pPr algn="ctr"/>
-            <a:r>
-              <a:rPr lang="en-US" sz="800" b="1">
-                <a:solidFill>
-                  <a:srgbClr val="10212D"/>
-                </a:solidFill>
-                <a:latin typeface="Aptos Display" panose="020B0004020202020204" pitchFamily="34" charset="0"/>
-              </a:rPr>
-              <a:t>OK</a:t>
-            </a:r>
-          </a:p>
-        </p:txBody>
-      </p:sp>
-      <p:sp>
-        <p:nvSpPr>
-          <p:cNvPr id="22" name="TextBox 21">
-            <a:extLst>
-              <a:ext uri="{FF2B5EF4-FFF2-40B4-BE49-F238E27FC236}">
-                <a16:creationId xmlns:a16="http://schemas.microsoft.com/office/drawing/2014/main" id="{A707ADC3-1653-481E-CF53-8B1239ACAB02}"/>
-              </a:ext>
-            </a:extLst>
-          </p:cNvPr>
-          <p:cNvSpPr txBox="1"/>
-          <p:nvPr/>
-        </p:nvSpPr>
-        <p:spPr>
-          <a:xfrm>
-            <a:off x="1447800" y="2895600"/>
-            <a:ext cx="2413000" cy="276999"/>
-          </a:xfrm>
-          <a:prstGeom prst="rect">
-            <a:avLst/>
-          </a:prstGeom>
-          <a:noFill/>
-        </p:spPr>
-        <p:txBody>
-          <a:bodyPr vert="horz" wrap="square" lIns="0" tIns="0" rIns="0" bIns="0" rtlCol="0">
-            <a:noAutofit/>
-          </a:bodyPr>
-          <a:lstStyle/>
-          <a:p>
-            <a:r>
-              <a:rPr lang="en-US" sz="900" b="1">
-                <a:solidFill>
-                  <a:srgbClr val="CE4A2B"/>
-                </a:solidFill>
-                <a:latin typeface="Aptos" panose="020B0004020202020204" pitchFamily="34" charset="0"/>
-              </a:rPr>
-              <a:t>PROVEN</a:t>
-            </a:r>
-          </a:p>
-        </p:txBody>
-      </p:sp>
-      <p:sp>
-        <p:nvSpPr>
-          <p:cNvPr id="23" name="TextBox 22">
-            <a:extLst>
-              <a:ext uri="{FF2B5EF4-FFF2-40B4-BE49-F238E27FC236}">
-                <a16:creationId xmlns:a16="http://schemas.microsoft.com/office/drawing/2014/main" id="{17491E1C-6D29-8C2A-6FDE-D1A1AD3B2A49}"/>
-              </a:ext>
-            </a:extLst>
-          </p:cNvPr>
-          <p:cNvSpPr txBox="1"/>
-          <p:nvPr/>
-        </p:nvSpPr>
-        <p:spPr>
-          <a:xfrm>
-            <a:off x="1447800" y="3136900"/>
-            <a:ext cx="2413000" cy="276999"/>
-          </a:xfrm>
-          <a:prstGeom prst="rect">
-            <a:avLst/>
-          </a:prstGeom>
-          <a:noFill/>
-        </p:spPr>
-        <p:txBody>
-          <a:bodyPr vert="horz" wrap="square" lIns="0" tIns="0" rIns="0" bIns="0" rtlCol="0">
-            <a:noAutofit/>
-          </a:bodyPr>
-          <a:lstStyle/>
-          <a:p>
-            <a:r>
-              <a:rPr lang="en-US" sz="1250" b="1">
-                <a:solidFill>
-                  <a:srgbClr val="1F2329"/>
-                </a:solidFill>
-                <a:latin typeface="Aptos" panose="020B0004020202020204" pitchFamily="34" charset="0"/>
-              </a:rPr>
-              <a:t>Two consumer-owned pins</a:t>
-            </a:r>
-          </a:p>
-        </p:txBody>
-      </p:sp>
-      <p:sp>
-        <p:nvSpPr>
-          <p:cNvPr id="24" name="Rectangle: Rounded Corners 23">
-            <a:extLst>
-              <a:ext uri="{FF2B5EF4-FFF2-40B4-BE49-F238E27FC236}">
-                <a16:creationId xmlns:a16="http://schemas.microsoft.com/office/drawing/2014/main" id="{23EDAEC4-C6E4-9361-1D42-7560EE7ED0E0}"/>
-              </a:ext>
-            </a:extLst>
-          </p:cNvPr>
-          <p:cNvSpPr/>
-          <p:nvPr/>
-        </p:nvSpPr>
-        <p:spPr>
-          <a:xfrm>
-            <a:off x="4419600" y="2768600"/>
-            <a:ext cx="3429000" cy="838200"/>
-          </a:xfrm>
-          <a:prstGeom prst="roundRect">
-            <a:avLst/>
-          </a:prstGeom>
-          <a:solidFill>
-            <a:srgbClr val="E8F1F7"/>
-          </a:solidFill>
-          <a:ln w="19050" cap="flat" cmpd="sng" algn="ctr">
-            <a:solidFill>
-              <a:srgbClr val="C5CED8"/>
-            </a:solidFill>
-            <a:prstDash val="solid"/>
-            <a:miter lim="800000"/>
-            <a:headEnd type="none" w="med" len="med"/>
-            <a:tailEnd type="none" w="med" len="med"/>
-          </a:ln>
-        </p:spPr>
-        <p:style>
-          <a:lnRef idx="2">
-            <a:schemeClr val="accent1">
-              <a:shade val="15000"/>
-            </a:schemeClr>
-          </a:lnRef>
-          <a:fillRef idx="1">
-            <a:schemeClr val="accent1"/>
-          </a:fillRef>
-          <a:effectRef idx="0">
-            <a:schemeClr val="accent1"/>
-          </a:effectRef>
-          <a:fontRef idx="minor">
-            <a:schemeClr val="lt1"/>
-          </a:fontRef>
-        </p:style>
-        <p:txBody>
-          <a:bodyPr rtlCol="0" anchor="ctr"/>
-          <a:lstStyle/>
-          <a:p>
-            <a:pPr algn="ctr"/>
-            <a:endParaRPr lang="en-US"/>
-          </a:p>
-        </p:txBody>
-      </p:sp>
-      <p:sp>
-        <p:nvSpPr>
-          <p:cNvPr id="25" name="Oval 24">
-            <a:extLst>
-              <a:ext uri="{FF2B5EF4-FFF2-40B4-BE49-F238E27FC236}">
-                <a16:creationId xmlns:a16="http://schemas.microsoft.com/office/drawing/2014/main" id="{C13ECF4F-9C99-86FD-BA77-71C09A9E2C4C}"/>
-              </a:ext>
-            </a:extLst>
-          </p:cNvPr>
-          <p:cNvSpPr/>
-          <p:nvPr/>
-        </p:nvSpPr>
-        <p:spPr>
-          <a:xfrm>
-            <a:off x="4622800" y="2959100"/>
             <a:ext cx="431800" cy="431800"/>
           </a:xfrm>
           <a:prstGeom prst="ellipse">
@@ -5026,19 +4786,19 @@
       </p:sp>
       <p:sp>
         <p:nvSpPr>
-          <p:cNvPr id="26" name="TextBox 25">
-            <a:extLst>
-              <a:ext uri="{FF2B5EF4-FFF2-40B4-BE49-F238E27FC236}">
-                <a16:creationId xmlns:a16="http://schemas.microsoft.com/office/drawing/2014/main" id="{2B75EDA8-04F7-ABC0-517F-53C0C96EBD98}"/>
-              </a:ext>
-            </a:extLst>
-          </p:cNvPr>
-          <p:cNvSpPr txBox="1"/>
-          <p:nvPr/>
-        </p:nvSpPr>
-        <p:spPr>
-          <a:xfrm>
-            <a:off x="4673600" y="3048000"/>
+          <p:cNvPr id="21" name="TextBox 20">
+            <a:extLst>
+              <a:ext uri="{FF2B5EF4-FFF2-40B4-BE49-F238E27FC236}">
+                <a16:creationId xmlns:a16="http://schemas.microsoft.com/office/drawing/2014/main" id="{9F775483-AC8B-2EF5-8144-156BB745F023}"/>
+              </a:ext>
+            </a:extLst>
+          </p:cNvPr>
+          <p:cNvSpPr txBox="1"/>
+          <p:nvPr/>
+        </p:nvSpPr>
+        <p:spPr>
+          <a:xfrm>
+            <a:off x="914400" y="3048000"/>
             <a:ext cx="330200" cy="276999"/>
           </a:xfrm>
           <a:prstGeom prst="rect">
@@ -5060,26 +4820,26 @@
                 </a:solidFill>
                 <a:latin typeface="Aptos Display" panose="020B0004020202020204" pitchFamily="34" charset="0"/>
               </a:rPr>
-              <a:t>NXT</a:t>
-            </a:r>
-          </a:p>
-        </p:txBody>
-      </p:sp>
-      <p:sp>
-        <p:nvSpPr>
-          <p:cNvPr id="27" name="TextBox 26">
-            <a:extLst>
-              <a:ext uri="{FF2B5EF4-FFF2-40B4-BE49-F238E27FC236}">
-                <a16:creationId xmlns:a16="http://schemas.microsoft.com/office/drawing/2014/main" id="{C5E0AAB4-D57B-F96F-C9E2-A6281BB03DAD}"/>
-              </a:ext>
-            </a:extLst>
-          </p:cNvPr>
-          <p:cNvSpPr txBox="1"/>
-          <p:nvPr/>
-        </p:nvSpPr>
-        <p:spPr>
-          <a:xfrm>
-            <a:off x="5207000" y="2895600"/>
+              <a:t>NO</a:t>
+            </a:r>
+          </a:p>
+        </p:txBody>
+      </p:sp>
+      <p:sp>
+        <p:nvSpPr>
+          <p:cNvPr id="22" name="TextBox 21">
+            <a:extLst>
+              <a:ext uri="{FF2B5EF4-FFF2-40B4-BE49-F238E27FC236}">
+                <a16:creationId xmlns:a16="http://schemas.microsoft.com/office/drawing/2014/main" id="{6BE7A285-C4BA-80F7-5B24-5B794D0300BB}"/>
+              </a:ext>
+            </a:extLst>
+          </p:cNvPr>
+          <p:cNvSpPr txBox="1"/>
+          <p:nvPr/>
+        </p:nvSpPr>
+        <p:spPr>
+          <a:xfrm>
+            <a:off x="1447800" y="2895600"/>
             <a:ext cx="2413000" cy="276999"/>
           </a:xfrm>
           <a:prstGeom prst="rect">
@@ -5100,26 +4860,26 @@
                 </a:solidFill>
                 <a:latin typeface="Aptos" panose="020B0004020202020204" pitchFamily="34" charset="0"/>
               </a:rPr>
-              <a:t>NEXT</a:t>
-            </a:r>
-          </a:p>
-        </p:txBody>
-      </p:sp>
-      <p:sp>
-        <p:nvSpPr>
-          <p:cNvPr id="28" name="TextBox 27">
-            <a:extLst>
-              <a:ext uri="{FF2B5EF4-FFF2-40B4-BE49-F238E27FC236}">
-                <a16:creationId xmlns:a16="http://schemas.microsoft.com/office/drawing/2014/main" id="{06CD7C4B-151E-FB8D-CF8E-FFEBDDDF7E80}"/>
-              </a:ext>
-            </a:extLst>
-          </p:cNvPr>
-          <p:cNvSpPr txBox="1"/>
-          <p:nvPr/>
-        </p:nvSpPr>
-        <p:spPr>
-          <a:xfrm>
-            <a:off x="5207000" y="3136900"/>
+              <a:t>BLOCKED</a:t>
+            </a:r>
+          </a:p>
+        </p:txBody>
+      </p:sp>
+      <p:sp>
+        <p:nvSpPr>
+          <p:cNvPr id="23" name="TextBox 22">
+            <a:extLst>
+              <a:ext uri="{FF2B5EF4-FFF2-40B4-BE49-F238E27FC236}">
+                <a16:creationId xmlns:a16="http://schemas.microsoft.com/office/drawing/2014/main" id="{80ACE30F-8892-8030-1689-BE49804B6125}"/>
+              </a:ext>
+            </a:extLst>
+          </p:cNvPr>
+          <p:cNvSpPr txBox="1"/>
+          <p:nvPr/>
+        </p:nvSpPr>
+        <p:spPr>
+          <a:xfrm>
+            <a:off x="1447800" y="3136900"/>
             <a:ext cx="2413000" cy="276999"/>
           </a:xfrm>
           <a:prstGeom prst="rect">
@@ -5140,17 +4900,17 @@
                 </a:solidFill>
                 <a:latin typeface="Aptos" panose="020B0004020202020204" pitchFamily="34" charset="0"/>
               </a:rPr>
-              <a:t>Native or service boundary</a:t>
-            </a:r>
-          </a:p>
-        </p:txBody>
-      </p:sp>
-      <p:sp>
-        <p:nvSpPr>
-          <p:cNvPr id="29" name="Rectangle: Rounded Corners 28">
-            <a:extLst>
-              <a:ext uri="{FF2B5EF4-FFF2-40B4-BE49-F238E27FC236}">
-                <a16:creationId xmlns:a16="http://schemas.microsoft.com/office/drawing/2014/main" id="{ED0F747A-1599-CF09-C808-720276C5D6D1}"/>
+              <a:t>Gate 2: measured value</a:t>
+            </a:r>
+          </a:p>
+        </p:txBody>
+      </p:sp>
+      <p:sp>
+        <p:nvSpPr>
+          <p:cNvPr id="24" name="Rectangle: Rounded Corners 23">
+            <a:extLst>
+              <a:ext uri="{FF2B5EF4-FFF2-40B4-BE49-F238E27FC236}">
+                <a16:creationId xmlns:a16="http://schemas.microsoft.com/office/drawing/2014/main" id="{7D27BFA7-552C-9C03-FB3B-BEDF7C433F03}"/>
               </a:ext>
             </a:extLst>
           </p:cNvPr>
@@ -5159,7 +4919,7 @@
         </p:nvSpPr>
         <p:spPr>
           <a:xfrm>
-            <a:off x="8178800" y="2768600"/>
+            <a:off x="4419600" y="2768600"/>
             <a:ext cx="3429000" cy="838200"/>
           </a:xfrm>
           <a:prstGeom prst="roundRect">
@@ -5205,10 +4965,10 @@
       </p:sp>
       <p:sp>
         <p:nvSpPr>
-          <p:cNvPr id="30" name="Oval 29">
-            <a:extLst>
-              <a:ext uri="{FF2B5EF4-FFF2-40B4-BE49-F238E27FC236}">
-                <a16:creationId xmlns:a16="http://schemas.microsoft.com/office/drawing/2014/main" id="{1B308855-B676-BBE6-5868-0E09A17ED302}"/>
+          <p:cNvPr id="25" name="Oval 24">
+            <a:extLst>
+              <a:ext uri="{FF2B5EF4-FFF2-40B4-BE49-F238E27FC236}">
+                <a16:creationId xmlns:a16="http://schemas.microsoft.com/office/drawing/2014/main" id="{A19A96B1-7ED7-AF50-6A55-F66F57148C86}"/>
               </a:ext>
             </a:extLst>
           </p:cNvPr>
@@ -5217,14 +4977,14 @@
         </p:nvSpPr>
         <p:spPr>
           <a:xfrm>
-            <a:off x="8382000" y="2959100"/>
+            <a:off x="4622800" y="2959100"/>
             <a:ext cx="431800" cy="431800"/>
           </a:xfrm>
           <a:prstGeom prst="ellipse">
             <a:avLst/>
           </a:prstGeom>
           <a:solidFill>
-            <a:srgbClr val="D95F31"/>
+            <a:srgbClr val="CE4A2B"/>
           </a:solidFill>
           <a:ln w="19050" cap="flat" cmpd="sng" algn="ctr">
             <a:solidFill>
@@ -5266,10 +5026,250 @@
       </p:sp>
       <p:sp>
         <p:nvSpPr>
+          <p:cNvPr id="26" name="TextBox 25">
+            <a:extLst>
+              <a:ext uri="{FF2B5EF4-FFF2-40B4-BE49-F238E27FC236}">
+                <a16:creationId xmlns:a16="http://schemas.microsoft.com/office/drawing/2014/main" id="{8E8ABD7D-CBF4-09E0-9384-D7D0DF1DBB7C}"/>
+              </a:ext>
+            </a:extLst>
+          </p:cNvPr>
+          <p:cNvSpPr txBox="1"/>
+          <p:nvPr/>
+        </p:nvSpPr>
+        <p:spPr>
+          <a:xfrm>
+            <a:off x="4673600" y="3048000"/>
+            <a:ext cx="330200" cy="276999"/>
+          </a:xfrm>
+          <a:prstGeom prst="rect">
+            <a:avLst/>
+          </a:prstGeom>
+          <a:noFill/>
+        </p:spPr>
+        <p:txBody>
+          <a:bodyPr vert="horz" wrap="square" lIns="0" tIns="0" rIns="0" bIns="0" rtlCol="0">
+            <a:noAutofit/>
+          </a:bodyPr>
+          <a:lstStyle/>
+          <a:p>
+            <a:pPr algn="ctr"/>
+            <a:r>
+              <a:rPr lang="en-US" sz="800" b="1">
+                <a:solidFill>
+                  <a:srgbClr val="10212D"/>
+                </a:solidFill>
+                <a:latin typeface="Aptos Display" panose="020B0004020202020204" pitchFamily="34" charset="0"/>
+              </a:rPr>
+              <a:t>--</a:t>
+            </a:r>
+          </a:p>
+        </p:txBody>
+      </p:sp>
+      <p:sp>
+        <p:nvSpPr>
+          <p:cNvPr id="27" name="TextBox 26">
+            <a:extLst>
+              <a:ext uri="{FF2B5EF4-FFF2-40B4-BE49-F238E27FC236}">
+                <a16:creationId xmlns:a16="http://schemas.microsoft.com/office/drawing/2014/main" id="{0AE60A21-EA8A-759E-8A8E-037DB894ED56}"/>
+              </a:ext>
+            </a:extLst>
+          </p:cNvPr>
+          <p:cNvSpPr txBox="1"/>
+          <p:nvPr/>
+        </p:nvSpPr>
+        <p:spPr>
+          <a:xfrm>
+            <a:off x="5207000" y="2895600"/>
+            <a:ext cx="2413000" cy="276999"/>
+          </a:xfrm>
+          <a:prstGeom prst="rect">
+            <a:avLst/>
+          </a:prstGeom>
+          <a:noFill/>
+        </p:spPr>
+        <p:txBody>
+          <a:bodyPr vert="horz" wrap="square" lIns="0" tIns="0" rIns="0" bIns="0" rtlCol="0">
+            <a:noAutofit/>
+          </a:bodyPr>
+          <a:lstStyle/>
+          <a:p>
+            <a:r>
+              <a:rPr lang="en-US" sz="900" b="1">
+                <a:solidFill>
+                  <a:srgbClr val="CE4A2B"/>
+                </a:solidFill>
+                <a:latin typeface="Aptos" panose="020B0004020202020204" pitchFamily="34" charset="0"/>
+              </a:rPr>
+              <a:t>WAITING</a:t>
+            </a:r>
+          </a:p>
+        </p:txBody>
+      </p:sp>
+      <p:sp>
+        <p:nvSpPr>
+          <p:cNvPr id="28" name="TextBox 27">
+            <a:extLst>
+              <a:ext uri="{FF2B5EF4-FFF2-40B4-BE49-F238E27FC236}">
+                <a16:creationId xmlns:a16="http://schemas.microsoft.com/office/drawing/2014/main" id="{57C40A57-4B5E-A7EC-9F5A-61B7AAE6839D}"/>
+              </a:ext>
+            </a:extLst>
+          </p:cNvPr>
+          <p:cNvSpPr txBox="1"/>
+          <p:nvPr/>
+        </p:nvSpPr>
+        <p:spPr>
+          <a:xfrm>
+            <a:off x="5207000" y="3136900"/>
+            <a:ext cx="2413000" cy="276999"/>
+          </a:xfrm>
+          <a:prstGeom prst="rect">
+            <a:avLst/>
+          </a:prstGeom>
+          <a:noFill/>
+        </p:spPr>
+        <p:txBody>
+          <a:bodyPr vert="horz" wrap="square" lIns="0" tIns="0" rIns="0" bIns="0" rtlCol="0">
+            <a:noAutofit/>
+          </a:bodyPr>
+          <a:lstStyle/>
+          <a:p>
+            <a:r>
+              <a:rPr lang="en-US" sz="1250" b="1">
+                <a:solidFill>
+                  <a:srgbClr val="1F2329"/>
+                </a:solidFill>
+                <a:latin typeface="Aptos" panose="020B0004020202020204" pitchFamily="34" charset="0"/>
+              </a:rPr>
+              <a:t>Gate 3: advisory CI shadow</a:t>
+            </a:r>
+          </a:p>
+        </p:txBody>
+      </p:sp>
+      <p:sp>
+        <p:nvSpPr>
+          <p:cNvPr id="29" name="Rectangle: Rounded Corners 28">
+            <a:extLst>
+              <a:ext uri="{FF2B5EF4-FFF2-40B4-BE49-F238E27FC236}">
+                <a16:creationId xmlns:a16="http://schemas.microsoft.com/office/drawing/2014/main" id="{4A2879DE-BFBC-1A2E-0A4A-79CECABADBEA}"/>
+              </a:ext>
+            </a:extLst>
+          </p:cNvPr>
+          <p:cNvSpPr/>
+          <p:nvPr/>
+        </p:nvSpPr>
+        <p:spPr>
+          <a:xfrm>
+            <a:off x="8178800" y="2768600"/>
+            <a:ext cx="3429000" cy="838200"/>
+          </a:xfrm>
+          <a:prstGeom prst="roundRect">
+            <a:avLst/>
+          </a:prstGeom>
+          <a:solidFill>
+            <a:srgbClr val="E8F1F7"/>
+          </a:solidFill>
+          <a:ln w="19050" cap="flat" cmpd="sng" algn="ctr">
+            <a:solidFill>
+              <a:srgbClr val="C5CED8"/>
+            </a:solidFill>
+            <a:prstDash val="solid"/>
+            <a:miter lim="800000"/>
+            <a:headEnd type="none" w="med" len="med"/>
+            <a:tailEnd type="none" w="med" len="med"/>
+          </a:ln>
+        </p:spPr>
+        <p:style>
+          <a:lnRef idx="2">
+            <a:schemeClr val="accent1">
+              <a:shade val="15000"/>
+            </a:schemeClr>
+          </a:lnRef>
+          <a:fillRef idx="1">
+            <a:schemeClr val="accent1"/>
+          </a:fillRef>
+          <a:effectRef idx="0">
+            <a:schemeClr val="accent1"/>
+          </a:effectRef>
+          <a:fontRef idx="minor">
+            <a:schemeClr val="lt1"/>
+          </a:fontRef>
+        </p:style>
+        <p:txBody>
+          <a:bodyPr rtlCol="0" anchor="ctr"/>
+          <a:lstStyle/>
+          <a:p>
+            <a:pPr algn="ctr"/>
+            <a:endParaRPr lang="en-US"/>
+          </a:p>
+        </p:txBody>
+      </p:sp>
+      <p:sp>
+        <p:nvSpPr>
+          <p:cNvPr id="30" name="Oval 29">
+            <a:extLst>
+              <a:ext uri="{FF2B5EF4-FFF2-40B4-BE49-F238E27FC236}">
+                <a16:creationId xmlns:a16="http://schemas.microsoft.com/office/drawing/2014/main" id="{FAC531C2-28D2-29FF-6B1A-5324D0173DE0}"/>
+              </a:ext>
+            </a:extLst>
+          </p:cNvPr>
+          <p:cNvSpPr/>
+          <p:nvPr/>
+        </p:nvSpPr>
+        <p:spPr>
+          <a:xfrm>
+            <a:off x="8382000" y="2959100"/>
+            <a:ext cx="431800" cy="431800"/>
+          </a:xfrm>
+          <a:prstGeom prst="ellipse">
+            <a:avLst/>
+          </a:prstGeom>
+          <a:solidFill>
+            <a:srgbClr val="CE4A2B"/>
+          </a:solidFill>
+          <a:ln w="19050" cap="flat" cmpd="sng" algn="ctr">
+            <a:solidFill>
+              <a:schemeClr val="accent1">
+                <a:shade val="15000"/>
+                <a:alpha val="0"/>
+              </a:schemeClr>
+            </a:solidFill>
+            <a:prstDash val="solid"/>
+            <a:miter lim="800000"/>
+            <a:headEnd type="none" w="med" len="med"/>
+            <a:tailEnd type="none" w="med" len="med"/>
+          </a:ln>
+        </p:spPr>
+        <p:style>
+          <a:lnRef idx="2">
+            <a:schemeClr val="accent1">
+              <a:shade val="15000"/>
+            </a:schemeClr>
+          </a:lnRef>
+          <a:fillRef idx="1">
+            <a:schemeClr val="accent1"/>
+          </a:fillRef>
+          <a:effectRef idx="0">
+            <a:schemeClr val="accent1"/>
+          </a:effectRef>
+          <a:fontRef idx="minor">
+            <a:schemeClr val="lt1"/>
+          </a:fontRef>
+        </p:style>
+        <p:txBody>
+          <a:bodyPr rtlCol="0" anchor="ctr"/>
+          <a:lstStyle/>
+          <a:p>
+            <a:pPr algn="ctr"/>
+            <a:endParaRPr lang="en-US"/>
+          </a:p>
+        </p:txBody>
+      </p:sp>
+      <p:sp>
+        <p:nvSpPr>
           <p:cNvPr id="31" name="TextBox 30">
             <a:extLst>
               <a:ext uri="{FF2B5EF4-FFF2-40B4-BE49-F238E27FC236}">
-                <a16:creationId xmlns:a16="http://schemas.microsoft.com/office/drawing/2014/main" id="{C9519918-EAA5-5DC7-F1E0-4E444D531D5A}"/>
+                <a16:creationId xmlns:a16="http://schemas.microsoft.com/office/drawing/2014/main" id="{2876212F-AF22-917C-B55F-9D6F398848D9}"/>
               </a:ext>
             </a:extLst>
           </p:cNvPr>
@@ -5300,7 +5300,7 @@
                 </a:solidFill>
                 <a:latin typeface="Aptos Display" panose="020B0004020202020204" pitchFamily="34" charset="0"/>
               </a:rPr>
-              <a:t>NXT</a:t>
+              <a:t>--</a:t>
             </a:r>
           </a:p>
         </p:txBody>
@@ -5310,7 +5310,7 @@
           <p:cNvPr id="32" name="TextBox 31">
             <a:extLst>
               <a:ext uri="{FF2B5EF4-FFF2-40B4-BE49-F238E27FC236}">
-                <a16:creationId xmlns:a16="http://schemas.microsoft.com/office/drawing/2014/main" id="{81C11F3E-D478-0A87-0F60-694D56E9D4D6}"/>
+                <a16:creationId xmlns:a16="http://schemas.microsoft.com/office/drawing/2014/main" id="{066BF02D-23AF-B7BC-D847-B0AE2B65D9DC}"/>
               </a:ext>
             </a:extLst>
           </p:cNvPr>
@@ -5340,7 +5340,7 @@
                 </a:solidFill>
                 <a:latin typeface="Aptos" panose="020B0004020202020204" pitchFamily="34" charset="0"/>
               </a:rPr>
-              <a:t>NEXT</a:t>
+              <a:t>WAITING</a:t>
             </a:r>
           </a:p>
         </p:txBody>
@@ -5350,7 +5350,7 @@
           <p:cNvPr id="33" name="TextBox 32">
             <a:extLst>
               <a:ext uri="{FF2B5EF4-FFF2-40B4-BE49-F238E27FC236}">
-                <a16:creationId xmlns:a16="http://schemas.microsoft.com/office/drawing/2014/main" id="{7A54AD47-303C-0BEC-88CD-CEBADCE4A8B2}"/>
+                <a16:creationId xmlns:a16="http://schemas.microsoft.com/office/drawing/2014/main" id="{23350F3D-A251-2745-E238-2DBB350FDC85}"/>
               </a:ext>
             </a:extLst>
           </p:cNvPr>
@@ -5380,7 +5380,7 @@
                 </a:solidFill>
                 <a:latin typeface="Aptos" panose="020B0004020202020204" pitchFamily="34" charset="0"/>
               </a:rPr>
-              <a:t>GitHub + Azure design partner</a:t>
+              <a:t>Gate 4: support boundary</a:t>
             </a:r>
           </a:p>
         </p:txBody>
@@ -5390,7 +5390,7 @@
           <p:cNvPr id="34" name="Rectangle: Rounded Corners 33">
             <a:extLst>
               <a:ext uri="{FF2B5EF4-FFF2-40B4-BE49-F238E27FC236}">
-                <a16:creationId xmlns:a16="http://schemas.microsoft.com/office/drawing/2014/main" id="{DD44581B-6226-378D-7273-2175A6F820C3}"/>
+                <a16:creationId xmlns:a16="http://schemas.microsoft.com/office/drawing/2014/main" id="{3B56ECCE-65AC-0877-FADD-8FF43F702870}"/>
               </a:ext>
             </a:extLst>
           </p:cNvPr>
@@ -5450,16 +5450,16 @@
           <p:cNvPr id="35" name="TextBox 34">
             <a:extLst>
               <a:ext uri="{FF2B5EF4-FFF2-40B4-BE49-F238E27FC236}">
-                <a16:creationId xmlns:a16="http://schemas.microsoft.com/office/drawing/2014/main" id="{31A47E11-9ABE-FE5D-0833-5E261B5345A3}"/>
-              </a:ext>
-            </a:extLst>
-          </p:cNvPr>
-          <p:cNvSpPr txBox="1"/>
-          <p:nvPr/>
-        </p:nvSpPr>
-        <p:spPr>
-          <a:xfrm>
-            <a:off x="990600" y="4546600"/>
+                <a16:creationId xmlns:a16="http://schemas.microsoft.com/office/drawing/2014/main" id="{3CB951B1-6F99-09D1-8B58-FA3AD4AF95D7}"/>
+              </a:ext>
+            </a:extLst>
+          </p:cNvPr>
+          <p:cNvSpPr txBox="1"/>
+          <p:nvPr/>
+        </p:nvSpPr>
+        <p:spPr>
+          <a:xfrm>
+            <a:off x="990600" y="4470400"/>
             <a:ext cx="10261600" cy="276999"/>
           </a:xfrm>
           <a:prstGeom prst="rect">
@@ -5481,7 +5481,7 @@
                 </a:solidFill>
                 <a:latin typeface="Aptos Display" panose="020B0004020202020204" pitchFamily="34" charset="0"/>
               </a:rPr>
-              <a:t>Next proof: one owned application, real boundaries, owner validation, rollback, and removal.</a:t>
+              <a:t>37 of 40 historical revisions widened to full validation.</a:t>
             </a:r>
           </a:p>
         </p:txBody>
@@ -5491,16 +5491,16 @@
           <p:cNvPr id="36" name="TextBox 35">
             <a:extLst>
               <a:ext uri="{FF2B5EF4-FFF2-40B4-BE49-F238E27FC236}">
-                <a16:creationId xmlns:a16="http://schemas.microsoft.com/office/drawing/2014/main" id="{1E2E1116-C34B-C396-47F6-D9B616850D9D}"/>
-              </a:ext>
-            </a:extLst>
-          </p:cNvPr>
-          <p:cNvSpPr txBox="1"/>
-          <p:nvPr/>
-        </p:nvSpPr>
-        <p:spPr>
-          <a:xfrm>
-            <a:off x="990600" y="5105400"/>
+                <a16:creationId xmlns:a16="http://schemas.microsoft.com/office/drawing/2014/main" id="{CAEB421F-4B19-A12D-7755-7EC9ACD95B60}"/>
+              </a:ext>
+            </a:extLst>
+          </p:cNvPr>
+          <p:cNvSpPr txBox="1"/>
+          <p:nvPr/>
+        </p:nvSpPr>
+        <p:spPr>
+          <a:xfrm>
+            <a:off x="990600" y="4991100"/>
             <a:ext cx="10261600" cy="276999"/>
           </a:xfrm>
           <a:prstGeom prst="rect">
@@ -5522,7 +5522,7 @@
                 </a:solidFill>
                 <a:latin typeface="Aptos" panose="020B0004020202020204" pitchFamily="34" charset="0"/>
               </a:rPr>
-              <a:t>Ferris remains removable and read-first; execution is not part of this ask.</a:t>
+              <a:t>The only admissible narrowed comparison was 7.7% slower. Later cohorts produced no admissible timing.</a:t>
             </a:r>
           </a:p>
         </p:txBody>
@@ -5532,7 +5532,7 @@
           <p:cNvPr id="37" name="TextBox 36">
             <a:extLst>
               <a:ext uri="{FF2B5EF4-FFF2-40B4-BE49-F238E27FC236}">
-                <a16:creationId xmlns:a16="http://schemas.microsoft.com/office/drawing/2014/main" id="{5F336038-6FBF-2325-C031-305BDDD94BC7}"/>
+                <a16:creationId xmlns:a16="http://schemas.microsoft.com/office/drawing/2014/main" id="{3E3766ED-FC88-0B65-304F-0676290E8456}"/>
               </a:ext>
             </a:extLst>
           </p:cNvPr>
@@ -5562,7 +5562,7 @@
                 </a:solidFill>
                 <a:latin typeface="Aptos" panose="020B0004020202020204" pitchFamily="34" charset="0"/>
               </a:rPr>
-              <a:t>Current status: public incubation platform, exact experimental contracts, no production support claim.</a:t>
+              <a:t>Claims F-01 and F-02: MICROSOFT_RUST_CLAIM_LEDGER.md. No savings, CI replacement, or support claim.</a:t>
             </a:r>
           </a:p>
         </p:txBody>
@@ -5572,7 +5572,7 @@
           <p:cNvPr id="38" name="TextBox 37">
             <a:extLst>
               <a:ext uri="{FF2B5EF4-FFF2-40B4-BE49-F238E27FC236}">
-                <a16:creationId xmlns:a16="http://schemas.microsoft.com/office/drawing/2014/main" id="{AFB08FC9-C04C-78AF-13E6-58E07D29CC2E}"/>
+                <a16:creationId xmlns:a16="http://schemas.microsoft.com/office/drawing/2014/main" id="{C405328C-B008-7F17-EDC1-39886CCE1CF2}"/>
               </a:ext>
             </a:extLst>
           </p:cNvPr>
@@ -5611,7 +5611,7 @@
     </p:spTree>
     <p:extLst>
       <p:ext uri="{BB962C8B-B14F-4D97-AF65-F5344CB8AC3E}">
-        <p14:creationId xmlns:p14="http://schemas.microsoft.com/office/powerpoint/2010/main" val="2443231766"/>
+        <p14:creationId xmlns:p14="http://schemas.microsoft.com/office/powerpoint/2010/main" val="605925656"/>
       </p:ext>
     </p:extLst>
   </p:cSld>
@@ -5643,7 +5643,7 @@
           <p:cNvPr id="2" name="TextBox 1">
             <a:extLst>
               <a:ext uri="{FF2B5EF4-FFF2-40B4-BE49-F238E27FC236}">
-                <a16:creationId xmlns:a16="http://schemas.microsoft.com/office/drawing/2014/main" id="{FB96BED9-EEA7-B2B2-E2EC-A421ECDBE280}"/>
+                <a16:creationId xmlns:a16="http://schemas.microsoft.com/office/drawing/2014/main" id="{CFB39985-AA18-D3A8-CC33-5D63E10E7EF4}"/>
               </a:ext>
             </a:extLst>
           </p:cNvPr>
@@ -5673,7 +5673,7 @@
                 </a:solidFill>
                 <a:latin typeface="Aptos" panose="020B0004020202020204" pitchFamily="34" charset="0"/>
               </a:rPr>
-              <a:t>ROADMAP</a:t>
+              <a:t>GATED ROADMAP</a:t>
             </a:r>
           </a:p>
         </p:txBody>
@@ -5683,7 +5683,7 @@
           <p:cNvPr id="3" name="TextBox 2">
             <a:extLst>
               <a:ext uri="{FF2B5EF4-FFF2-40B4-BE49-F238E27FC236}">
-                <a16:creationId xmlns:a16="http://schemas.microsoft.com/office/drawing/2014/main" id="{D90A055B-E6BC-8E01-3696-6163FB1B62D5}"/>
+                <a16:creationId xmlns:a16="http://schemas.microsoft.com/office/drawing/2014/main" id="{D96C676D-2CF4-15D3-A119-CA4D74341B78}"/>
               </a:ext>
             </a:extLst>
           </p:cNvPr>
@@ -5713,7 +5713,7 @@
                 </a:solidFill>
                 <a:latin typeface="Aptos Display" panose="020B0004020202020204" pitchFamily="34" charset="0"/>
               </a:rPr>
-              <a:t>A staged investment keeps ambition high and risk bounded</a:t>
+              <a:t>Evidence gates control the roadmap</a:t>
             </a:r>
           </a:p>
         </p:txBody>
@@ -5723,7 +5723,7 @@
           <p:cNvPr id="4" name="Rectangle: Rounded Corners 3">
             <a:extLst>
               <a:ext uri="{FF2B5EF4-FFF2-40B4-BE49-F238E27FC236}">
-                <a16:creationId xmlns:a16="http://schemas.microsoft.com/office/drawing/2014/main" id="{D8743BCF-AA8B-1BAF-0DF0-FC9D8F95470E}"/>
+                <a16:creationId xmlns:a16="http://schemas.microsoft.com/office/drawing/2014/main" id="{21088B0D-A47F-2CE3-41AC-915E92185037}"/>
               </a:ext>
             </a:extLst>
           </p:cNvPr>
@@ -5781,7 +5781,7 @@
           <p:cNvPr id="5" name="TextBox 4">
             <a:extLst>
               <a:ext uri="{FF2B5EF4-FFF2-40B4-BE49-F238E27FC236}">
-                <a16:creationId xmlns:a16="http://schemas.microsoft.com/office/drawing/2014/main" id="{A19BEB3B-E227-279D-333C-F4C4296CDF0C}"/>
+                <a16:creationId xmlns:a16="http://schemas.microsoft.com/office/drawing/2014/main" id="{4384359A-0702-75D0-BDFD-2D12EFA047CE}"/>
               </a:ext>
             </a:extLst>
           </p:cNvPr>
@@ -5811,7 +5811,7 @@
                 </a:solidFill>
                 <a:latin typeface="Aptos" panose="020B0004020202020204" pitchFamily="34" charset="0"/>
               </a:rPr>
-              <a:t>NOW</a:t>
+              <a:t>PASSED</a:t>
             </a:r>
           </a:p>
         </p:txBody>
@@ -5821,7 +5821,7 @@
           <p:cNvPr id="6" name="TextBox 5">
             <a:extLst>
               <a:ext uri="{FF2B5EF4-FFF2-40B4-BE49-F238E27FC236}">
-                <a16:creationId xmlns:a16="http://schemas.microsoft.com/office/drawing/2014/main" id="{1985E856-B762-F64D-E207-144D94AE0F99}"/>
+                <a16:creationId xmlns:a16="http://schemas.microsoft.com/office/drawing/2014/main" id="{EC8C527E-2800-D741-C3FA-91C65D5B8267}"/>
               </a:ext>
             </a:extLst>
           </p:cNvPr>
@@ -5851,7 +5851,7 @@
                 </a:solidFill>
                 <a:latin typeface="Aptos Display" panose="020B0004020202020204" pitchFamily="34" charset="0"/>
               </a:rPr>
-              <a:t>Public foundation</a:t>
+              <a:t>Foundation proof</a:t>
             </a:r>
           </a:p>
         </p:txBody>
@@ -5861,7 +5861,7 @@
           <p:cNvPr id="7" name="TextBox 6">
             <a:extLst>
               <a:ext uri="{FF2B5EF4-FFF2-40B4-BE49-F238E27FC236}">
-                <a16:creationId xmlns:a16="http://schemas.microsoft.com/office/drawing/2014/main" id="{36FACBD3-B750-8DF4-7798-FFA0248A30D6}"/>
+                <a16:creationId xmlns:a16="http://schemas.microsoft.com/office/drawing/2014/main" id="{6A3310CD-8341-8BD2-D2D9-31751E532FF7}"/>
               </a:ext>
             </a:extLst>
           </p:cNvPr>
@@ -5891,9 +5891,9 @@
                 </a:solidFill>
                 <a:latin typeface="Aptos" panose="020B0004020202020204" pitchFamily="34" charset="0"/>
               </a:rPr>
-              <a:t>Cargo-native plans
-Federation + schemas
-PARLOR + RUNE pins</a:t>
+              <a:t>Owner execution + receipts
+Windows/Linux onboarding
+Complete removal proof</a:t>
             </a:r>
           </a:p>
         </p:txBody>
@@ -5903,7 +5903,7 @@
           <p:cNvPr id="8" name="Rectangle: Rounded Corners 7">
             <a:extLst>
               <a:ext uri="{FF2B5EF4-FFF2-40B4-BE49-F238E27FC236}">
-                <a16:creationId xmlns:a16="http://schemas.microsoft.com/office/drawing/2014/main" id="{0FDD5C6D-0005-AE51-9C8A-5594561962E1}"/>
+                <a16:creationId xmlns:a16="http://schemas.microsoft.com/office/drawing/2014/main" id="{251A012A-2512-BAC6-F260-6E53C4CC7741}"/>
               </a:ext>
             </a:extLst>
           </p:cNvPr>
@@ -5961,7 +5961,7 @@
           <p:cNvPr id="9" name="TextBox 8">
             <a:extLst>
               <a:ext uri="{FF2B5EF4-FFF2-40B4-BE49-F238E27FC236}">
-                <a16:creationId xmlns:a16="http://schemas.microsoft.com/office/drawing/2014/main" id="{82DEF6F4-5582-6548-39F6-2DBEE58D30FE}"/>
+                <a16:creationId xmlns:a16="http://schemas.microsoft.com/office/drawing/2014/main" id="{4A319CB2-0BD7-EA85-8BE4-45410A91FCE7}"/>
               </a:ext>
             </a:extLst>
           </p:cNvPr>
@@ -5991,7 +5991,7 @@
                 </a:solidFill>
                 <a:latin typeface="Aptos" panose="020B0004020202020204" pitchFamily="34" charset="0"/>
               </a:rPr>
-              <a:t>0-6 MONTHS</a:t>
+              <a:t>PROPOSED</a:t>
             </a:r>
           </a:p>
         </p:txBody>
@@ -6001,7 +6001,7 @@
           <p:cNvPr id="10" name="TextBox 9">
             <a:extLst>
               <a:ext uri="{FF2B5EF4-FFF2-40B4-BE49-F238E27FC236}">
-                <a16:creationId xmlns:a16="http://schemas.microsoft.com/office/drawing/2014/main" id="{54C51C31-39CB-F86E-910E-64CB8025C1A7}"/>
+                <a16:creationId xmlns:a16="http://schemas.microsoft.com/office/drawing/2014/main" id="{15BB723A-EFA0-A4EA-598C-E3A04E56E0C6}"/>
               </a:ext>
             </a:extLst>
           </p:cNvPr>
@@ -6031,7 +6031,7 @@
                 </a:solidFill>
                 <a:latin typeface="Aptos Display" panose="020B0004020202020204" pitchFamily="34" charset="0"/>
               </a:rPr>
-              <a:t>Application proof</a:t>
+              <a:t>One final value cohort</a:t>
             </a:r>
           </a:p>
         </p:txBody>
@@ -6041,7 +6041,7 @@
           <p:cNvPr id="11" name="TextBox 10">
             <a:extLst>
               <a:ext uri="{FF2B5EF4-FFF2-40B4-BE49-F238E27FC236}">
-                <a16:creationId xmlns:a16="http://schemas.microsoft.com/office/drawing/2014/main" id="{E492A541-D40D-67B4-0538-995AFC1DD5A3}"/>
+                <a16:creationId xmlns:a16="http://schemas.microsoft.com/office/drawing/2014/main" id="{FB06F00D-026F-4756-4437-D59454910132}"/>
               </a:ext>
             </a:extLst>
           </p:cNvPr>
@@ -6071,9 +6071,10 @@
                 </a:solidFill>
                 <a:latin typeface="Aptos" panose="020B0004020202020204" pitchFamily="34" charset="0"/>
               </a:rPr>
-              <a:t>Named design partner
-Boundary + owner gates
-Rollback + removal</a:t>
+              <a:t>Frozen owner preflight
+One attempt maximum
+Stop if invalid, divergent,
+or nonpositive</a:t>
             </a:r>
           </a:p>
         </p:txBody>
@@ -6083,7 +6084,7 @@
           <p:cNvPr id="12" name="Rectangle: Rounded Corners 11">
             <a:extLst>
               <a:ext uri="{FF2B5EF4-FFF2-40B4-BE49-F238E27FC236}">
-                <a16:creationId xmlns:a16="http://schemas.microsoft.com/office/drawing/2014/main" id="{D499C3D0-0EF4-D64D-B80E-54424BA28FE5}"/>
+                <a16:creationId xmlns:a16="http://schemas.microsoft.com/office/drawing/2014/main" id="{671430C0-FB9B-74B2-EAD1-5A4AA3F4BAE2}"/>
               </a:ext>
             </a:extLst>
           </p:cNvPr>
@@ -6141,7 +6142,7 @@
           <p:cNvPr id="13" name="TextBox 12">
             <a:extLst>
               <a:ext uri="{FF2B5EF4-FFF2-40B4-BE49-F238E27FC236}">
-                <a16:creationId xmlns:a16="http://schemas.microsoft.com/office/drawing/2014/main" id="{B81D9644-E212-5033-A7D2-A232A79B29DF}"/>
+                <a16:creationId xmlns:a16="http://schemas.microsoft.com/office/drawing/2014/main" id="{2EC9D955-A66C-D25A-5E69-6F75107AF574}"/>
               </a:ext>
             </a:extLst>
           </p:cNvPr>
@@ -6171,7 +6172,7 @@
                 </a:solidFill>
                 <a:latin typeface="Aptos" panose="020B0004020202020204" pitchFamily="34" charset="0"/>
               </a:rPr>
-              <a:t>6-12 MONTHS</a:t>
+              <a:t>BLOCKED</a:t>
             </a:r>
           </a:p>
         </p:txBody>
@@ -6181,7 +6182,7 @@
           <p:cNvPr id="14" name="TextBox 13">
             <a:extLst>
               <a:ext uri="{FF2B5EF4-FFF2-40B4-BE49-F238E27FC236}">
-                <a16:creationId xmlns:a16="http://schemas.microsoft.com/office/drawing/2014/main" id="{AB154C74-1B1C-E66A-F7D8-F4B920A302A1}"/>
+                <a16:creationId xmlns:a16="http://schemas.microsoft.com/office/drawing/2014/main" id="{9A53CEAB-CB5B-E9EC-254D-58D09E50EF97}"/>
               </a:ext>
             </a:extLst>
           </p:cNvPr>
@@ -6211,7 +6212,7 @@
                 </a:solidFill>
                 <a:latin typeface="Aptos Display" panose="020B0004020202020204" pitchFamily="34" charset="0"/>
               </a:rPr>
-              <a:t>Platform pilot</a:t>
+              <a:t>Advisory CI shadow</a:t>
             </a:r>
           </a:p>
         </p:txBody>
@@ -6221,7 +6222,7 @@
           <p:cNvPr id="15" name="TextBox 14">
             <a:extLst>
               <a:ext uri="{FF2B5EF4-FFF2-40B4-BE49-F238E27FC236}">
-                <a16:creationId xmlns:a16="http://schemas.microsoft.com/office/drawing/2014/main" id="{DCB7A9E4-F2DE-2285-C5CE-C32F93129923}"/>
+                <a16:creationId xmlns:a16="http://schemas.microsoft.com/office/drawing/2014/main" id="{FF9E35E4-B32F-1F7D-2F54-32A792F057B2}"/>
               </a:ext>
             </a:extLst>
           </p:cNvPr>
@@ -6251,9 +6252,9 @@
                 </a:solidFill>
                 <a:latin typeface="Aptos" panose="020B0004020202020204" pitchFamily="34" charset="0"/>
               </a:rPr>
-              <a:t>Multiple orgs
-Read-only MCP
-Copilot + Azure connectors</a:t>
+              <a:t>Owner-approved scope
+Required checks retained
+Divergence measured</a:t>
             </a:r>
           </a:p>
         </p:txBody>
@@ -6263,7 +6264,7 @@
           <p:cNvPr id="16" name="Rectangle: Rounded Corners 15">
             <a:extLst>
               <a:ext uri="{FF2B5EF4-FFF2-40B4-BE49-F238E27FC236}">
-                <a16:creationId xmlns:a16="http://schemas.microsoft.com/office/drawing/2014/main" id="{2D724CD5-1F7D-8A9F-AB9D-84D6A456342F}"/>
+                <a16:creationId xmlns:a16="http://schemas.microsoft.com/office/drawing/2014/main" id="{C1B46B02-AC4C-95E2-DFAE-363D2DD6F4F5}"/>
               </a:ext>
             </a:extLst>
           </p:cNvPr>
@@ -6321,7 +6322,7 @@
           <p:cNvPr id="17" name="TextBox 16">
             <a:extLst>
               <a:ext uri="{FF2B5EF4-FFF2-40B4-BE49-F238E27FC236}">
-                <a16:creationId xmlns:a16="http://schemas.microsoft.com/office/drawing/2014/main" id="{2609E1E6-C827-BD92-5D05-A4FFC6FBD93E}"/>
+                <a16:creationId xmlns:a16="http://schemas.microsoft.com/office/drawing/2014/main" id="{ECC2BC8B-0278-1DA5-1167-FA87F2088C07}"/>
               </a:ext>
             </a:extLst>
           </p:cNvPr>
@@ -6351,7 +6352,7 @@
                 </a:solidFill>
                 <a:latin typeface="Aptos" panose="020B0004020202020204" pitchFamily="34" charset="0"/>
               </a:rPr>
-              <a:t>12-24 MONTHS</a:t>
+              <a:t>BLOCKED</a:t>
             </a:r>
           </a:p>
         </p:txBody>
@@ -6361,7 +6362,7 @@
           <p:cNvPr id="18" name="TextBox 17">
             <a:extLst>
               <a:ext uri="{FF2B5EF4-FFF2-40B4-BE49-F238E27FC236}">
-                <a16:creationId xmlns:a16="http://schemas.microsoft.com/office/drawing/2014/main" id="{A819F89C-046D-44DE-5E9C-781D4F716B94}"/>
+                <a16:creationId xmlns:a16="http://schemas.microsoft.com/office/drawing/2014/main" id="{61CB30EA-85EE-DC45-F7E9-8D3DE1368C8B}"/>
               </a:ext>
             </a:extLst>
           </p:cNvPr>
@@ -6391,7 +6392,7 @@
                 </a:solidFill>
                 <a:latin typeface="Aptos Display" panose="020B0004020202020204" pitchFamily="34" charset="0"/>
               </a:rPr>
-              <a:t>Selective product</a:t>
+              <a:t>Support + interop</a:t>
             </a:r>
           </a:p>
         </p:txBody>
@@ -6401,7 +6402,7 @@
           <p:cNvPr id="19" name="TextBox 18">
             <a:extLst>
               <a:ext uri="{FF2B5EF4-FFF2-40B4-BE49-F238E27FC236}">
-                <a16:creationId xmlns:a16="http://schemas.microsoft.com/office/drawing/2014/main" id="{EF4DC7AA-6469-3EBB-ABED-FC88028FAA7B}"/>
+                <a16:creationId xmlns:a16="http://schemas.microsoft.com/office/drawing/2014/main" id="{56BAF489-E5E2-8500-4FD7-6BA91B1C6943}"/>
               </a:ext>
             </a:extLst>
           </p:cNvPr>
@@ -6431,9 +6432,11 @@
                 </a:solidFill>
                 <a:latin typeface="Aptos" panose="020B0004020202020204" pitchFamily="34" charset="0"/>
               </a:rPr>
-              <a:t>Supported capabilities
-Renewable profiles
-SLAs + outcomes</a:t>
+              <a:t>Platforms + ABI
+Ownership + allocation
+Panic/error + threading
+Debugging + deployment
+Rollback + audit + support</a:t>
             </a:r>
           </a:p>
         </p:txBody>
@@ -6443,7 +6446,7 @@
           <p:cNvPr id="20" name="Straight Connector 19">
             <a:extLst>
               <a:ext uri="{FF2B5EF4-FFF2-40B4-BE49-F238E27FC236}">
-                <a16:creationId xmlns:a16="http://schemas.microsoft.com/office/drawing/2014/main" id="{9E17F0DC-89D0-F5B0-56C2-4694E9B8A002}"/>
+                <a16:creationId xmlns:a16="http://schemas.microsoft.com/office/drawing/2014/main" id="{B10E7B51-BACC-C5D0-2649-750F718890F9}"/>
               </a:ext>
             </a:extLst>
           </p:cNvPr>
@@ -6484,7 +6487,7 @@
           <p:cNvPr id="21" name="Oval 20">
             <a:extLst>
               <a:ext uri="{FF2B5EF4-FFF2-40B4-BE49-F238E27FC236}">
-                <a16:creationId xmlns:a16="http://schemas.microsoft.com/office/drawing/2014/main" id="{9D5ABB1B-795C-3101-64A3-BC54F54E60FB}"/>
+                <a16:creationId xmlns:a16="http://schemas.microsoft.com/office/drawing/2014/main" id="{5B6520C0-E27A-CD15-9BD4-B161C9DB0D04}"/>
               </a:ext>
             </a:extLst>
           </p:cNvPr>
@@ -6545,7 +6548,7 @@
           <p:cNvPr id="22" name="Oval 21">
             <a:extLst>
               <a:ext uri="{FF2B5EF4-FFF2-40B4-BE49-F238E27FC236}">
-                <a16:creationId xmlns:a16="http://schemas.microsoft.com/office/drawing/2014/main" id="{EFF96A94-DACF-30FD-C374-4367BEAF178D}"/>
+                <a16:creationId xmlns:a16="http://schemas.microsoft.com/office/drawing/2014/main" id="{A154A8D2-B182-0BFC-BE40-F47667F3F5B7}"/>
               </a:ext>
             </a:extLst>
           </p:cNvPr>
@@ -6606,7 +6609,7 @@
           <p:cNvPr id="23" name="Oval 22">
             <a:extLst>
               <a:ext uri="{FF2B5EF4-FFF2-40B4-BE49-F238E27FC236}">
-                <a16:creationId xmlns:a16="http://schemas.microsoft.com/office/drawing/2014/main" id="{337071DE-7E99-F91F-34C3-C5F252F90A2F}"/>
+                <a16:creationId xmlns:a16="http://schemas.microsoft.com/office/drawing/2014/main" id="{7637CFC8-A98E-D44C-13BA-93E9144B1F74}"/>
               </a:ext>
             </a:extLst>
           </p:cNvPr>
@@ -6667,7 +6670,7 @@
           <p:cNvPr id="24" name="Oval 23">
             <a:extLst>
               <a:ext uri="{FF2B5EF4-FFF2-40B4-BE49-F238E27FC236}">
-                <a16:creationId xmlns:a16="http://schemas.microsoft.com/office/drawing/2014/main" id="{BCC7784A-A2CB-7F83-70D4-BE1031CC4DFF}"/>
+                <a16:creationId xmlns:a16="http://schemas.microsoft.com/office/drawing/2014/main" id="{651A3554-5CDE-A337-35FD-BB514B47EE6B}"/>
               </a:ext>
             </a:extLst>
           </p:cNvPr>
@@ -6728,7 +6731,7 @@
           <p:cNvPr id="25" name="Oval 24">
             <a:extLst>
               <a:ext uri="{FF2B5EF4-FFF2-40B4-BE49-F238E27FC236}">
-                <a16:creationId xmlns:a16="http://schemas.microsoft.com/office/drawing/2014/main" id="{54CB53BC-BCCF-FECA-02B2-889132754C90}"/>
+                <a16:creationId xmlns:a16="http://schemas.microsoft.com/office/drawing/2014/main" id="{F2E32D6B-ECC8-D27F-9D6C-351988BA6BFC}"/>
               </a:ext>
             </a:extLst>
           </p:cNvPr>
@@ -6789,7 +6792,7 @@
           <p:cNvPr id="26" name="TextBox 25">
             <a:extLst>
               <a:ext uri="{FF2B5EF4-FFF2-40B4-BE49-F238E27FC236}">
-                <a16:creationId xmlns:a16="http://schemas.microsoft.com/office/drawing/2014/main" id="{F01FBB28-9BBB-CC8F-EB53-6238A5610B5E}"/>
+                <a16:creationId xmlns:a16="http://schemas.microsoft.com/office/drawing/2014/main" id="{5E5A82DA-4F0E-BCFC-C365-2140C9107600}"/>
               </a:ext>
             </a:extLst>
           </p:cNvPr>
@@ -6819,7 +6822,7 @@
                 </a:solidFill>
                 <a:latin typeface="Aptos" panose="020B0004020202020204" pitchFamily="34" charset="0"/>
               </a:rPr>
-              <a:t>Stage gates: named owner demand, measurable value, cross-platform proof, policy safety, rollback, and removal.</a:t>
+              <a:t>A later gate opens only after the preceding evidence passes owner review.</a:t>
             </a:r>
           </a:p>
         </p:txBody>
@@ -6829,7 +6832,7 @@
           <p:cNvPr id="27" name="TextBox 26">
             <a:extLst>
               <a:ext uri="{FF2B5EF4-FFF2-40B4-BE49-F238E27FC236}">
-                <a16:creationId xmlns:a16="http://schemas.microsoft.com/office/drawing/2014/main" id="{43733792-6206-3F6B-5E7F-5C36AED7824C}"/>
+                <a16:creationId xmlns:a16="http://schemas.microsoft.com/office/drawing/2014/main" id="{08C4AF8F-595F-D21E-B4E6-B0A7110740E7}"/>
               </a:ext>
             </a:extLst>
           </p:cNvPr>
@@ -6868,7 +6871,7 @@
     </p:spTree>
     <p:extLst>
       <p:ext uri="{BB962C8B-B14F-4D97-AF65-F5344CB8AC3E}">
-        <p14:creationId xmlns:p14="http://schemas.microsoft.com/office/powerpoint/2010/main" val="965504574"/>
+        <p14:creationId xmlns:p14="http://schemas.microsoft.com/office/powerpoint/2010/main" val="2838398686"/>
       </p:ext>
     </p:extLst>
   </p:cSld>
@@ -6881,6 +6884,14 @@
 <file path=ppt/slides/slide12.xml><?xml version="1.0" encoding="utf-8"?>
 <p:sld xmlns:a="http://schemas.openxmlformats.org/drawingml/2006/main" xmlns:r="http://schemas.openxmlformats.org/officeDocument/2006/relationships" xmlns:p="http://schemas.openxmlformats.org/presentationml/2006/main">
   <p:cSld>
+    <p:bg>
+      <p:bgPr>
+        <a:solidFill>
+          <a:srgbClr val="10212D"/>
+        </a:solidFill>
+        <a:effectLst/>
+      </p:bgPr>
+    </p:bg>
     <p:spTree>
       <p:nvGrpSpPr>
         <p:cNvPr id="1" name=""/>
@@ -6900,7 +6911,7 @@
           <p:cNvPr id="2" name="TextBox 1">
             <a:extLst>
               <a:ext uri="{FF2B5EF4-FFF2-40B4-BE49-F238E27FC236}">
-                <a16:creationId xmlns:a16="http://schemas.microsoft.com/office/drawing/2014/main" id="{B356C25B-068B-3F3D-5C92-5E317E5328F5}"/>
+                <a16:creationId xmlns:a16="http://schemas.microsoft.com/office/drawing/2014/main" id="{BB48751F-C99D-E3FB-06D2-CC53294FB720}"/>
               </a:ext>
             </a:extLst>
           </p:cNvPr>
@@ -6940,7 +6951,7 @@
           <p:cNvPr id="3" name="TextBox 2">
             <a:extLst>
               <a:ext uri="{FF2B5EF4-FFF2-40B4-BE49-F238E27FC236}">
-                <a16:creationId xmlns:a16="http://schemas.microsoft.com/office/drawing/2014/main" id="{CB747047-72ED-A071-80D0-E627C974EFF1}"/>
+                <a16:creationId xmlns:a16="http://schemas.microsoft.com/office/drawing/2014/main" id="{CAAC1860-D5B5-C5CF-874B-30E924702430}"/>
               </a:ext>
             </a:extLst>
           </p:cNvPr>
@@ -6970,7 +6981,7 @@
                 </a:solidFill>
                 <a:latin typeface="Aptos Display" panose="020B0004020202020204" pitchFamily="34" charset="0"/>
               </a:rPr>
-              <a:t>Sponsor the application strategy -- not another isolated Rust tool</a:t>
+              <a:t>Fund the evidence needed for a platform decision</a:t>
             </a:r>
           </a:p>
         </p:txBody>
@@ -6980,7 +6991,7 @@
           <p:cNvPr id="4" name="Rectangle: Rounded Corners 3">
             <a:extLst>
               <a:ext uri="{FF2B5EF4-FFF2-40B4-BE49-F238E27FC236}">
-                <a16:creationId xmlns:a16="http://schemas.microsoft.com/office/drawing/2014/main" id="{3918C57D-6B2B-3D13-D5B5-E481377ACACE}"/>
+                <a16:creationId xmlns:a16="http://schemas.microsoft.com/office/drawing/2014/main" id="{6FFAF243-1B74-D102-5D3C-F939E6FC8A3A}"/>
               </a:ext>
             </a:extLst>
           </p:cNvPr>
@@ -7040,7 +7051,7 @@
           <p:cNvPr id="5" name="Oval 4">
             <a:extLst>
               <a:ext uri="{FF2B5EF4-FFF2-40B4-BE49-F238E27FC236}">
-                <a16:creationId xmlns:a16="http://schemas.microsoft.com/office/drawing/2014/main" id="{136959B5-85A5-EFCB-8966-B7447A708DC7}"/>
+                <a16:creationId xmlns:a16="http://schemas.microsoft.com/office/drawing/2014/main" id="{978C53E5-9773-1A49-C5F8-AE8261D630E1}"/>
               </a:ext>
             </a:extLst>
           </p:cNvPr>
@@ -7101,7 +7112,7 @@
           <p:cNvPr id="6" name="TextBox 5">
             <a:extLst>
               <a:ext uri="{FF2B5EF4-FFF2-40B4-BE49-F238E27FC236}">
-                <a16:creationId xmlns:a16="http://schemas.microsoft.com/office/drawing/2014/main" id="{123DD072-E1DF-A1F3-C8A9-5488DB18EFDA}"/>
+                <a16:creationId xmlns:a16="http://schemas.microsoft.com/office/drawing/2014/main" id="{CD433FC7-E244-FF93-1DD6-C73531D219C4}"/>
               </a:ext>
             </a:extLst>
           </p:cNvPr>
@@ -7142,7 +7153,7 @@
           <p:cNvPr id="7" name="TextBox 6">
             <a:extLst>
               <a:ext uri="{FF2B5EF4-FFF2-40B4-BE49-F238E27FC236}">
-                <a16:creationId xmlns:a16="http://schemas.microsoft.com/office/drawing/2014/main" id="{B295A2EF-C339-679F-7EAC-EEC62EFE9D48}"/>
+                <a16:creationId xmlns:a16="http://schemas.microsoft.com/office/drawing/2014/main" id="{082F2588-8B59-8FAF-31C4-4C695F2ADBF4}"/>
               </a:ext>
             </a:extLst>
           </p:cNvPr>
@@ -7172,7 +7183,7 @@
                 </a:solidFill>
                 <a:latin typeface="Aptos" panose="020B0004020202020204" pitchFamily="34" charset="0"/>
               </a:rPr>
-              <a:t>Sponsor one six-month application proof</a:t>
+              <a:t>Name one accountable sponsor and one application owner</a:t>
             </a:r>
           </a:p>
         </p:txBody>
@@ -7182,7 +7193,7 @@
           <p:cNvPr id="8" name="Rectangle: Rounded Corners 7">
             <a:extLst>
               <a:ext uri="{FF2B5EF4-FFF2-40B4-BE49-F238E27FC236}">
-                <a16:creationId xmlns:a16="http://schemas.microsoft.com/office/drawing/2014/main" id="{0511C7D8-D97A-4323-9454-BCD736214E96}"/>
+                <a16:creationId xmlns:a16="http://schemas.microsoft.com/office/drawing/2014/main" id="{73DCC322-F3DB-49E7-37DE-0D5AB3448376}"/>
               </a:ext>
             </a:extLst>
           </p:cNvPr>
@@ -7242,7 +7253,7 @@
           <p:cNvPr id="9" name="Oval 8">
             <a:extLst>
               <a:ext uri="{FF2B5EF4-FFF2-40B4-BE49-F238E27FC236}">
-                <a16:creationId xmlns:a16="http://schemas.microsoft.com/office/drawing/2014/main" id="{D8616F55-D808-3376-54F4-995147D7AF1E}"/>
+                <a16:creationId xmlns:a16="http://schemas.microsoft.com/office/drawing/2014/main" id="{1C635E84-0F0A-4097-8738-835A4DBDDA17}"/>
               </a:ext>
             </a:extLst>
           </p:cNvPr>
@@ -7303,7 +7314,7 @@
           <p:cNvPr id="10" name="TextBox 9">
             <a:extLst>
               <a:ext uri="{FF2B5EF4-FFF2-40B4-BE49-F238E27FC236}">
-                <a16:creationId xmlns:a16="http://schemas.microsoft.com/office/drawing/2014/main" id="{7B9E3AFA-6847-4E4F-B491-B6BE8264F037}"/>
+                <a16:creationId xmlns:a16="http://schemas.microsoft.com/office/drawing/2014/main" id="{42A65E01-C4F1-669E-C525-5FF013276CB1}"/>
               </a:ext>
             </a:extLst>
           </p:cNvPr>
@@ -7344,7 +7355,7 @@
           <p:cNvPr id="11" name="TextBox 10">
             <a:extLst>
               <a:ext uri="{FF2B5EF4-FFF2-40B4-BE49-F238E27FC236}">
-                <a16:creationId xmlns:a16="http://schemas.microsoft.com/office/drawing/2014/main" id="{C2D59C9B-C24C-A55A-AE56-B75031679CB3}"/>
+                <a16:creationId xmlns:a16="http://schemas.microsoft.com/office/drawing/2014/main" id="{5B5DFB28-5716-301C-E473-8C34E45FACB8}"/>
               </a:ext>
             </a:extLst>
           </p:cNvPr>
@@ -7374,7 +7385,7 @@
                 </a:solidFill>
                 <a:latin typeface="Aptos" panose="020B0004020202020204" pitchFamily="34" charset="0"/>
               </a:rPr>
-              <a:t>Name one systems application + GitHub/Copilot workflow</a:t>
+              <a:t>Authorize one preflight-qualified value cohort, one attempt maximum</a:t>
             </a:r>
           </a:p>
         </p:txBody>
@@ -7384,7 +7395,7 @@
           <p:cNvPr id="12" name="Rectangle: Rounded Corners 11">
             <a:extLst>
               <a:ext uri="{FF2B5EF4-FFF2-40B4-BE49-F238E27FC236}">
-                <a16:creationId xmlns:a16="http://schemas.microsoft.com/office/drawing/2014/main" id="{15735BE8-0D98-5201-58E3-FDAF2365F241}"/>
+                <a16:creationId xmlns:a16="http://schemas.microsoft.com/office/drawing/2014/main" id="{92BB714F-395F-9D8F-552E-DEDE63BC3C29}"/>
               </a:ext>
             </a:extLst>
           </p:cNvPr>
@@ -7444,7 +7455,7 @@
           <p:cNvPr id="13" name="Oval 12">
             <a:extLst>
               <a:ext uri="{FF2B5EF4-FFF2-40B4-BE49-F238E27FC236}">
-                <a16:creationId xmlns:a16="http://schemas.microsoft.com/office/drawing/2014/main" id="{0E064558-BB20-65EE-00BA-91B13F27D864}"/>
+                <a16:creationId xmlns:a16="http://schemas.microsoft.com/office/drawing/2014/main" id="{17AFED7E-89C7-2F00-6981-36E6C9A82545}"/>
               </a:ext>
             </a:extLst>
           </p:cNvPr>
@@ -7505,7 +7516,7 @@
           <p:cNvPr id="14" name="TextBox 13">
             <a:extLst>
               <a:ext uri="{FF2B5EF4-FFF2-40B4-BE49-F238E27FC236}">
-                <a16:creationId xmlns:a16="http://schemas.microsoft.com/office/drawing/2014/main" id="{DF3DCB0A-BED7-166A-26A2-4BB11DC96FDC}"/>
+                <a16:creationId xmlns:a16="http://schemas.microsoft.com/office/drawing/2014/main" id="{A6FC56FA-9698-A792-3944-230963F7BC39}"/>
               </a:ext>
             </a:extLst>
           </p:cNvPr>
@@ -7546,7 +7557,7 @@
           <p:cNvPr id="15" name="TextBox 14">
             <a:extLst>
               <a:ext uri="{FF2B5EF4-FFF2-40B4-BE49-F238E27FC236}">
-                <a16:creationId xmlns:a16="http://schemas.microsoft.com/office/drawing/2014/main" id="{894D090D-FE48-AECA-0635-A564B80D147E}"/>
+                <a16:creationId xmlns:a16="http://schemas.microsoft.com/office/drawing/2014/main" id="{CDF4FCF4-FB56-75CA-C528-EF3ED82A86F8}"/>
               </a:ext>
             </a:extLst>
           </p:cNvPr>
@@ -7576,7 +7587,7 @@
                 </a:solidFill>
                 <a:latin typeface="Aptos" panose="020B0004020202020204" pitchFamily="34" charset="0"/>
               </a:rPr>
-              <a:t>Privacy-safe Rust estate census</a:t>
+              <a:t>Authorize an advisory CI shadow only after Gate 2 passes</a:t>
             </a:r>
           </a:p>
         </p:txBody>
@@ -7586,7 +7597,7 @@
           <p:cNvPr id="16" name="Rectangle: Rounded Corners 15">
             <a:extLst>
               <a:ext uri="{FF2B5EF4-FFF2-40B4-BE49-F238E27FC236}">
-                <a16:creationId xmlns:a16="http://schemas.microsoft.com/office/drawing/2014/main" id="{84D5E16A-115C-10B4-7E57-1C3F82584328}"/>
+                <a16:creationId xmlns:a16="http://schemas.microsoft.com/office/drawing/2014/main" id="{461DC86D-DFDA-517E-4386-9E6F2FD665D3}"/>
               </a:ext>
             </a:extLst>
           </p:cNvPr>
@@ -7646,7 +7657,7 @@
           <p:cNvPr id="17" name="Oval 16">
             <a:extLst>
               <a:ext uri="{FF2B5EF4-FFF2-40B4-BE49-F238E27FC236}">
-                <a16:creationId xmlns:a16="http://schemas.microsoft.com/office/drawing/2014/main" id="{097DCC27-5CA5-952E-EA16-08531B24E190}"/>
+                <a16:creationId xmlns:a16="http://schemas.microsoft.com/office/drawing/2014/main" id="{9FDAD1AE-C151-A11D-CCCB-169C30F457BF}"/>
               </a:ext>
             </a:extLst>
           </p:cNvPr>
@@ -7707,7 +7718,7 @@
           <p:cNvPr id="18" name="TextBox 17">
             <a:extLst>
               <a:ext uri="{FF2B5EF4-FFF2-40B4-BE49-F238E27FC236}">
-                <a16:creationId xmlns:a16="http://schemas.microsoft.com/office/drawing/2014/main" id="{98E4CED8-1E79-D694-CBE1-4B1E68139878}"/>
+                <a16:creationId xmlns:a16="http://schemas.microsoft.com/office/drawing/2014/main" id="{CD0D02DE-F667-C09B-67CC-02B6ED898E60}"/>
               </a:ext>
             </a:extLst>
           </p:cNvPr>
@@ -7748,7 +7759,7 @@
           <p:cNvPr id="19" name="TextBox 18">
             <a:extLst>
               <a:ext uri="{FF2B5EF4-FFF2-40B4-BE49-F238E27FC236}">
-                <a16:creationId xmlns:a16="http://schemas.microsoft.com/office/drawing/2014/main" id="{34118DB8-CEEC-1245-2D35-3480ECD6B479}"/>
+                <a16:creationId xmlns:a16="http://schemas.microsoft.com/office/drawing/2014/main" id="{4817AFF4-2A6B-F9DA-E1C0-4CA20AFFE20B}"/>
               </a:ext>
             </a:extLst>
           </p:cNvPr>
@@ -7778,7 +7789,7 @@
                 </a:solidFill>
                 <a:latin typeface="Aptos" panose="020B0004020202020204" pitchFamily="34" charset="0"/>
               </a:rPr>
-              <a:t>Dedicated upstream liaison + maintainer funding</a:t>
+              <a:t>Complete the Microsoft Rust estate and economic baseline</a:t>
             </a:r>
           </a:p>
         </p:txBody>
@@ -7788,7 +7799,7 @@
           <p:cNvPr id="20" name="Rectangle: Rounded Corners 19">
             <a:extLst>
               <a:ext uri="{FF2B5EF4-FFF2-40B4-BE49-F238E27FC236}">
-                <a16:creationId xmlns:a16="http://schemas.microsoft.com/office/drawing/2014/main" id="{6965D5C8-D094-7440-D8F0-32533BF80ABE}"/>
+                <a16:creationId xmlns:a16="http://schemas.microsoft.com/office/drawing/2014/main" id="{307D30B8-C3DE-06DD-903E-F190354988D7}"/>
               </a:ext>
             </a:extLst>
           </p:cNvPr>
@@ -7848,7 +7859,7 @@
           <p:cNvPr id="21" name="Oval 20">
             <a:extLst>
               <a:ext uri="{FF2B5EF4-FFF2-40B4-BE49-F238E27FC236}">
-                <a16:creationId xmlns:a16="http://schemas.microsoft.com/office/drawing/2014/main" id="{7E3A3165-B374-A234-A06B-1A1D80931F4A}"/>
+                <a16:creationId xmlns:a16="http://schemas.microsoft.com/office/drawing/2014/main" id="{9178C275-8B67-E7C1-0B86-F4D671463031}"/>
               </a:ext>
             </a:extLst>
           </p:cNvPr>
@@ -7909,7 +7920,7 @@
           <p:cNvPr id="22" name="TextBox 21">
             <a:extLst>
               <a:ext uri="{FF2B5EF4-FFF2-40B4-BE49-F238E27FC236}">
-                <a16:creationId xmlns:a16="http://schemas.microsoft.com/office/drawing/2014/main" id="{8D1923C2-BCC1-3049-3237-07B322F5675A}"/>
+                <a16:creationId xmlns:a16="http://schemas.microsoft.com/office/drawing/2014/main" id="{A96BD477-B413-DCC6-0978-CDCB1F80316D}"/>
               </a:ext>
             </a:extLst>
           </p:cNvPr>
@@ -7950,7 +7961,7 @@
           <p:cNvPr id="23" name="TextBox 22">
             <a:extLst>
               <a:ext uri="{FF2B5EF4-FFF2-40B4-BE49-F238E27FC236}">
-                <a16:creationId xmlns:a16="http://schemas.microsoft.com/office/drawing/2014/main" id="{7126E334-53DE-3019-46DD-46D463A46DAF}"/>
+                <a16:creationId xmlns:a16="http://schemas.microsoft.com/office/drawing/2014/main" id="{8D7DC819-BEB9-7211-31A6-535869D5E9F0}"/>
               </a:ext>
             </a:extLst>
           </p:cNvPr>
@@ -7980,7 +7991,7 @@
                 </a:solidFill>
                 <a:latin typeface="Aptos" panose="020B0004020202020204" pitchFamily="34" charset="0"/>
               </a:rPr>
-              <a:t>Require Windows/Linux, rollback, removal, and a null-case gate</a:t>
+              <a:t>Define support, interop, rollback, audit, and an explicit exit path</a:t>
             </a:r>
           </a:p>
         </p:txBody>
@@ -7990,7 +8001,7 @@
           <p:cNvPr id="24" name="Rectangle: Rounded Corners 23">
             <a:extLst>
               <a:ext uri="{FF2B5EF4-FFF2-40B4-BE49-F238E27FC236}">
-                <a16:creationId xmlns:a16="http://schemas.microsoft.com/office/drawing/2014/main" id="{42B05CAE-BC1D-5A20-2D7A-D58D87B208FA}"/>
+                <a16:creationId xmlns:a16="http://schemas.microsoft.com/office/drawing/2014/main" id="{3E0B176F-7D77-52D0-5F17-F82F900C8316}"/>
               </a:ext>
             </a:extLst>
           </p:cNvPr>
@@ -8050,7 +8061,7 @@
           <p:cNvPr id="25" name="TextBox 24">
             <a:extLst>
               <a:ext uri="{FF2B5EF4-FFF2-40B4-BE49-F238E27FC236}">
-                <a16:creationId xmlns:a16="http://schemas.microsoft.com/office/drawing/2014/main" id="{C898153B-7C7E-1E75-2F69-B2FEF49E3411}"/>
+                <a16:creationId xmlns:a16="http://schemas.microsoft.com/office/drawing/2014/main" id="{A7CAA8F0-B45E-4AE4-BD48-8A7B7F71183E}"/>
               </a:ext>
             </a:extLst>
           </p:cNvPr>
@@ -8081,7 +8092,7 @@
                 </a:solidFill>
                 <a:latin typeface="Aptos" panose="020B0004020202020204" pitchFamily="34" charset="0"/>
               </a:rPr>
-              <a:t>Grab the moment: align the workspaces, crates, contracts, and applications before fragmentation hardens.</a:t>
+              <a:t>Stop after an invalid, divergent, or nonpositive cohort. Platform funding remains gated.</a:t>
             </a:r>
           </a:p>
         </p:txBody>
@@ -8089,7 +8100,7 @@
     </p:spTree>
     <p:extLst>
       <p:ext uri="{BB962C8B-B14F-4D97-AF65-F5344CB8AC3E}">
-        <p14:creationId xmlns:p14="http://schemas.microsoft.com/office/powerpoint/2010/main" val="1537845852"/>
+        <p14:creationId xmlns:p14="http://schemas.microsoft.com/office/powerpoint/2010/main" val="2491577701"/>
       </p:ext>
     </p:extLst>
   </p:cSld>
@@ -8121,7 +8132,7 @@
           <p:cNvPr id="2" name="TextBox 1">
             <a:extLst>
               <a:ext uri="{FF2B5EF4-FFF2-40B4-BE49-F238E27FC236}">
-                <a16:creationId xmlns:a16="http://schemas.microsoft.com/office/drawing/2014/main" id="{3B95EB8C-4AFE-9DFB-147E-DF9CA6C5BB82}"/>
+                <a16:creationId xmlns:a16="http://schemas.microsoft.com/office/drawing/2014/main" id="{BFF3F994-CA70-3202-93E5-14D15F7D6752}"/>
               </a:ext>
             </a:extLst>
           </p:cNvPr>
@@ -8161,7 +8172,7 @@
           <p:cNvPr id="3" name="TextBox 2">
             <a:extLst>
               <a:ext uri="{FF2B5EF4-FFF2-40B4-BE49-F238E27FC236}">
-                <a16:creationId xmlns:a16="http://schemas.microsoft.com/office/drawing/2014/main" id="{D01531CA-48CC-5670-961D-9AAB1AD922F7}"/>
+                <a16:creationId xmlns:a16="http://schemas.microsoft.com/office/drawing/2014/main" id="{FD62DF49-FA7F-2B0D-FCB7-3F3AD4233D8C}"/>
               </a:ext>
             </a:extLst>
           </p:cNvPr>
@@ -8201,7 +8212,7 @@
           <p:cNvPr id="4" name="Rectangle: Rounded Corners 3">
             <a:extLst>
               <a:ext uri="{FF2B5EF4-FFF2-40B4-BE49-F238E27FC236}">
-                <a16:creationId xmlns:a16="http://schemas.microsoft.com/office/drawing/2014/main" id="{A3C1081C-0CD4-18F2-0056-5DBCE836655E}"/>
+                <a16:creationId xmlns:a16="http://schemas.microsoft.com/office/drawing/2014/main" id="{3597223E-4F9D-1066-7D58-24C4BB633C8A}"/>
               </a:ext>
             </a:extLst>
           </p:cNvPr>
@@ -8259,7 +8270,7 @@
           <p:cNvPr id="5" name="TextBox 4">
             <a:extLst>
               <a:ext uri="{FF2B5EF4-FFF2-40B4-BE49-F238E27FC236}">
-                <a16:creationId xmlns:a16="http://schemas.microsoft.com/office/drawing/2014/main" id="{4D98B17B-3C05-4051-019F-F41B8C9EBBF6}"/>
+                <a16:creationId xmlns:a16="http://schemas.microsoft.com/office/drawing/2014/main" id="{BFCD4CBD-4620-FF09-1748-8A9C036DB537}"/>
               </a:ext>
             </a:extLst>
           </p:cNvPr>
@@ -8299,7 +8310,7 @@
           <p:cNvPr id="6" name="TextBox 5">
             <a:extLst>
               <a:ext uri="{FF2B5EF4-FFF2-40B4-BE49-F238E27FC236}">
-                <a16:creationId xmlns:a16="http://schemas.microsoft.com/office/drawing/2014/main" id="{1E01E488-BEBE-976F-BEF2-1422C84E9F5B}"/>
+                <a16:creationId xmlns:a16="http://schemas.microsoft.com/office/drawing/2014/main" id="{5562275F-4381-ECAD-CE9A-9DC51355183C}"/>
               </a:ext>
             </a:extLst>
           </p:cNvPr>
@@ -8339,7 +8350,7 @@
           <p:cNvPr id="7" name="TextBox 6">
             <a:extLst>
               <a:ext uri="{FF2B5EF4-FFF2-40B4-BE49-F238E27FC236}">
-                <a16:creationId xmlns:a16="http://schemas.microsoft.com/office/drawing/2014/main" id="{582D3898-93FA-9AE0-3970-047020F14E5F}"/>
+                <a16:creationId xmlns:a16="http://schemas.microsoft.com/office/drawing/2014/main" id="{7C40086E-A137-FC66-F35F-B8D6E3635A79}"/>
               </a:ext>
             </a:extLst>
           </p:cNvPr>
@@ -8379,7 +8390,7 @@
           <p:cNvPr id="8" name="Rectangle: Rounded Corners 7">
             <a:extLst>
               <a:ext uri="{FF2B5EF4-FFF2-40B4-BE49-F238E27FC236}">
-                <a16:creationId xmlns:a16="http://schemas.microsoft.com/office/drawing/2014/main" id="{00817436-92F8-CA1C-7319-9C0FE156602A}"/>
+                <a16:creationId xmlns:a16="http://schemas.microsoft.com/office/drawing/2014/main" id="{0FE65388-2036-9A41-AEAB-B99F98F9C01B}"/>
               </a:ext>
             </a:extLst>
           </p:cNvPr>
@@ -8437,7 +8448,7 @@
           <p:cNvPr id="9" name="TextBox 8">
             <a:extLst>
               <a:ext uri="{FF2B5EF4-FFF2-40B4-BE49-F238E27FC236}">
-                <a16:creationId xmlns:a16="http://schemas.microsoft.com/office/drawing/2014/main" id="{6A177AE2-B284-8CC2-3FE4-6A03F08B1A7D}"/>
+                <a16:creationId xmlns:a16="http://schemas.microsoft.com/office/drawing/2014/main" id="{23E1C1B5-0904-AC33-41FD-413491140D8A}"/>
               </a:ext>
             </a:extLst>
           </p:cNvPr>
@@ -8477,7 +8488,7 @@
           <p:cNvPr id="10" name="TextBox 9">
             <a:extLst>
               <a:ext uri="{FF2B5EF4-FFF2-40B4-BE49-F238E27FC236}">
-                <a16:creationId xmlns:a16="http://schemas.microsoft.com/office/drawing/2014/main" id="{9F0A1872-FCD7-FDF0-7B69-B87FDA82EDBC}"/>
+                <a16:creationId xmlns:a16="http://schemas.microsoft.com/office/drawing/2014/main" id="{2BEC15CD-C030-D99E-BB9B-D7D09A076B05}"/>
               </a:ext>
             </a:extLst>
           </p:cNvPr>
@@ -8517,7 +8528,7 @@
           <p:cNvPr id="11" name="TextBox 10">
             <a:extLst>
               <a:ext uri="{FF2B5EF4-FFF2-40B4-BE49-F238E27FC236}">
-                <a16:creationId xmlns:a16="http://schemas.microsoft.com/office/drawing/2014/main" id="{889F3A38-A9F8-F406-A889-49E17760B9AA}"/>
+                <a16:creationId xmlns:a16="http://schemas.microsoft.com/office/drawing/2014/main" id="{8DEC9D94-629E-AFE2-1FEB-FB3CF31CE3B2}"/>
               </a:ext>
             </a:extLst>
           </p:cNvPr>
@@ -8557,7 +8568,7 @@
           <p:cNvPr id="12" name="Rectangle: Rounded Corners 11">
             <a:extLst>
               <a:ext uri="{FF2B5EF4-FFF2-40B4-BE49-F238E27FC236}">
-                <a16:creationId xmlns:a16="http://schemas.microsoft.com/office/drawing/2014/main" id="{AB639555-80D4-7466-69B8-354C0AB1B89A}"/>
+                <a16:creationId xmlns:a16="http://schemas.microsoft.com/office/drawing/2014/main" id="{164EA5CE-B745-D151-B718-AC6B905D98A9}"/>
               </a:ext>
             </a:extLst>
           </p:cNvPr>
@@ -8615,7 +8626,7 @@
           <p:cNvPr id="13" name="TextBox 12">
             <a:extLst>
               <a:ext uri="{FF2B5EF4-FFF2-40B4-BE49-F238E27FC236}">
-                <a16:creationId xmlns:a16="http://schemas.microsoft.com/office/drawing/2014/main" id="{D01182C1-BC58-5E0F-DFFF-1125842E7971}"/>
+                <a16:creationId xmlns:a16="http://schemas.microsoft.com/office/drawing/2014/main" id="{6DBD0F64-79BF-FDA4-CA06-952F561BF8B2}"/>
               </a:ext>
             </a:extLst>
           </p:cNvPr>
@@ -8655,7 +8666,7 @@
           <p:cNvPr id="14" name="TextBox 13">
             <a:extLst>
               <a:ext uri="{FF2B5EF4-FFF2-40B4-BE49-F238E27FC236}">
-                <a16:creationId xmlns:a16="http://schemas.microsoft.com/office/drawing/2014/main" id="{F002F391-C6E8-6A66-3FB1-F7F6F1080C8C}"/>
+                <a16:creationId xmlns:a16="http://schemas.microsoft.com/office/drawing/2014/main" id="{C42D196C-8DBE-00AE-860A-BDE860FD9133}"/>
               </a:ext>
             </a:extLst>
           </p:cNvPr>
@@ -8695,7 +8706,7 @@
           <p:cNvPr id="15" name="TextBox 14">
             <a:extLst>
               <a:ext uri="{FF2B5EF4-FFF2-40B4-BE49-F238E27FC236}">
-                <a16:creationId xmlns:a16="http://schemas.microsoft.com/office/drawing/2014/main" id="{21EB5F54-E7F9-AE1D-47BF-D8B56D24064A}"/>
+                <a16:creationId xmlns:a16="http://schemas.microsoft.com/office/drawing/2014/main" id="{C6AEB5F4-8ED9-7A37-DA0D-E887E15AABD3}"/>
               </a:ext>
             </a:extLst>
           </p:cNvPr>
@@ -8735,7 +8746,7 @@
           <p:cNvPr id="16" name="Rectangle: Rounded Corners 15">
             <a:extLst>
               <a:ext uri="{FF2B5EF4-FFF2-40B4-BE49-F238E27FC236}">
-                <a16:creationId xmlns:a16="http://schemas.microsoft.com/office/drawing/2014/main" id="{B2D54355-760F-7F9E-C127-DD883E3C2034}"/>
+                <a16:creationId xmlns:a16="http://schemas.microsoft.com/office/drawing/2014/main" id="{6358DCCA-2E7C-6CF5-F4C5-369D634949B8}"/>
               </a:ext>
             </a:extLst>
           </p:cNvPr>
@@ -8793,7 +8804,7 @@
           <p:cNvPr id="17" name="TextBox 16">
             <a:extLst>
               <a:ext uri="{FF2B5EF4-FFF2-40B4-BE49-F238E27FC236}">
-                <a16:creationId xmlns:a16="http://schemas.microsoft.com/office/drawing/2014/main" id="{FFE378B3-7430-C311-290A-C4AB304938F5}"/>
+                <a16:creationId xmlns:a16="http://schemas.microsoft.com/office/drawing/2014/main" id="{2111FEED-D99C-8434-B6D4-533EFD6D0298}"/>
               </a:ext>
             </a:extLst>
           </p:cNvPr>
@@ -8833,7 +8844,7 @@
           <p:cNvPr id="18" name="TextBox 17">
             <a:extLst>
               <a:ext uri="{FF2B5EF4-FFF2-40B4-BE49-F238E27FC236}">
-                <a16:creationId xmlns:a16="http://schemas.microsoft.com/office/drawing/2014/main" id="{C8C5C184-00D7-CA0F-2DCB-7A7BA74CAAF8}"/>
+                <a16:creationId xmlns:a16="http://schemas.microsoft.com/office/drawing/2014/main" id="{D0850696-619C-5674-EE84-C16F7900DA2D}"/>
               </a:ext>
             </a:extLst>
           </p:cNvPr>
@@ -8873,7 +8884,7 @@
           <p:cNvPr id="19" name="TextBox 18">
             <a:extLst>
               <a:ext uri="{FF2B5EF4-FFF2-40B4-BE49-F238E27FC236}">
-                <a16:creationId xmlns:a16="http://schemas.microsoft.com/office/drawing/2014/main" id="{6AD790E1-FDB2-4409-32FF-54E8C17B4773}"/>
+                <a16:creationId xmlns:a16="http://schemas.microsoft.com/office/drawing/2014/main" id="{0BA20A81-9E5D-CA0D-8434-D6A2DF3C1E76}"/>
               </a:ext>
             </a:extLst>
           </p:cNvPr>
@@ -8913,7 +8924,7 @@
           <p:cNvPr id="20" name="Rectangle: Rounded Corners 19">
             <a:extLst>
               <a:ext uri="{FF2B5EF4-FFF2-40B4-BE49-F238E27FC236}">
-                <a16:creationId xmlns:a16="http://schemas.microsoft.com/office/drawing/2014/main" id="{B23F1E06-307C-8B57-D244-50621C80BC98}"/>
+                <a16:creationId xmlns:a16="http://schemas.microsoft.com/office/drawing/2014/main" id="{F9ED8458-6A51-C6A7-1FC4-DDA9AACA7E2C}"/>
               </a:ext>
             </a:extLst>
           </p:cNvPr>
@@ -8973,7 +8984,7 @@
           <p:cNvPr id="21" name="TextBox 20">
             <a:extLst>
               <a:ext uri="{FF2B5EF4-FFF2-40B4-BE49-F238E27FC236}">
-                <a16:creationId xmlns:a16="http://schemas.microsoft.com/office/drawing/2014/main" id="{D12A27CC-9A22-9DE3-D2AA-BC9306279BD1}"/>
+                <a16:creationId xmlns:a16="http://schemas.microsoft.com/office/drawing/2014/main" id="{C12520A4-76C9-629B-9690-5907CE6FD3FA}"/>
               </a:ext>
             </a:extLst>
           </p:cNvPr>
@@ -9013,7 +9024,7 @@
           <p:cNvPr id="22" name="TextBox 21">
             <a:extLst>
               <a:ext uri="{FF2B5EF4-FFF2-40B4-BE49-F238E27FC236}">
-                <a16:creationId xmlns:a16="http://schemas.microsoft.com/office/drawing/2014/main" id="{5E0875D3-E3DB-654E-9DAF-2A9A0BC357DF}"/>
+                <a16:creationId xmlns:a16="http://schemas.microsoft.com/office/drawing/2014/main" id="{FEDDA2FE-7ADB-258D-20DE-D6087CE7AD05}"/>
               </a:ext>
             </a:extLst>
           </p:cNvPr>
@@ -9053,7 +9064,7 @@
           <p:cNvPr id="23" name="TextBox 22">
             <a:extLst>
               <a:ext uri="{FF2B5EF4-FFF2-40B4-BE49-F238E27FC236}">
-                <a16:creationId xmlns:a16="http://schemas.microsoft.com/office/drawing/2014/main" id="{9F9C892E-D3DD-8822-1E47-DB70F1B2C3FC}"/>
+                <a16:creationId xmlns:a16="http://schemas.microsoft.com/office/drawing/2014/main" id="{56426BA6-7292-195B-C9F4-B99206FDF395}"/>
               </a:ext>
             </a:extLst>
           </p:cNvPr>
@@ -9083,7 +9094,7 @@
                 </a:solidFill>
                 <a:latin typeface="Aptos" panose="020B0004020202020204" pitchFamily="34" charset="0"/>
               </a:rPr>
-              <a:t>Sources: Stack Overflow 2024; State of Rust 2025; crates.io public API (observed 2026-08-11).</a:t>
+              <a:t>Claims P-01 to P-04: MICROSOFT_RUST_CLAIM_LEDGER.md.</a:t>
             </a:r>
           </a:p>
         </p:txBody>
@@ -9093,7 +9104,7 @@
           <p:cNvPr id="24" name="TextBox 23">
             <a:extLst>
               <a:ext uri="{FF2B5EF4-FFF2-40B4-BE49-F238E27FC236}">
-                <a16:creationId xmlns:a16="http://schemas.microsoft.com/office/drawing/2014/main" id="{54411895-AE5D-E89A-9813-821F62338B8E}"/>
+                <a16:creationId xmlns:a16="http://schemas.microsoft.com/office/drawing/2014/main" id="{909A25AB-3E0F-1E20-E6A6-F99325D446A0}"/>
               </a:ext>
             </a:extLst>
           </p:cNvPr>
@@ -9132,7 +9143,7 @@
     </p:spTree>
     <p:extLst>
       <p:ext uri="{BB962C8B-B14F-4D97-AF65-F5344CB8AC3E}">
-        <p14:creationId xmlns:p14="http://schemas.microsoft.com/office/powerpoint/2010/main" val="1464473697"/>
+        <p14:creationId xmlns:p14="http://schemas.microsoft.com/office/powerpoint/2010/main" val="3144431686"/>
       </p:ext>
     </p:extLst>
   </p:cSld>
@@ -9164,7 +9175,7 @@
           <p:cNvPr id="2" name="TextBox 1">
             <a:extLst>
               <a:ext uri="{FF2B5EF4-FFF2-40B4-BE49-F238E27FC236}">
-                <a16:creationId xmlns:a16="http://schemas.microsoft.com/office/drawing/2014/main" id="{6C485A25-AE8A-4302-79FB-85D62AB705A1}"/>
+                <a16:creationId xmlns:a16="http://schemas.microsoft.com/office/drawing/2014/main" id="{A7F62D49-68A9-C663-646B-CD82C4DA3BBA}"/>
               </a:ext>
             </a:extLst>
           </p:cNvPr>
@@ -9204,7 +9215,7 @@
           <p:cNvPr id="3" name="TextBox 2">
             <a:extLst>
               <a:ext uri="{FF2B5EF4-FFF2-40B4-BE49-F238E27FC236}">
-                <a16:creationId xmlns:a16="http://schemas.microsoft.com/office/drawing/2014/main" id="{81DECB7E-7105-1B9A-636F-FF231A16E6F4}"/>
+                <a16:creationId xmlns:a16="http://schemas.microsoft.com/office/drawing/2014/main" id="{00F66329-A08F-D1A2-1807-EE2F54DDBB18}"/>
               </a:ext>
             </a:extLst>
           </p:cNvPr>
@@ -9244,7 +9255,7 @@
           <p:cNvPr id="4" name="TextBox 3">
             <a:extLst>
               <a:ext uri="{FF2B5EF4-FFF2-40B4-BE49-F238E27FC236}">
-                <a16:creationId xmlns:a16="http://schemas.microsoft.com/office/drawing/2014/main" id="{6A44856F-D222-5AD5-947A-63925525642A}"/>
+                <a16:creationId xmlns:a16="http://schemas.microsoft.com/office/drawing/2014/main" id="{08D1DB16-387E-D159-7C69-29DAE8FD3E5C}"/>
               </a:ext>
             </a:extLst>
           </p:cNvPr>
@@ -9284,7 +9295,7 @@
           <p:cNvPr id="5" name="Rectangle: Rounded Corners 4">
             <a:extLst>
               <a:ext uri="{FF2B5EF4-FFF2-40B4-BE49-F238E27FC236}">
-                <a16:creationId xmlns:a16="http://schemas.microsoft.com/office/drawing/2014/main" id="{27051B60-13B4-80FC-7C83-19D44C77A478}"/>
+                <a16:creationId xmlns:a16="http://schemas.microsoft.com/office/drawing/2014/main" id="{7A39CE78-8273-32C1-B24B-095FC8BBEEDA}"/>
               </a:ext>
             </a:extLst>
           </p:cNvPr>
@@ -9344,7 +9355,7 @@
           <p:cNvPr id="6" name="Rectangle: Rounded Corners 5">
             <a:extLst>
               <a:ext uri="{FF2B5EF4-FFF2-40B4-BE49-F238E27FC236}">
-                <a16:creationId xmlns:a16="http://schemas.microsoft.com/office/drawing/2014/main" id="{B016B6DE-E725-8985-B35D-005809F69E37}"/>
+                <a16:creationId xmlns:a16="http://schemas.microsoft.com/office/drawing/2014/main" id="{2BC4B122-8435-AC47-F641-656C43AFCA10}"/>
               </a:ext>
             </a:extLst>
           </p:cNvPr>
@@ -9404,7 +9415,7 @@
           <p:cNvPr id="7" name="TextBox 6">
             <a:extLst>
               <a:ext uri="{FF2B5EF4-FFF2-40B4-BE49-F238E27FC236}">
-                <a16:creationId xmlns:a16="http://schemas.microsoft.com/office/drawing/2014/main" id="{68871C16-DCDF-86BF-7492-0B0B10FC9A45}"/>
+                <a16:creationId xmlns:a16="http://schemas.microsoft.com/office/drawing/2014/main" id="{FB5EEFD8-1788-4805-F84D-0B9EEBF6D987}"/>
               </a:ext>
             </a:extLst>
           </p:cNvPr>
@@ -9444,7 +9455,7 @@
           <p:cNvPr id="8" name="TextBox 7">
             <a:extLst>
               <a:ext uri="{FF2B5EF4-FFF2-40B4-BE49-F238E27FC236}">
-                <a16:creationId xmlns:a16="http://schemas.microsoft.com/office/drawing/2014/main" id="{4FA41DB4-2C62-BF03-550B-95EA1F37B341}"/>
+                <a16:creationId xmlns:a16="http://schemas.microsoft.com/office/drawing/2014/main" id="{06F26841-9C3F-1079-BE4B-943886400077}"/>
               </a:ext>
             </a:extLst>
           </p:cNvPr>
@@ -9485,7 +9496,7 @@
           <p:cNvPr id="9" name="Rectangle: Rounded Corners 8">
             <a:extLst>
               <a:ext uri="{FF2B5EF4-FFF2-40B4-BE49-F238E27FC236}">
-                <a16:creationId xmlns:a16="http://schemas.microsoft.com/office/drawing/2014/main" id="{B6039DBD-30B4-0D84-CC16-65A45B8F2BC1}"/>
+                <a16:creationId xmlns:a16="http://schemas.microsoft.com/office/drawing/2014/main" id="{CB534113-21C4-87AC-B861-23EC42244252}"/>
               </a:ext>
             </a:extLst>
           </p:cNvPr>
@@ -9545,7 +9556,7 @@
           <p:cNvPr id="10" name="Rectangle: Rounded Corners 9">
             <a:extLst>
               <a:ext uri="{FF2B5EF4-FFF2-40B4-BE49-F238E27FC236}">
-                <a16:creationId xmlns:a16="http://schemas.microsoft.com/office/drawing/2014/main" id="{82EB0857-067F-71E6-6267-1F01BB06A82D}"/>
+                <a16:creationId xmlns:a16="http://schemas.microsoft.com/office/drawing/2014/main" id="{0E62D6A6-1C30-308F-5311-9949220C943C}"/>
               </a:ext>
             </a:extLst>
           </p:cNvPr>
@@ -9605,7 +9616,7 @@
           <p:cNvPr id="11" name="TextBox 10">
             <a:extLst>
               <a:ext uri="{FF2B5EF4-FFF2-40B4-BE49-F238E27FC236}">
-                <a16:creationId xmlns:a16="http://schemas.microsoft.com/office/drawing/2014/main" id="{A0D2E663-95CA-2C39-F3D0-7EC022154120}"/>
+                <a16:creationId xmlns:a16="http://schemas.microsoft.com/office/drawing/2014/main" id="{D49CE713-8F54-A180-2756-D4FB5A038378}"/>
               </a:ext>
             </a:extLst>
           </p:cNvPr>
@@ -9645,7 +9656,7 @@
           <p:cNvPr id="12" name="TextBox 11">
             <a:extLst>
               <a:ext uri="{FF2B5EF4-FFF2-40B4-BE49-F238E27FC236}">
-                <a16:creationId xmlns:a16="http://schemas.microsoft.com/office/drawing/2014/main" id="{B2684D0F-F47B-00B2-7D4E-682599BEBAD1}"/>
+                <a16:creationId xmlns:a16="http://schemas.microsoft.com/office/drawing/2014/main" id="{79BC2F5E-81BA-3EBC-60E5-018AAFE686D0}"/>
               </a:ext>
             </a:extLst>
           </p:cNvPr>
@@ -9686,7 +9697,7 @@
           <p:cNvPr id="13" name="Rectangle: Rounded Corners 12">
             <a:extLst>
               <a:ext uri="{FF2B5EF4-FFF2-40B4-BE49-F238E27FC236}">
-                <a16:creationId xmlns:a16="http://schemas.microsoft.com/office/drawing/2014/main" id="{77FB932F-A7C8-1AE8-8312-1DA3F23AEA72}"/>
+                <a16:creationId xmlns:a16="http://schemas.microsoft.com/office/drawing/2014/main" id="{FEF04796-A8D7-2E34-8939-B11A23F899B6}"/>
               </a:ext>
             </a:extLst>
           </p:cNvPr>
@@ -9744,7 +9755,7 @@
           <p:cNvPr id="14" name="Rectangle 13">
             <a:extLst>
               <a:ext uri="{FF2B5EF4-FFF2-40B4-BE49-F238E27FC236}">
-                <a16:creationId xmlns:a16="http://schemas.microsoft.com/office/drawing/2014/main" id="{F74842B5-6FFE-2FE4-C548-5A3210E00DAC}"/>
+                <a16:creationId xmlns:a16="http://schemas.microsoft.com/office/drawing/2014/main" id="{B3F3D88C-E5EE-503E-037C-511844FA67B2}"/>
               </a:ext>
             </a:extLst>
           </p:cNvPr>
@@ -9804,7 +9815,7 @@
           <p:cNvPr id="15" name="TextBox 14">
             <a:extLst>
               <a:ext uri="{FF2B5EF4-FFF2-40B4-BE49-F238E27FC236}">
-                <a16:creationId xmlns:a16="http://schemas.microsoft.com/office/drawing/2014/main" id="{301AAE4E-4F99-CEB5-D150-E310D0BF5A82}"/>
+                <a16:creationId xmlns:a16="http://schemas.microsoft.com/office/drawing/2014/main" id="{A7E549DB-2AF0-BE14-9FD1-CD1E0A179C2F}"/>
               </a:ext>
             </a:extLst>
           </p:cNvPr>
@@ -9844,7 +9855,7 @@
           <p:cNvPr id="16" name="TextBox 15">
             <a:extLst>
               <a:ext uri="{FF2B5EF4-FFF2-40B4-BE49-F238E27FC236}">
-                <a16:creationId xmlns:a16="http://schemas.microsoft.com/office/drawing/2014/main" id="{4B2B0E86-4954-AA96-6239-0EB8C96D764E}"/>
+                <a16:creationId xmlns:a16="http://schemas.microsoft.com/office/drawing/2014/main" id="{0BB04C6A-2575-33EE-6C89-893FE346D9D4}"/>
               </a:ext>
             </a:extLst>
           </p:cNvPr>
@@ -9884,7 +9895,7 @@
           <p:cNvPr id="17" name="Rectangle: Rounded Corners 16">
             <a:extLst>
               <a:ext uri="{FF2B5EF4-FFF2-40B4-BE49-F238E27FC236}">
-                <a16:creationId xmlns:a16="http://schemas.microsoft.com/office/drawing/2014/main" id="{0CA1D01E-DE67-A403-F8C2-2FA0A93E8F5F}"/>
+                <a16:creationId xmlns:a16="http://schemas.microsoft.com/office/drawing/2014/main" id="{30A62435-8324-E9F0-374B-909A024A1598}"/>
               </a:ext>
             </a:extLst>
           </p:cNvPr>
@@ -9942,7 +9953,7 @@
           <p:cNvPr id="18" name="Rectangle 17">
             <a:extLst>
               <a:ext uri="{FF2B5EF4-FFF2-40B4-BE49-F238E27FC236}">
-                <a16:creationId xmlns:a16="http://schemas.microsoft.com/office/drawing/2014/main" id="{35127323-F2BB-EB46-1622-AD8643BA5591}"/>
+                <a16:creationId xmlns:a16="http://schemas.microsoft.com/office/drawing/2014/main" id="{6BF22D0E-4F8B-DB48-4CDD-6A7566254277}"/>
               </a:ext>
             </a:extLst>
           </p:cNvPr>
@@ -10002,7 +10013,7 @@
           <p:cNvPr id="19" name="TextBox 18">
             <a:extLst>
               <a:ext uri="{FF2B5EF4-FFF2-40B4-BE49-F238E27FC236}">
-                <a16:creationId xmlns:a16="http://schemas.microsoft.com/office/drawing/2014/main" id="{183D05B5-0D40-824B-DF05-069F8EADE14A}"/>
+                <a16:creationId xmlns:a16="http://schemas.microsoft.com/office/drawing/2014/main" id="{56343AEE-D605-F7BC-6C2F-98FCB698E48C}"/>
               </a:ext>
             </a:extLst>
           </p:cNvPr>
@@ -10042,7 +10053,7 @@
           <p:cNvPr id="20" name="TextBox 19">
             <a:extLst>
               <a:ext uri="{FF2B5EF4-FFF2-40B4-BE49-F238E27FC236}">
-                <a16:creationId xmlns:a16="http://schemas.microsoft.com/office/drawing/2014/main" id="{746DA808-0689-5FB3-636F-CC563F430659}"/>
+                <a16:creationId xmlns:a16="http://schemas.microsoft.com/office/drawing/2014/main" id="{9D97C71A-8EAB-05CB-84F3-DD2F7B4C2C3F}"/>
               </a:ext>
             </a:extLst>
           </p:cNvPr>
@@ -10082,7 +10093,7 @@
           <p:cNvPr id="21" name="TextBox 20">
             <a:extLst>
               <a:ext uri="{FF2B5EF4-FFF2-40B4-BE49-F238E27FC236}">
-                <a16:creationId xmlns:a16="http://schemas.microsoft.com/office/drawing/2014/main" id="{9E19D07C-4A59-2535-93B5-E0F496C3B5B9}"/>
+                <a16:creationId xmlns:a16="http://schemas.microsoft.com/office/drawing/2014/main" id="{1E6BC597-F037-F7A9-C2C3-C52161429F7A}"/>
               </a:ext>
             </a:extLst>
           </p:cNvPr>
@@ -10112,7 +10123,7 @@
                 </a:solidFill>
                 <a:latin typeface="Aptos" panose="020B0004020202020204" pitchFamily="34" charset="0"/>
               </a:rPr>
-              <a:t>Source: Google Security Blog, "Eliminating Memory Safety Vulnerabilities at the Source," 25 Sep 2024.</a:t>
+              <a:t>Claims P-05 and P-06: MICROSOFT_RUST_CLAIM_LEDGER.md.</a:t>
             </a:r>
           </a:p>
         </p:txBody>
@@ -10122,7 +10133,7 @@
           <p:cNvPr id="22" name="TextBox 21">
             <a:extLst>
               <a:ext uri="{FF2B5EF4-FFF2-40B4-BE49-F238E27FC236}">
-                <a16:creationId xmlns:a16="http://schemas.microsoft.com/office/drawing/2014/main" id="{CAE20527-C986-FDC1-2617-662CEA33709F}"/>
+                <a16:creationId xmlns:a16="http://schemas.microsoft.com/office/drawing/2014/main" id="{8FE40BEB-0918-030D-3C1C-958058CE6348}"/>
               </a:ext>
             </a:extLst>
           </p:cNvPr>
@@ -10161,7 +10172,7 @@
     </p:spTree>
     <p:extLst>
       <p:ext uri="{BB962C8B-B14F-4D97-AF65-F5344CB8AC3E}">
-        <p14:creationId xmlns:p14="http://schemas.microsoft.com/office/powerpoint/2010/main" val="1285798742"/>
+        <p14:creationId xmlns:p14="http://schemas.microsoft.com/office/powerpoint/2010/main" val="597573373"/>
       </p:ext>
     </p:extLst>
   </p:cSld>
@@ -10193,7 +10204,7 @@
           <p:cNvPr id="2" name="TextBox 1">
             <a:extLst>
               <a:ext uri="{FF2B5EF4-FFF2-40B4-BE49-F238E27FC236}">
-                <a16:creationId xmlns:a16="http://schemas.microsoft.com/office/drawing/2014/main" id="{025CBB22-F964-5406-A465-68834EF7E849}"/>
+                <a16:creationId xmlns:a16="http://schemas.microsoft.com/office/drawing/2014/main" id="{F9AD3D46-7ECC-7B57-ACC7-BE7C1A3AD007}"/>
               </a:ext>
             </a:extLst>
           </p:cNvPr>
@@ -10233,7 +10244,7 @@
           <p:cNvPr id="3" name="TextBox 2">
             <a:extLst>
               <a:ext uri="{FF2B5EF4-FFF2-40B4-BE49-F238E27FC236}">
-                <a16:creationId xmlns:a16="http://schemas.microsoft.com/office/drawing/2014/main" id="{C477F4B7-F795-C285-4B3F-AB1E9512A2BF}"/>
+                <a16:creationId xmlns:a16="http://schemas.microsoft.com/office/drawing/2014/main" id="{B70D1597-CA34-0383-E571-40CE3DF3E1FA}"/>
               </a:ext>
             </a:extLst>
           </p:cNvPr>
@@ -10273,7 +10284,7 @@
           <p:cNvPr id="4" name="Oval 3">
             <a:extLst>
               <a:ext uri="{FF2B5EF4-FFF2-40B4-BE49-F238E27FC236}">
-                <a16:creationId xmlns:a16="http://schemas.microsoft.com/office/drawing/2014/main" id="{49DBAB4B-F75A-9121-F106-B702108A8C2B}"/>
+                <a16:creationId xmlns:a16="http://schemas.microsoft.com/office/drawing/2014/main" id="{E5D72D9E-8FD2-9E57-9461-1A397D64AC84}"/>
               </a:ext>
             </a:extLst>
           </p:cNvPr>
@@ -10334,7 +10345,7 @@
           <p:cNvPr id="5" name="TextBox 4">
             <a:extLst>
               <a:ext uri="{FF2B5EF4-FFF2-40B4-BE49-F238E27FC236}">
-                <a16:creationId xmlns:a16="http://schemas.microsoft.com/office/drawing/2014/main" id="{38AF63B9-7076-F9E5-2623-77549852E5B7}"/>
+                <a16:creationId xmlns:a16="http://schemas.microsoft.com/office/drawing/2014/main" id="{D5BDEF32-6411-864E-B654-35BCE91F9B35}"/>
               </a:ext>
             </a:extLst>
           </p:cNvPr>
@@ -10375,7 +10386,7 @@
           <p:cNvPr id="6" name="TextBox 5">
             <a:extLst>
               <a:ext uri="{FF2B5EF4-FFF2-40B4-BE49-F238E27FC236}">
-                <a16:creationId xmlns:a16="http://schemas.microsoft.com/office/drawing/2014/main" id="{406BFFF5-C563-51B2-8E23-436F1F198CD3}"/>
+                <a16:creationId xmlns:a16="http://schemas.microsoft.com/office/drawing/2014/main" id="{BC9EBC70-D66A-F0DD-F1C8-59CE436B928F}"/>
               </a:ext>
             </a:extLst>
           </p:cNvPr>
@@ -10415,7 +10426,7 @@
           <p:cNvPr id="7" name="TextBox 6">
             <a:extLst>
               <a:ext uri="{FF2B5EF4-FFF2-40B4-BE49-F238E27FC236}">
-                <a16:creationId xmlns:a16="http://schemas.microsoft.com/office/drawing/2014/main" id="{8D017FF8-9136-82F6-F506-F3FD1B0FEB09}"/>
+                <a16:creationId xmlns:a16="http://schemas.microsoft.com/office/drawing/2014/main" id="{7CA171A5-5474-A209-E254-C5DACEED5F64}"/>
               </a:ext>
             </a:extLst>
           </p:cNvPr>
@@ -10455,7 +10466,7 @@
           <p:cNvPr id="8" name="Straight Connector 7">
             <a:extLst>
               <a:ext uri="{FF2B5EF4-FFF2-40B4-BE49-F238E27FC236}">
-                <a16:creationId xmlns:a16="http://schemas.microsoft.com/office/drawing/2014/main" id="{3671E3A8-0237-A87F-AF76-DADE60F4DC0D}"/>
+                <a16:creationId xmlns:a16="http://schemas.microsoft.com/office/drawing/2014/main" id="{225F557C-ACC3-F627-BFE1-35F81F572F0A}"/>
               </a:ext>
             </a:extLst>
           </p:cNvPr>
@@ -10496,7 +10507,7 @@
           <p:cNvPr id="9" name="Oval 8">
             <a:extLst>
               <a:ext uri="{FF2B5EF4-FFF2-40B4-BE49-F238E27FC236}">
-                <a16:creationId xmlns:a16="http://schemas.microsoft.com/office/drawing/2014/main" id="{D9ADD919-0D74-703C-F53F-673A4E4546D7}"/>
+                <a16:creationId xmlns:a16="http://schemas.microsoft.com/office/drawing/2014/main" id="{E73F4D26-C5D4-B9D2-C761-2D1C20C7AB12}"/>
               </a:ext>
             </a:extLst>
           </p:cNvPr>
@@ -10557,7 +10568,7 @@
           <p:cNvPr id="10" name="TextBox 9">
             <a:extLst>
               <a:ext uri="{FF2B5EF4-FFF2-40B4-BE49-F238E27FC236}">
-                <a16:creationId xmlns:a16="http://schemas.microsoft.com/office/drawing/2014/main" id="{D1CBC2D6-E4AE-E455-C366-69888854590A}"/>
+                <a16:creationId xmlns:a16="http://schemas.microsoft.com/office/drawing/2014/main" id="{C2E39768-F377-A033-31B0-C97F096D25DF}"/>
               </a:ext>
             </a:extLst>
           </p:cNvPr>
@@ -10598,7 +10609,7 @@
           <p:cNvPr id="11" name="TextBox 10">
             <a:extLst>
               <a:ext uri="{FF2B5EF4-FFF2-40B4-BE49-F238E27FC236}">
-                <a16:creationId xmlns:a16="http://schemas.microsoft.com/office/drawing/2014/main" id="{E6E2EFD4-2E41-1451-40BB-D357784966CE}"/>
+                <a16:creationId xmlns:a16="http://schemas.microsoft.com/office/drawing/2014/main" id="{7953B621-FE17-6CF5-E3AA-95D04C0A0F50}"/>
               </a:ext>
             </a:extLst>
           </p:cNvPr>
@@ -10638,7 +10649,7 @@
           <p:cNvPr id="12" name="TextBox 11">
             <a:extLst>
               <a:ext uri="{FF2B5EF4-FFF2-40B4-BE49-F238E27FC236}">
-                <a16:creationId xmlns:a16="http://schemas.microsoft.com/office/drawing/2014/main" id="{E612A890-A398-1664-A817-68191E341633}"/>
+                <a16:creationId xmlns:a16="http://schemas.microsoft.com/office/drawing/2014/main" id="{9B9973A7-BBFF-1A13-D44C-CD0B7841C16A}"/>
               </a:ext>
             </a:extLst>
           </p:cNvPr>
@@ -10678,7 +10689,7 @@
           <p:cNvPr id="13" name="Straight Connector 12">
             <a:extLst>
               <a:ext uri="{FF2B5EF4-FFF2-40B4-BE49-F238E27FC236}">
-                <a16:creationId xmlns:a16="http://schemas.microsoft.com/office/drawing/2014/main" id="{1B4B1BE6-978E-82FA-A246-3FF4FA7E975C}"/>
+                <a16:creationId xmlns:a16="http://schemas.microsoft.com/office/drawing/2014/main" id="{CEA4CC18-30C1-961E-C068-6CBF231050B0}"/>
               </a:ext>
             </a:extLst>
           </p:cNvPr>
@@ -10719,7 +10730,7 @@
           <p:cNvPr id="14" name="Oval 13">
             <a:extLst>
               <a:ext uri="{FF2B5EF4-FFF2-40B4-BE49-F238E27FC236}">
-                <a16:creationId xmlns:a16="http://schemas.microsoft.com/office/drawing/2014/main" id="{226CA27C-AEBF-F7C5-D301-F8953CB84219}"/>
+                <a16:creationId xmlns:a16="http://schemas.microsoft.com/office/drawing/2014/main" id="{7BD7D42E-98D0-6E1B-1900-0B055D400B2F}"/>
               </a:ext>
             </a:extLst>
           </p:cNvPr>
@@ -10780,7 +10791,7 @@
           <p:cNvPr id="15" name="TextBox 14">
             <a:extLst>
               <a:ext uri="{FF2B5EF4-FFF2-40B4-BE49-F238E27FC236}">
-                <a16:creationId xmlns:a16="http://schemas.microsoft.com/office/drawing/2014/main" id="{E3E1E47D-45C6-C168-D726-EDAC4BF4E93B}"/>
+                <a16:creationId xmlns:a16="http://schemas.microsoft.com/office/drawing/2014/main" id="{80834637-6AE9-F90D-5276-D753D3DAD3B3}"/>
               </a:ext>
             </a:extLst>
           </p:cNvPr>
@@ -10821,7 +10832,7 @@
           <p:cNvPr id="16" name="TextBox 15">
             <a:extLst>
               <a:ext uri="{FF2B5EF4-FFF2-40B4-BE49-F238E27FC236}">
-                <a16:creationId xmlns:a16="http://schemas.microsoft.com/office/drawing/2014/main" id="{C1507523-2A4F-C7D2-393B-DFCE9ED8F4CE}"/>
+                <a16:creationId xmlns:a16="http://schemas.microsoft.com/office/drawing/2014/main" id="{DB3B2694-C2E1-B9E8-9386-C03983541310}"/>
               </a:ext>
             </a:extLst>
           </p:cNvPr>
@@ -10861,7 +10872,7 @@
           <p:cNvPr id="17" name="TextBox 16">
             <a:extLst>
               <a:ext uri="{FF2B5EF4-FFF2-40B4-BE49-F238E27FC236}">
-                <a16:creationId xmlns:a16="http://schemas.microsoft.com/office/drawing/2014/main" id="{1BAFD9CC-A062-AC49-1509-00C20B696836}"/>
+                <a16:creationId xmlns:a16="http://schemas.microsoft.com/office/drawing/2014/main" id="{5147EC5C-97CA-E93C-B313-6EDE3234BB84}"/>
               </a:ext>
             </a:extLst>
           </p:cNvPr>
@@ -10901,7 +10912,7 @@
           <p:cNvPr id="18" name="Straight Connector 17">
             <a:extLst>
               <a:ext uri="{FF2B5EF4-FFF2-40B4-BE49-F238E27FC236}">
-                <a16:creationId xmlns:a16="http://schemas.microsoft.com/office/drawing/2014/main" id="{8BCB3DA7-E588-3980-1FD4-C5282C3EA2DE}"/>
+                <a16:creationId xmlns:a16="http://schemas.microsoft.com/office/drawing/2014/main" id="{C538A673-E7BE-80AF-2C49-3A0FBE488D46}"/>
               </a:ext>
             </a:extLst>
           </p:cNvPr>
@@ -10942,7 +10953,7 @@
           <p:cNvPr id="19" name="Oval 18">
             <a:extLst>
               <a:ext uri="{FF2B5EF4-FFF2-40B4-BE49-F238E27FC236}">
-                <a16:creationId xmlns:a16="http://schemas.microsoft.com/office/drawing/2014/main" id="{012C198E-55A1-2B10-96E9-477D6A788965}"/>
+                <a16:creationId xmlns:a16="http://schemas.microsoft.com/office/drawing/2014/main" id="{A74B1787-6524-0646-882D-B946105BE9F0}"/>
               </a:ext>
             </a:extLst>
           </p:cNvPr>
@@ -11003,7 +11014,7 @@
           <p:cNvPr id="20" name="TextBox 19">
             <a:extLst>
               <a:ext uri="{FF2B5EF4-FFF2-40B4-BE49-F238E27FC236}">
-                <a16:creationId xmlns:a16="http://schemas.microsoft.com/office/drawing/2014/main" id="{D2ACE7FE-D60C-56DD-FA6C-D876A05CDEE9}"/>
+                <a16:creationId xmlns:a16="http://schemas.microsoft.com/office/drawing/2014/main" id="{43D2E4AD-AAEE-96DD-4A3C-D1525289E4B0}"/>
               </a:ext>
             </a:extLst>
           </p:cNvPr>
@@ -11044,7 +11055,7 @@
           <p:cNvPr id="21" name="TextBox 20">
             <a:extLst>
               <a:ext uri="{FF2B5EF4-FFF2-40B4-BE49-F238E27FC236}">
-                <a16:creationId xmlns:a16="http://schemas.microsoft.com/office/drawing/2014/main" id="{B4A14C18-C0BD-EDBD-EA56-AF397EB989AA}"/>
+                <a16:creationId xmlns:a16="http://schemas.microsoft.com/office/drawing/2014/main" id="{2D993D27-2965-923D-4DD5-97FBA2F5274B}"/>
               </a:ext>
             </a:extLst>
           </p:cNvPr>
@@ -11084,7 +11095,7 @@
           <p:cNvPr id="22" name="TextBox 21">
             <a:extLst>
               <a:ext uri="{FF2B5EF4-FFF2-40B4-BE49-F238E27FC236}">
-                <a16:creationId xmlns:a16="http://schemas.microsoft.com/office/drawing/2014/main" id="{6445FF49-6C24-45AE-025B-68C3181DA9CA}"/>
+                <a16:creationId xmlns:a16="http://schemas.microsoft.com/office/drawing/2014/main" id="{4F012F17-2079-6DD6-4A93-34FAFD910D0A}"/>
               </a:ext>
             </a:extLst>
           </p:cNvPr>
@@ -11124,7 +11135,7 @@
           <p:cNvPr id="23" name="TextBox 22">
             <a:extLst>
               <a:ext uri="{FF2B5EF4-FFF2-40B4-BE49-F238E27FC236}">
-                <a16:creationId xmlns:a16="http://schemas.microsoft.com/office/drawing/2014/main" id="{4CCC90A7-721C-448D-BF97-CC169F458306}"/>
+                <a16:creationId xmlns:a16="http://schemas.microsoft.com/office/drawing/2014/main" id="{841420C9-3149-C3EB-0A52-25ADC2A481DA}"/>
               </a:ext>
             </a:extLst>
           </p:cNvPr>
@@ -11154,7 +11165,7 @@
                 </a:solidFill>
                 <a:latin typeface="Aptos" panose="020B0004020202020204" pitchFamily="34" charset="0"/>
               </a:rPr>
-              <a:t>Sources: Microsoft Azure Security; Azure SDK Blog; github.com/microsoft/openvmm; Rust Foundation members.</a:t>
+              <a:t>Claims M-01 to M-04: MICROSOFT_RUST_CLAIM_LEDGER.md.</a:t>
             </a:r>
           </a:p>
         </p:txBody>
@@ -11164,7 +11175,7 @@
           <p:cNvPr id="24" name="TextBox 23">
             <a:extLst>
               <a:ext uri="{FF2B5EF4-FFF2-40B4-BE49-F238E27FC236}">
-                <a16:creationId xmlns:a16="http://schemas.microsoft.com/office/drawing/2014/main" id="{6C07A3C7-051F-BBFC-79BA-85BFF2F760B2}"/>
+                <a16:creationId xmlns:a16="http://schemas.microsoft.com/office/drawing/2014/main" id="{7FC34D7B-6BA0-F168-9377-63323D79459A}"/>
               </a:ext>
             </a:extLst>
           </p:cNvPr>
@@ -11203,7 +11214,7 @@
     </p:spTree>
     <p:extLst>
       <p:ext uri="{BB962C8B-B14F-4D97-AF65-F5344CB8AC3E}">
-        <p14:creationId xmlns:p14="http://schemas.microsoft.com/office/powerpoint/2010/main" val="1932824270"/>
+        <p14:creationId xmlns:p14="http://schemas.microsoft.com/office/powerpoint/2010/main" val="1589047179"/>
       </p:ext>
     </p:extLst>
   </p:cSld>
@@ -11235,7 +11246,7 @@
           <p:cNvPr id="2" name="TextBox 1">
             <a:extLst>
               <a:ext uri="{FF2B5EF4-FFF2-40B4-BE49-F238E27FC236}">
-                <a16:creationId xmlns:a16="http://schemas.microsoft.com/office/drawing/2014/main" id="{5FC103EA-5825-C573-A08B-54D58802AF6E}"/>
+                <a16:creationId xmlns:a16="http://schemas.microsoft.com/office/drawing/2014/main" id="{99A99F18-E053-CED8-E46F-64896FD95C31}"/>
               </a:ext>
             </a:extLst>
           </p:cNvPr>
@@ -11275,7 +11286,7 @@
           <p:cNvPr id="3" name="TextBox 2">
             <a:extLst>
               <a:ext uri="{FF2B5EF4-FFF2-40B4-BE49-F238E27FC236}">
-                <a16:creationId xmlns:a16="http://schemas.microsoft.com/office/drawing/2014/main" id="{9564D5E0-C65F-8517-38E3-E8536E052842}"/>
+                <a16:creationId xmlns:a16="http://schemas.microsoft.com/office/drawing/2014/main" id="{E724ACF5-0B5E-F704-5BBF-012D865C72AA}"/>
               </a:ext>
             </a:extLst>
           </p:cNvPr>
@@ -11315,7 +11326,7 @@
           <p:cNvPr id="4" name="Rectangle: Rounded Corners 3">
             <a:extLst>
               <a:ext uri="{FF2B5EF4-FFF2-40B4-BE49-F238E27FC236}">
-                <a16:creationId xmlns:a16="http://schemas.microsoft.com/office/drawing/2014/main" id="{13F77A99-E2A1-7B51-BE75-D61A510671A2}"/>
+                <a16:creationId xmlns:a16="http://schemas.microsoft.com/office/drawing/2014/main" id="{6CE75150-DAA1-7E47-7384-BB758EAF150E}"/>
               </a:ext>
             </a:extLst>
           </p:cNvPr>
@@ -11375,7 +11386,7 @@
           <p:cNvPr id="5" name="TextBox 4">
             <a:extLst>
               <a:ext uri="{FF2B5EF4-FFF2-40B4-BE49-F238E27FC236}">
-                <a16:creationId xmlns:a16="http://schemas.microsoft.com/office/drawing/2014/main" id="{920D6033-347A-51E6-A818-A12BE2D3DD34}"/>
+                <a16:creationId xmlns:a16="http://schemas.microsoft.com/office/drawing/2014/main" id="{1EF49E3A-922D-FC28-5630-3B74E03F5B5F}"/>
               </a:ext>
             </a:extLst>
           </p:cNvPr>
@@ -11415,7 +11426,7 @@
           <p:cNvPr id="6" name="TextBox 5">
             <a:extLst>
               <a:ext uri="{FF2B5EF4-FFF2-40B4-BE49-F238E27FC236}">
-                <a16:creationId xmlns:a16="http://schemas.microsoft.com/office/drawing/2014/main" id="{BAC6622D-6BE3-BD51-DBFE-02DC02E46609}"/>
+                <a16:creationId xmlns:a16="http://schemas.microsoft.com/office/drawing/2014/main" id="{2973688E-F509-0E2A-0779-A7EFA92BE6D5}"/>
               </a:ext>
             </a:extLst>
           </p:cNvPr>
@@ -11455,7 +11466,7 @@
           <p:cNvPr id="7" name="Rectangle: Rounded Corners 6">
             <a:extLst>
               <a:ext uri="{FF2B5EF4-FFF2-40B4-BE49-F238E27FC236}">
-                <a16:creationId xmlns:a16="http://schemas.microsoft.com/office/drawing/2014/main" id="{4D59C664-0544-779A-2598-2EA33AE0266C}"/>
+                <a16:creationId xmlns:a16="http://schemas.microsoft.com/office/drawing/2014/main" id="{B13D0EA8-556F-B7DA-039C-05EF6FC52E8D}"/>
               </a:ext>
             </a:extLst>
           </p:cNvPr>
@@ -11515,7 +11526,7 @@
           <p:cNvPr id="8" name="TextBox 7">
             <a:extLst>
               <a:ext uri="{FF2B5EF4-FFF2-40B4-BE49-F238E27FC236}">
-                <a16:creationId xmlns:a16="http://schemas.microsoft.com/office/drawing/2014/main" id="{1AFC2387-9860-AC4A-34C1-07ADB2889E37}"/>
+                <a16:creationId xmlns:a16="http://schemas.microsoft.com/office/drawing/2014/main" id="{E14861A4-E5D4-87A2-26FE-68D3C2706615}"/>
               </a:ext>
             </a:extLst>
           </p:cNvPr>
@@ -11555,7 +11566,7 @@
           <p:cNvPr id="9" name="TextBox 8">
             <a:extLst>
               <a:ext uri="{FF2B5EF4-FFF2-40B4-BE49-F238E27FC236}">
-                <a16:creationId xmlns:a16="http://schemas.microsoft.com/office/drawing/2014/main" id="{90EFC6E7-18B3-CC51-0B44-43146A4B35B0}"/>
+                <a16:creationId xmlns:a16="http://schemas.microsoft.com/office/drawing/2014/main" id="{2019180D-F792-A5EA-0BEE-D66E17D362B6}"/>
               </a:ext>
             </a:extLst>
           </p:cNvPr>
@@ -11595,7 +11606,7 @@
           <p:cNvPr id="10" name="Rectangle: Rounded Corners 9">
             <a:extLst>
               <a:ext uri="{FF2B5EF4-FFF2-40B4-BE49-F238E27FC236}">
-                <a16:creationId xmlns:a16="http://schemas.microsoft.com/office/drawing/2014/main" id="{7B022BDF-D07F-CED3-1CEF-7D81ADDF6B45}"/>
+                <a16:creationId xmlns:a16="http://schemas.microsoft.com/office/drawing/2014/main" id="{6FEB27BD-F80F-9688-105E-0FB5C5A489E1}"/>
               </a:ext>
             </a:extLst>
           </p:cNvPr>
@@ -11655,7 +11666,7 @@
           <p:cNvPr id="11" name="TextBox 10">
             <a:extLst>
               <a:ext uri="{FF2B5EF4-FFF2-40B4-BE49-F238E27FC236}">
-                <a16:creationId xmlns:a16="http://schemas.microsoft.com/office/drawing/2014/main" id="{40C3F782-0596-C6C3-E5CB-9CE6906676DA}"/>
+                <a16:creationId xmlns:a16="http://schemas.microsoft.com/office/drawing/2014/main" id="{87BCDBFD-8F9A-3A9D-EAEB-6128C3135D9C}"/>
               </a:ext>
             </a:extLst>
           </p:cNvPr>
@@ -11695,7 +11706,7 @@
           <p:cNvPr id="12" name="TextBox 11">
             <a:extLst>
               <a:ext uri="{FF2B5EF4-FFF2-40B4-BE49-F238E27FC236}">
-                <a16:creationId xmlns:a16="http://schemas.microsoft.com/office/drawing/2014/main" id="{77B25829-8683-ACAB-0655-F532232A022D}"/>
+                <a16:creationId xmlns:a16="http://schemas.microsoft.com/office/drawing/2014/main" id="{93460993-3C63-B0A7-1399-722B0A011322}"/>
               </a:ext>
             </a:extLst>
           </p:cNvPr>
@@ -11735,7 +11746,7 @@
           <p:cNvPr id="13" name="Rectangle: Rounded Corners 12">
             <a:extLst>
               <a:ext uri="{FF2B5EF4-FFF2-40B4-BE49-F238E27FC236}">
-                <a16:creationId xmlns:a16="http://schemas.microsoft.com/office/drawing/2014/main" id="{2C5F152B-B250-48D6-9913-EB2FA891ED5A}"/>
+                <a16:creationId xmlns:a16="http://schemas.microsoft.com/office/drawing/2014/main" id="{03F12F46-8A65-BF3A-D5FB-AD5B64C79EF1}"/>
               </a:ext>
             </a:extLst>
           </p:cNvPr>
@@ -11795,7 +11806,7 @@
           <p:cNvPr id="14" name="TextBox 13">
             <a:extLst>
               <a:ext uri="{FF2B5EF4-FFF2-40B4-BE49-F238E27FC236}">
-                <a16:creationId xmlns:a16="http://schemas.microsoft.com/office/drawing/2014/main" id="{4753AACB-1B9C-30F8-EAB9-65C1004A9786}"/>
+                <a16:creationId xmlns:a16="http://schemas.microsoft.com/office/drawing/2014/main" id="{7A2C3C6F-44FA-BB93-CCC7-8283F70FFC5D}"/>
               </a:ext>
             </a:extLst>
           </p:cNvPr>
@@ -11835,7 +11846,7 @@
           <p:cNvPr id="15" name="TextBox 14">
             <a:extLst>
               <a:ext uri="{FF2B5EF4-FFF2-40B4-BE49-F238E27FC236}">
-                <a16:creationId xmlns:a16="http://schemas.microsoft.com/office/drawing/2014/main" id="{B364AA31-C1E2-DBCF-7F4B-2748DDD9472F}"/>
+                <a16:creationId xmlns:a16="http://schemas.microsoft.com/office/drawing/2014/main" id="{E30EAC77-7AD8-5561-BFA7-EF9D04EB23F5}"/>
               </a:ext>
             </a:extLst>
           </p:cNvPr>
@@ -11875,7 +11886,7 @@
           <p:cNvPr id="16" name="Rectangle: Rounded Corners 15">
             <a:extLst>
               <a:ext uri="{FF2B5EF4-FFF2-40B4-BE49-F238E27FC236}">
-                <a16:creationId xmlns:a16="http://schemas.microsoft.com/office/drawing/2014/main" id="{500DA2B2-67E8-DFCE-415A-BDC06D1E8227}"/>
+                <a16:creationId xmlns:a16="http://schemas.microsoft.com/office/drawing/2014/main" id="{95DCB528-9544-A6E6-B54D-6C2B842F7CCB}"/>
               </a:ext>
             </a:extLst>
           </p:cNvPr>
@@ -11935,7 +11946,7 @@
           <p:cNvPr id="17" name="TextBox 16">
             <a:extLst>
               <a:ext uri="{FF2B5EF4-FFF2-40B4-BE49-F238E27FC236}">
-                <a16:creationId xmlns:a16="http://schemas.microsoft.com/office/drawing/2014/main" id="{2C6B4705-22B3-1656-263C-0FD9454E1364}"/>
+                <a16:creationId xmlns:a16="http://schemas.microsoft.com/office/drawing/2014/main" id="{810A65DF-EB22-652D-DFF4-FA5DDDB8460C}"/>
               </a:ext>
             </a:extLst>
           </p:cNvPr>
@@ -11975,7 +11986,7 @@
           <p:cNvPr id="18" name="TextBox 17">
             <a:extLst>
               <a:ext uri="{FF2B5EF4-FFF2-40B4-BE49-F238E27FC236}">
-                <a16:creationId xmlns:a16="http://schemas.microsoft.com/office/drawing/2014/main" id="{1350000A-6640-B303-6D4D-181F33122EDF}"/>
+                <a16:creationId xmlns:a16="http://schemas.microsoft.com/office/drawing/2014/main" id="{CB198161-78DF-DFC5-9942-1AF790A53264}"/>
               </a:ext>
             </a:extLst>
           </p:cNvPr>
@@ -12015,7 +12026,7 @@
           <p:cNvPr id="19" name="Rectangle: Rounded Corners 18">
             <a:extLst>
               <a:ext uri="{FF2B5EF4-FFF2-40B4-BE49-F238E27FC236}">
-                <a16:creationId xmlns:a16="http://schemas.microsoft.com/office/drawing/2014/main" id="{1BB7698E-10DF-7C0B-62FD-FF71E0BA0FC0}"/>
+                <a16:creationId xmlns:a16="http://schemas.microsoft.com/office/drawing/2014/main" id="{8B942D1E-C063-9DAE-3C85-4673D94FFD5A}"/>
               </a:ext>
             </a:extLst>
           </p:cNvPr>
@@ -12075,7 +12086,7 @@
           <p:cNvPr id="20" name="TextBox 19">
             <a:extLst>
               <a:ext uri="{FF2B5EF4-FFF2-40B4-BE49-F238E27FC236}">
-                <a16:creationId xmlns:a16="http://schemas.microsoft.com/office/drawing/2014/main" id="{55460742-8AD1-C107-FFEF-D0F2882B06B3}"/>
+                <a16:creationId xmlns:a16="http://schemas.microsoft.com/office/drawing/2014/main" id="{73F300D5-142E-9414-7AF2-259B9D14DF7E}"/>
               </a:ext>
             </a:extLst>
           </p:cNvPr>
@@ -12115,7 +12126,7 @@
           <p:cNvPr id="21" name="TextBox 20">
             <a:extLst>
               <a:ext uri="{FF2B5EF4-FFF2-40B4-BE49-F238E27FC236}">
-                <a16:creationId xmlns:a16="http://schemas.microsoft.com/office/drawing/2014/main" id="{7F6996AE-903B-E6E9-73BD-AA36907A213C}"/>
+                <a16:creationId xmlns:a16="http://schemas.microsoft.com/office/drawing/2014/main" id="{0E434565-8130-70A5-2801-8B745F71E0F3}"/>
               </a:ext>
             </a:extLst>
           </p:cNvPr>
@@ -12155,7 +12166,7 @@
           <p:cNvPr id="22" name="TextBox 21">
             <a:extLst>
               <a:ext uri="{FF2B5EF4-FFF2-40B4-BE49-F238E27FC236}">
-                <a16:creationId xmlns:a16="http://schemas.microsoft.com/office/drawing/2014/main" id="{1161A3B4-A527-EEBE-979B-F5940138F959}"/>
+                <a16:creationId xmlns:a16="http://schemas.microsoft.com/office/drawing/2014/main" id="{4777E817-959A-95C4-CA5D-F35DF4D920BA}"/>
               </a:ext>
             </a:extLst>
           </p:cNvPr>
@@ -12195,7 +12206,7 @@
           <p:cNvPr id="23" name="TextBox 22">
             <a:extLst>
               <a:ext uri="{FF2B5EF4-FFF2-40B4-BE49-F238E27FC236}">
-                <a16:creationId xmlns:a16="http://schemas.microsoft.com/office/drawing/2014/main" id="{90CB8B3A-19AB-C5CA-CC42-94E4179500CA}"/>
+                <a16:creationId xmlns:a16="http://schemas.microsoft.com/office/drawing/2014/main" id="{2DE74F43-6A72-18B6-53B4-9D5253ABC2FC}"/>
               </a:ext>
             </a:extLst>
           </p:cNvPr>
@@ -12225,7 +12236,7 @@
                 </a:solidFill>
                 <a:latin typeface="Aptos" panose="020B0004020202020204" pitchFamily="34" charset="0"/>
               </a:rPr>
-              <a:t>Ferris now demonstrates this layer without replacing Cargo, CI, execution, or owner authority.</a:t>
+              <a:t>Ferris demonstrates this layer without replacing Cargo, required CI, or owner authority.</a:t>
             </a:r>
           </a:p>
         </p:txBody>
@@ -12235,7 +12246,7 @@
           <p:cNvPr id="24" name="TextBox 23">
             <a:extLst>
               <a:ext uri="{FF2B5EF4-FFF2-40B4-BE49-F238E27FC236}">
-                <a16:creationId xmlns:a16="http://schemas.microsoft.com/office/drawing/2014/main" id="{C7A0F748-1627-8B38-9010-A6B4E83F17E5}"/>
+                <a16:creationId xmlns:a16="http://schemas.microsoft.com/office/drawing/2014/main" id="{49336AF0-C9C6-610C-C366-6CC26BEF759A}"/>
               </a:ext>
             </a:extLst>
           </p:cNvPr>
@@ -12274,7 +12285,7 @@
     </p:spTree>
     <p:extLst>
       <p:ext uri="{BB962C8B-B14F-4D97-AF65-F5344CB8AC3E}">
-        <p14:creationId xmlns:p14="http://schemas.microsoft.com/office/powerpoint/2010/main" val="1008610841"/>
+        <p14:creationId xmlns:p14="http://schemas.microsoft.com/office/powerpoint/2010/main" val="2836413845"/>
       </p:ext>
     </p:extLst>
   </p:cSld>
@@ -12306,7 +12317,7 @@
           <p:cNvPr id="2" name="TextBox 1">
             <a:extLst>
               <a:ext uri="{FF2B5EF4-FFF2-40B4-BE49-F238E27FC236}">
-                <a16:creationId xmlns:a16="http://schemas.microsoft.com/office/drawing/2014/main" id="{E1B44488-ECE4-84F9-F119-CAACAA89A55E}"/>
+                <a16:creationId xmlns:a16="http://schemas.microsoft.com/office/drawing/2014/main" id="{DEEB9C59-3E23-FCE8-6DB6-9A1871E6A7A7}"/>
               </a:ext>
             </a:extLst>
           </p:cNvPr>
@@ -12336,7 +12347,7 @@
                 </a:solidFill>
                 <a:latin typeface="Aptos" panose="020B0004020202020204" pitchFamily="34" charset="0"/>
               </a:rPr>
-              <a:t>PUBLIC PRODUCT PROOF</a:t>
+              <a:t>CURRENT PRODUCT PROOF</a:t>
             </a:r>
           </a:p>
         </p:txBody>
@@ -12346,7 +12357,7 @@
           <p:cNvPr id="3" name="TextBox 2">
             <a:extLst>
               <a:ext uri="{FF2B5EF4-FFF2-40B4-BE49-F238E27FC236}">
-                <a16:creationId xmlns:a16="http://schemas.microsoft.com/office/drawing/2014/main" id="{B8A9FE4C-AB13-61B6-3A6E-3977F0FD8456}"/>
+                <a16:creationId xmlns:a16="http://schemas.microsoft.com/office/drawing/2014/main" id="{75BA521C-80E5-E094-862F-403E5DCBDB73}"/>
               </a:ext>
             </a:extLst>
           </p:cNvPr>
@@ -12376,7 +12387,7 @@
                 </a:solidFill>
                 <a:latin typeface="Aptos Display" panose="020B0004020202020204" pitchFamily="34" charset="0"/>
               </a:rPr>
-              <a:t>Ferris now proves the application layer can stay Cargo-native</a:t>
+              <a:t>Ferris now executes approved owner work and records evidence</a:t>
             </a:r>
           </a:p>
         </p:txBody>
@@ -12386,7 +12397,7 @@
           <p:cNvPr id="4" name="Rectangle: Rounded Corners 3">
             <a:extLst>
               <a:ext uri="{FF2B5EF4-FFF2-40B4-BE49-F238E27FC236}">
-                <a16:creationId xmlns:a16="http://schemas.microsoft.com/office/drawing/2014/main" id="{08FC9205-093B-4EF5-277E-1167C37E0E01}"/>
+                <a16:creationId xmlns:a16="http://schemas.microsoft.com/office/drawing/2014/main" id="{3745BC4B-F8CE-4880-0BB9-A2AFE6EC2A8C}"/>
               </a:ext>
             </a:extLst>
           </p:cNvPr>
@@ -12444,7 +12455,7 @@
           <p:cNvPr id="5" name="Rectangle 4">
             <a:extLst>
               <a:ext uri="{FF2B5EF4-FFF2-40B4-BE49-F238E27FC236}">
-                <a16:creationId xmlns:a16="http://schemas.microsoft.com/office/drawing/2014/main" id="{BC0E25AE-97D4-C626-6DA9-00B3E3B388E0}"/>
+                <a16:creationId xmlns:a16="http://schemas.microsoft.com/office/drawing/2014/main" id="{BA34E17D-E9B6-FAF3-20FF-3E1B710B656D}"/>
               </a:ext>
             </a:extLst>
           </p:cNvPr>
@@ -12504,7 +12515,7 @@
           <p:cNvPr id="6" name="TextBox 5">
             <a:extLst>
               <a:ext uri="{FF2B5EF4-FFF2-40B4-BE49-F238E27FC236}">
-                <a16:creationId xmlns:a16="http://schemas.microsoft.com/office/drawing/2014/main" id="{0609C71D-B5F0-92C6-63CF-164D68F22FCF}"/>
+                <a16:creationId xmlns:a16="http://schemas.microsoft.com/office/drawing/2014/main" id="{04F1F907-8637-CA44-B4F1-4609E4FB35E1}"/>
               </a:ext>
             </a:extLst>
           </p:cNvPr>
@@ -12534,7 +12545,7 @@
                 </a:solidFill>
                 <a:latin typeface="Aptos" panose="020B0004020202020204" pitchFamily="34" charset="0"/>
               </a:rPr>
-              <a:t>CARGO DISCOVERY</a:t>
+              <a:t>PLAN</a:t>
             </a:r>
           </a:p>
         </p:txBody>
@@ -12544,7 +12555,7 @@
           <p:cNvPr id="7" name="TextBox 6">
             <a:extLst>
               <a:ext uri="{FF2B5EF4-FFF2-40B4-BE49-F238E27FC236}">
-                <a16:creationId xmlns:a16="http://schemas.microsoft.com/office/drawing/2014/main" id="{0BB8ACBE-97D0-0823-F318-E65C12EC16FC}"/>
+                <a16:creationId xmlns:a16="http://schemas.microsoft.com/office/drawing/2014/main" id="{4C5C1B3B-DF57-3BD5-FFCA-F55C1D799C06}"/>
               </a:ext>
             </a:extLst>
           </p:cNvPr>
@@ -12574,7 +12585,7 @@
                 </a:solidFill>
                 <a:latin typeface="Aptos" panose="020B0004020202020204" pitchFamily="34" charset="0"/>
               </a:rPr>
-              <a:t>cargo ferris locates the current workspace through Cargo itself.</a:t>
+              <a:t>Cargo-native planning preserves owner declarations and widens unknown inputs safely.</a:t>
             </a:r>
           </a:p>
         </p:txBody>
@@ -12584,7 +12595,7 @@
           <p:cNvPr id="8" name="Rectangle: Rounded Corners 7">
             <a:extLst>
               <a:ext uri="{FF2B5EF4-FFF2-40B4-BE49-F238E27FC236}">
-                <a16:creationId xmlns:a16="http://schemas.microsoft.com/office/drawing/2014/main" id="{7B4DD7FC-B8A8-AE47-F715-A1D6C7B6C573}"/>
+                <a16:creationId xmlns:a16="http://schemas.microsoft.com/office/drawing/2014/main" id="{A91A5555-4398-38DD-1F6A-86407685AC0B}"/>
               </a:ext>
             </a:extLst>
           </p:cNvPr>
@@ -12642,7 +12653,7 @@
           <p:cNvPr id="9" name="Rectangle 8">
             <a:extLst>
               <a:ext uri="{FF2B5EF4-FFF2-40B4-BE49-F238E27FC236}">
-                <a16:creationId xmlns:a16="http://schemas.microsoft.com/office/drawing/2014/main" id="{E4632837-421D-86F5-B26B-B10509A08359}"/>
+                <a16:creationId xmlns:a16="http://schemas.microsoft.com/office/drawing/2014/main" id="{D476CE3F-3B52-C2AC-A702-67812F7505B4}"/>
               </a:ext>
             </a:extLst>
           </p:cNvPr>
@@ -12702,7 +12713,7 @@
           <p:cNvPr id="10" name="TextBox 9">
             <a:extLst>
               <a:ext uri="{FF2B5EF4-FFF2-40B4-BE49-F238E27FC236}">
-                <a16:creationId xmlns:a16="http://schemas.microsoft.com/office/drawing/2014/main" id="{860D8D68-E528-9B2C-AD41-B1DEFE371752}"/>
+                <a16:creationId xmlns:a16="http://schemas.microsoft.com/office/drawing/2014/main" id="{99455EA2-F944-99B2-67C7-8A997BBAF326}"/>
               </a:ext>
             </a:extLst>
           </p:cNvPr>
@@ -12732,7 +12743,7 @@
                 </a:solidFill>
                 <a:latin typeface="Aptos" panose="020B0004020202020204" pitchFamily="34" charset="0"/>
               </a:rPr>
-              <a:t>VALIDATION PLAN</a:t>
+              <a:t>EXECUTE</a:t>
             </a:r>
           </a:p>
         </p:txBody>
@@ -12742,7 +12753,7 @@
           <p:cNvPr id="11" name="TextBox 10">
             <a:extLst>
               <a:ext uri="{FF2B5EF4-FFF2-40B4-BE49-F238E27FC236}">
-                <a16:creationId xmlns:a16="http://schemas.microsoft.com/office/drawing/2014/main" id="{7080134B-9798-1CE5-27DE-4374511B3BE9}"/>
+                <a16:creationId xmlns:a16="http://schemas.microsoft.com/office/drawing/2014/main" id="{17919D13-A759-A670-D516-99C5FEE69002}"/>
               </a:ext>
             </a:extLst>
           </p:cNvPr>
@@ -12772,7 +12783,7 @@
                 </a:solidFill>
                 <a:latin typeface="Aptos" panose="020B0004020202020204" pitchFamily="34" charset="0"/>
               </a:rPr>
-              <a:t>Changed paths and packages produce conservative, non-executable validation scope.</a:t>
+              <a:t>Approved Action Plans launch only exact repository-owned commands.</a:t>
             </a:r>
           </a:p>
         </p:txBody>
@@ -12782,7 +12793,7 @@
           <p:cNvPr id="12" name="Rectangle: Rounded Corners 11">
             <a:extLst>
               <a:ext uri="{FF2B5EF4-FFF2-40B4-BE49-F238E27FC236}">
-                <a16:creationId xmlns:a16="http://schemas.microsoft.com/office/drawing/2014/main" id="{3CA798DD-92B8-5C6C-4B37-93E5A14ECED4}"/>
+                <a16:creationId xmlns:a16="http://schemas.microsoft.com/office/drawing/2014/main" id="{B8AD1421-5207-D576-D239-0F0EF1EC90C8}"/>
               </a:ext>
             </a:extLst>
           </p:cNvPr>
@@ -12840,7 +12851,7 @@
           <p:cNvPr id="13" name="Rectangle 12">
             <a:extLst>
               <a:ext uri="{FF2B5EF4-FFF2-40B4-BE49-F238E27FC236}">
-                <a16:creationId xmlns:a16="http://schemas.microsoft.com/office/drawing/2014/main" id="{5D11D83F-D6FB-F5B3-D583-322F950B1267}"/>
+                <a16:creationId xmlns:a16="http://schemas.microsoft.com/office/drawing/2014/main" id="{72EBB5BD-8873-9EEA-A00C-5A9E26E6F9CC}"/>
               </a:ext>
             </a:extLst>
           </p:cNvPr>
@@ -12900,7 +12911,7 @@
           <p:cNvPr id="14" name="TextBox 13">
             <a:extLst>
               <a:ext uri="{FF2B5EF4-FFF2-40B4-BE49-F238E27FC236}">
-                <a16:creationId xmlns:a16="http://schemas.microsoft.com/office/drawing/2014/main" id="{7A1C6DA3-DA9C-994C-1795-DB0856908617}"/>
+                <a16:creationId xmlns:a16="http://schemas.microsoft.com/office/drawing/2014/main" id="{BAB2E654-63E5-D2A5-6D70-5BBD912E7251}"/>
               </a:ext>
             </a:extLst>
           </p:cNvPr>
@@ -12930,7 +12941,7 @@
                 </a:solidFill>
                 <a:latin typeface="Aptos" panose="020B0004020202020204" pitchFamily="34" charset="0"/>
               </a:rPr>
-              <a:t>FEDERATED PLAN</a:t>
+              <a:t>EVIDENCE</a:t>
             </a:r>
           </a:p>
         </p:txBody>
@@ -12940,7 +12951,7 @@
           <p:cNvPr id="15" name="TextBox 14">
             <a:extLst>
               <a:ext uri="{FF2B5EF4-FFF2-40B4-BE49-F238E27FC236}">
-                <a16:creationId xmlns:a16="http://schemas.microsoft.com/office/drawing/2014/main" id="{599B08D0-647F-3800-5686-ED865A3C54A6}"/>
+                <a16:creationId xmlns:a16="http://schemas.microsoft.com/office/drawing/2014/main" id="{79A6F8F5-DF7E-DB9E-68B1-6130B9B7F232}"/>
               </a:ext>
             </a:extLst>
           </p:cNvPr>
@@ -12970,7 +12981,7 @@
                 </a:solidFill>
                 <a:latin typeface="Aptos" panose="020B0004020202020204" pitchFamily="34" charset="0"/>
               </a:rPr>
-              <a:t>One strict request links 2-16 independent workspace plans without flattening Cargo truth.</a:t>
+              <a:t>Receipts preserve direct and transitive blockers across verification and replay.</a:t>
             </a:r>
           </a:p>
         </p:txBody>
@@ -12980,7 +12991,7 @@
           <p:cNvPr id="16" name="Rectangle: Rounded Corners 15">
             <a:extLst>
               <a:ext uri="{FF2B5EF4-FFF2-40B4-BE49-F238E27FC236}">
-                <a16:creationId xmlns:a16="http://schemas.microsoft.com/office/drawing/2014/main" id="{05065F39-4077-F619-CB24-8B1A58FBA2C5}"/>
+                <a16:creationId xmlns:a16="http://schemas.microsoft.com/office/drawing/2014/main" id="{262FFABF-B62E-D22A-8EF4-88E414EF5533}"/>
               </a:ext>
             </a:extLst>
           </p:cNvPr>
@@ -13038,7 +13049,7 @@
           <p:cNvPr id="17" name="Rectangle 16">
             <a:extLst>
               <a:ext uri="{FF2B5EF4-FFF2-40B4-BE49-F238E27FC236}">
-                <a16:creationId xmlns:a16="http://schemas.microsoft.com/office/drawing/2014/main" id="{B62F2E8C-F22B-6FFB-7451-5D0F1ACD2A77}"/>
+                <a16:creationId xmlns:a16="http://schemas.microsoft.com/office/drawing/2014/main" id="{7C766080-A954-B029-1600-77EC21C9763F}"/>
               </a:ext>
             </a:extLst>
           </p:cNvPr>
@@ -13098,7 +13109,7 @@
           <p:cNvPr id="18" name="TextBox 17">
             <a:extLst>
               <a:ext uri="{FF2B5EF4-FFF2-40B4-BE49-F238E27FC236}">
-                <a16:creationId xmlns:a16="http://schemas.microsoft.com/office/drawing/2014/main" id="{D0AD3E2F-8275-B7EC-7789-66155F5B82FF}"/>
+                <a16:creationId xmlns:a16="http://schemas.microsoft.com/office/drawing/2014/main" id="{096352F8-83D0-8FF4-B4EA-71ABB7582CB9}"/>
               </a:ext>
             </a:extLst>
           </p:cNvPr>
@@ -13128,7 +13139,7 @@
                 </a:solidFill>
                 <a:latin typeface="Aptos" panose="020B0004020202020204" pitchFamily="34" charset="0"/>
               </a:rPr>
-              <a:t>CONSUMER PINS</a:t>
+              <a:t>PREFLIGHT</a:t>
             </a:r>
           </a:p>
         </p:txBody>
@@ -13138,7 +13149,7 @@
           <p:cNvPr id="19" name="TextBox 18">
             <a:extLst>
               <a:ext uri="{FF2B5EF4-FFF2-40B4-BE49-F238E27FC236}">
-                <a16:creationId xmlns:a16="http://schemas.microsoft.com/office/drawing/2014/main" id="{938DA327-F810-1996-79D7-3429120D1D09}"/>
+                <a16:creationId xmlns:a16="http://schemas.microsoft.com/office/drawing/2014/main" id="{84137A0D-849D-EB04-F3C0-94E75D9CEAD4}"/>
               </a:ext>
             </a:extLst>
           </p:cNvPr>
@@ -13168,7 +13179,7 @@
                 </a:solidFill>
                 <a:latin typeface="Aptos" panose="020B0004020202020204" pitchFamily="34" charset="0"/>
               </a:rPr>
-              <a:t>PARLOR and RUNE validate exact experimental output contracts on Windows and Ubuntu.</a:t>
+              <a:t>Workspace and application readiness identify missing requirements before owner work.</a:t>
             </a:r>
           </a:p>
         </p:txBody>
@@ -13178,7 +13189,7 @@
           <p:cNvPr id="20" name="Rectangle: Rounded Corners 19">
             <a:extLst>
               <a:ext uri="{FF2B5EF4-FFF2-40B4-BE49-F238E27FC236}">
-                <a16:creationId xmlns:a16="http://schemas.microsoft.com/office/drawing/2014/main" id="{12855475-AADF-6EF9-7C9D-12D1282A0A0E}"/>
+                <a16:creationId xmlns:a16="http://schemas.microsoft.com/office/drawing/2014/main" id="{85491E9F-815B-751D-9881-802AD90B81B3}"/>
               </a:ext>
             </a:extLst>
           </p:cNvPr>
@@ -13238,7 +13249,7 @@
           <p:cNvPr id="21" name="TextBox 20">
             <a:extLst>
               <a:ext uri="{FF2B5EF4-FFF2-40B4-BE49-F238E27FC236}">
-                <a16:creationId xmlns:a16="http://schemas.microsoft.com/office/drawing/2014/main" id="{52CF1358-D5C3-30CB-0714-E84E9CB78D01}"/>
+                <a16:creationId xmlns:a16="http://schemas.microsoft.com/office/drawing/2014/main" id="{ADE0B5A5-9EF3-F885-BC50-A81C291FBA99}"/>
               </a:ext>
             </a:extLst>
           </p:cNvPr>
@@ -13263,13 +13274,13 @@
           <a:p>
             <a:pPr algn="ctr"/>
             <a:r>
-              <a:rPr lang="en-US" sz="1700" b="1">
+              <a:rPr lang="en-US" sz="1600" b="1">
                 <a:solidFill>
                   <a:srgbClr val="FFFFFF"/>
                 </a:solidFill>
                 <a:latin typeface="Aptos Display" panose="020B0004020202020204" pitchFamily="34" charset="0"/>
               </a:rPr>
-              <a:t>Read-only. Non-executable. Portable JSON. Unknowns widen safely.</a:t>
+              <a:t>Owner commands remain authoritative. Ferris does not remove or replace required CI gates.</a:t>
             </a:r>
           </a:p>
         </p:txBody>
@@ -13279,7 +13290,7 @@
           <p:cNvPr id="22" name="TextBox 21">
             <a:extLst>
               <a:ext uri="{FF2B5EF4-FFF2-40B4-BE49-F238E27FC236}">
-                <a16:creationId xmlns:a16="http://schemas.microsoft.com/office/drawing/2014/main" id="{EB9B75B4-EFB7-DDFC-7219-7198E50A9F15}"/>
+                <a16:creationId xmlns:a16="http://schemas.microsoft.com/office/drawing/2014/main" id="{6977D0C4-C070-3B94-1139-122A3E3C86BC}"/>
               </a:ext>
             </a:extLst>
           </p:cNvPr>
@@ -13309,7 +13320,7 @@
                 </a:solidFill>
                 <a:latin typeface="Aptos" panose="020B0004020202020204" pitchFamily="34" charset="0"/>
               </a:rPr>
-              <a:t>Published schemas cover validation-plan success structure; runtime semantic invariants remain explicit.</a:t>
+              <a:t>Claims F-03 and F-04: MICROSOFT_RUST_CLAIM_LEDGER.md. No production support claim.</a:t>
             </a:r>
           </a:p>
         </p:txBody>
@@ -13319,7 +13330,7 @@
           <p:cNvPr id="23" name="TextBox 22">
             <a:extLst>
               <a:ext uri="{FF2B5EF4-FFF2-40B4-BE49-F238E27FC236}">
-                <a16:creationId xmlns:a16="http://schemas.microsoft.com/office/drawing/2014/main" id="{4BAC5E2E-8B21-ACEF-FA4F-E1DB67B58B20}"/>
+                <a16:creationId xmlns:a16="http://schemas.microsoft.com/office/drawing/2014/main" id="{3385A761-FAD7-546F-DE0F-E85BFF820767}"/>
               </a:ext>
             </a:extLst>
           </p:cNvPr>
@@ -13358,7 +13369,7 @@
     </p:spTree>
     <p:extLst>
       <p:ext uri="{BB962C8B-B14F-4D97-AF65-F5344CB8AC3E}">
-        <p14:creationId xmlns:p14="http://schemas.microsoft.com/office/powerpoint/2010/main" val="1076517255"/>
+        <p14:creationId xmlns:p14="http://schemas.microsoft.com/office/powerpoint/2010/main" val="1415253367"/>
       </p:ext>
     </p:extLst>
   </p:cSld>
@@ -13390,7 +13401,7 @@
           <p:cNvPr id="2" name="TextBox 1">
             <a:extLst>
               <a:ext uri="{FF2B5EF4-FFF2-40B4-BE49-F238E27FC236}">
-                <a16:creationId xmlns:a16="http://schemas.microsoft.com/office/drawing/2014/main" id="{407C20C8-EAA1-41B2-DDA1-5C2BB98DDB39}"/>
+                <a16:creationId xmlns:a16="http://schemas.microsoft.com/office/drawing/2014/main" id="{73C1C85D-8898-529E-962C-C4A28028BBE1}"/>
               </a:ext>
             </a:extLst>
           </p:cNvPr>
@@ -13420,7 +13431,7 @@
                 </a:solidFill>
                 <a:latin typeface="Aptos" panose="020B0004020202020204" pitchFamily="34" charset="0"/>
               </a:rPr>
-              <a:t>GITHUB + COPILOT</a:t>
+              <a:t>FUTURE WORKFLOW, NOT IMPLEMENTED</a:t>
             </a:r>
           </a:p>
         </p:txBody>
@@ -13430,7 +13441,7 @@
           <p:cNvPr id="3" name="TextBox 2">
             <a:extLst>
               <a:ext uri="{FF2B5EF4-FFF2-40B4-BE49-F238E27FC236}">
-                <a16:creationId xmlns:a16="http://schemas.microsoft.com/office/drawing/2014/main" id="{236A7D1F-367D-DEE2-0683-33CB00296F25}"/>
+                <a16:creationId xmlns:a16="http://schemas.microsoft.com/office/drawing/2014/main" id="{5389373E-182E-9879-2DE7-F7130C8BEC86}"/>
               </a:ext>
             </a:extLst>
           </p:cNvPr>
@@ -13460,7 +13471,7 @@
                 </a:solidFill>
                 <a:latin typeface="Aptos Display" panose="020B0004020202020204" pitchFamily="34" charset="0"/>
               </a:rPr>
-              <a:t>Copilot's differentiated opportunity is governed native change</a:t>
+              <a:t>Target Copilot workflow for governed native change</a:t>
             </a:r>
           </a:p>
         </p:txBody>
@@ -13470,7 +13481,7 @@
           <p:cNvPr id="4" name="Oval 3">
             <a:extLst>
               <a:ext uri="{FF2B5EF4-FFF2-40B4-BE49-F238E27FC236}">
-                <a16:creationId xmlns:a16="http://schemas.microsoft.com/office/drawing/2014/main" id="{373CDCE3-DFB2-D4B5-5294-5DFE55CE4972}"/>
+                <a16:creationId xmlns:a16="http://schemas.microsoft.com/office/drawing/2014/main" id="{4252D45E-28A8-4D06-D3F1-FB7EA5BEE6EB}"/>
               </a:ext>
             </a:extLst>
           </p:cNvPr>
@@ -13531,7 +13542,7 @@
           <p:cNvPr id="5" name="TextBox 4">
             <a:extLst>
               <a:ext uri="{FF2B5EF4-FFF2-40B4-BE49-F238E27FC236}">
-                <a16:creationId xmlns:a16="http://schemas.microsoft.com/office/drawing/2014/main" id="{25E0F43D-BEF7-DA55-674B-3721CDB05838}"/>
+                <a16:creationId xmlns:a16="http://schemas.microsoft.com/office/drawing/2014/main" id="{90570015-CD48-44D8-77B6-94DF94D060B1}"/>
               </a:ext>
             </a:extLst>
           </p:cNvPr>
@@ -13572,7 +13583,7 @@
           <p:cNvPr id="6" name="Straight Connector 5">
             <a:extLst>
               <a:ext uri="{FF2B5EF4-FFF2-40B4-BE49-F238E27FC236}">
-                <a16:creationId xmlns:a16="http://schemas.microsoft.com/office/drawing/2014/main" id="{2A674A51-C33D-4FDE-6140-9297A1B1492A}"/>
+                <a16:creationId xmlns:a16="http://schemas.microsoft.com/office/drawing/2014/main" id="{997E1D5F-C977-F11E-A94E-17FB1586F263}"/>
               </a:ext>
             </a:extLst>
           </p:cNvPr>
@@ -13613,7 +13624,7 @@
           <p:cNvPr id="7" name="TextBox 6">
             <a:extLst>
               <a:ext uri="{FF2B5EF4-FFF2-40B4-BE49-F238E27FC236}">
-                <a16:creationId xmlns:a16="http://schemas.microsoft.com/office/drawing/2014/main" id="{0E08230B-1965-E9B6-47E9-C20AA4DC1DD4}"/>
+                <a16:creationId xmlns:a16="http://schemas.microsoft.com/office/drawing/2014/main" id="{29AED434-5691-3502-D3F2-EC9BD198A34B}"/>
               </a:ext>
             </a:extLst>
           </p:cNvPr>
@@ -13654,7 +13665,7 @@
           <p:cNvPr id="8" name="Oval 7">
             <a:extLst>
               <a:ext uri="{FF2B5EF4-FFF2-40B4-BE49-F238E27FC236}">
-                <a16:creationId xmlns:a16="http://schemas.microsoft.com/office/drawing/2014/main" id="{76207B75-D7FB-297F-B0BE-68240037C876}"/>
+                <a16:creationId xmlns:a16="http://schemas.microsoft.com/office/drawing/2014/main" id="{4AE838CF-181F-8AE6-0F61-D40F08023A3D}"/>
               </a:ext>
             </a:extLst>
           </p:cNvPr>
@@ -13715,7 +13726,7 @@
           <p:cNvPr id="9" name="TextBox 8">
             <a:extLst>
               <a:ext uri="{FF2B5EF4-FFF2-40B4-BE49-F238E27FC236}">
-                <a16:creationId xmlns:a16="http://schemas.microsoft.com/office/drawing/2014/main" id="{B20B660E-F192-F30D-3FFA-B5CA0D9D861C}"/>
+                <a16:creationId xmlns:a16="http://schemas.microsoft.com/office/drawing/2014/main" id="{85435E61-56A1-3988-8584-F01C7ABDE773}"/>
               </a:ext>
             </a:extLst>
           </p:cNvPr>
@@ -13756,7 +13767,7 @@
           <p:cNvPr id="10" name="Straight Connector 9">
             <a:extLst>
               <a:ext uri="{FF2B5EF4-FFF2-40B4-BE49-F238E27FC236}">
-                <a16:creationId xmlns:a16="http://schemas.microsoft.com/office/drawing/2014/main" id="{5CF27FFF-1DA5-481F-820E-F3BCD9830C1E}"/>
+                <a16:creationId xmlns:a16="http://schemas.microsoft.com/office/drawing/2014/main" id="{074C4BB4-82DA-ABE9-D5BE-FDECC7444FC0}"/>
               </a:ext>
             </a:extLst>
           </p:cNvPr>
@@ -13797,7 +13808,7 @@
           <p:cNvPr id="11" name="TextBox 10">
             <a:extLst>
               <a:ext uri="{FF2B5EF4-FFF2-40B4-BE49-F238E27FC236}">
-                <a16:creationId xmlns:a16="http://schemas.microsoft.com/office/drawing/2014/main" id="{98D47E65-31B6-5FD0-CA4B-24E2BDB92860}"/>
+                <a16:creationId xmlns:a16="http://schemas.microsoft.com/office/drawing/2014/main" id="{A8C7D5C6-BD5A-4B04-FCA5-6CE558B48819}"/>
               </a:ext>
             </a:extLst>
           </p:cNvPr>
@@ -13838,7 +13849,7 @@
           <p:cNvPr id="12" name="Oval 11">
             <a:extLst>
               <a:ext uri="{FF2B5EF4-FFF2-40B4-BE49-F238E27FC236}">
-                <a16:creationId xmlns:a16="http://schemas.microsoft.com/office/drawing/2014/main" id="{F29CA353-9C78-2291-75E3-44924DE4A686}"/>
+                <a16:creationId xmlns:a16="http://schemas.microsoft.com/office/drawing/2014/main" id="{7F846F97-6673-89DE-FD6C-3DCCCB5403C0}"/>
               </a:ext>
             </a:extLst>
           </p:cNvPr>
@@ -13899,7 +13910,7 @@
           <p:cNvPr id="13" name="TextBox 12">
             <a:extLst>
               <a:ext uri="{FF2B5EF4-FFF2-40B4-BE49-F238E27FC236}">
-                <a16:creationId xmlns:a16="http://schemas.microsoft.com/office/drawing/2014/main" id="{3B84F47B-39C1-36E3-FB33-31D7384AA46B}"/>
+                <a16:creationId xmlns:a16="http://schemas.microsoft.com/office/drawing/2014/main" id="{E35D3574-3069-59A1-0FD0-D01E293C2C5B}"/>
               </a:ext>
             </a:extLst>
           </p:cNvPr>
@@ -13940,7 +13951,7 @@
           <p:cNvPr id="14" name="Straight Connector 13">
             <a:extLst>
               <a:ext uri="{FF2B5EF4-FFF2-40B4-BE49-F238E27FC236}">
-                <a16:creationId xmlns:a16="http://schemas.microsoft.com/office/drawing/2014/main" id="{C8E843B0-C917-88B7-225C-7794FD3368A9}"/>
+                <a16:creationId xmlns:a16="http://schemas.microsoft.com/office/drawing/2014/main" id="{51A88B72-07B4-AF8B-1698-77A035EB4375}"/>
               </a:ext>
             </a:extLst>
           </p:cNvPr>
@@ -13981,7 +13992,7 @@
           <p:cNvPr id="15" name="TextBox 14">
             <a:extLst>
               <a:ext uri="{FF2B5EF4-FFF2-40B4-BE49-F238E27FC236}">
-                <a16:creationId xmlns:a16="http://schemas.microsoft.com/office/drawing/2014/main" id="{EEF6141C-D9EA-DA30-C003-4F72122E8F8B}"/>
+                <a16:creationId xmlns:a16="http://schemas.microsoft.com/office/drawing/2014/main" id="{433C4735-953B-D7DA-E698-7B7CD7F06347}"/>
               </a:ext>
             </a:extLst>
           </p:cNvPr>
@@ -14022,7 +14033,7 @@
           <p:cNvPr id="16" name="Oval 15">
             <a:extLst>
               <a:ext uri="{FF2B5EF4-FFF2-40B4-BE49-F238E27FC236}">
-                <a16:creationId xmlns:a16="http://schemas.microsoft.com/office/drawing/2014/main" id="{AA884A53-D0D8-68BD-4F03-FC6954C1E724}"/>
+                <a16:creationId xmlns:a16="http://schemas.microsoft.com/office/drawing/2014/main" id="{1326D4DA-3E05-50C8-B4F0-BFC642664E55}"/>
               </a:ext>
             </a:extLst>
           </p:cNvPr>
@@ -14083,7 +14094,7 @@
           <p:cNvPr id="17" name="TextBox 16">
             <a:extLst>
               <a:ext uri="{FF2B5EF4-FFF2-40B4-BE49-F238E27FC236}">
-                <a16:creationId xmlns:a16="http://schemas.microsoft.com/office/drawing/2014/main" id="{CA71E8D0-1217-0819-A572-EA35AC3399E7}"/>
+                <a16:creationId xmlns:a16="http://schemas.microsoft.com/office/drawing/2014/main" id="{DAF5CF6C-D7DE-6718-CDF6-EAB0DF080898}"/>
               </a:ext>
             </a:extLst>
           </p:cNvPr>
@@ -14124,7 +14135,7 @@
           <p:cNvPr id="18" name="Straight Connector 17">
             <a:extLst>
               <a:ext uri="{FF2B5EF4-FFF2-40B4-BE49-F238E27FC236}">
-                <a16:creationId xmlns:a16="http://schemas.microsoft.com/office/drawing/2014/main" id="{BF04C43D-7006-3520-5080-5AEBB28A3E47}"/>
+                <a16:creationId xmlns:a16="http://schemas.microsoft.com/office/drawing/2014/main" id="{E1A5848B-8A2B-F7D7-FC48-830462FD8D71}"/>
               </a:ext>
             </a:extLst>
           </p:cNvPr>
@@ -14165,7 +14176,7 @@
           <p:cNvPr id="19" name="TextBox 18">
             <a:extLst>
               <a:ext uri="{FF2B5EF4-FFF2-40B4-BE49-F238E27FC236}">
-                <a16:creationId xmlns:a16="http://schemas.microsoft.com/office/drawing/2014/main" id="{44BDACEC-CC87-DACA-FE7F-59003EF4D35C}"/>
+                <a16:creationId xmlns:a16="http://schemas.microsoft.com/office/drawing/2014/main" id="{99C3ECB7-C8FB-1936-CAC2-A59045B0D9AA}"/>
               </a:ext>
             </a:extLst>
           </p:cNvPr>
@@ -14206,7 +14217,7 @@
           <p:cNvPr id="20" name="Oval 19">
             <a:extLst>
               <a:ext uri="{FF2B5EF4-FFF2-40B4-BE49-F238E27FC236}">
-                <a16:creationId xmlns:a16="http://schemas.microsoft.com/office/drawing/2014/main" id="{BB8FD131-6C0E-30D2-2837-A74CDAA6EE82}"/>
+                <a16:creationId xmlns:a16="http://schemas.microsoft.com/office/drawing/2014/main" id="{5FA10591-6AC4-5271-2634-A83B1985BA61}"/>
               </a:ext>
             </a:extLst>
           </p:cNvPr>
@@ -14267,7 +14278,7 @@
           <p:cNvPr id="21" name="TextBox 20">
             <a:extLst>
               <a:ext uri="{FF2B5EF4-FFF2-40B4-BE49-F238E27FC236}">
-                <a16:creationId xmlns:a16="http://schemas.microsoft.com/office/drawing/2014/main" id="{7269F1AA-DFD0-1A79-4337-C42D34C85CDB}"/>
+                <a16:creationId xmlns:a16="http://schemas.microsoft.com/office/drawing/2014/main" id="{649965BB-1D4C-8831-378E-2F20535205A0}"/>
               </a:ext>
             </a:extLst>
           </p:cNvPr>
@@ -14308,7 +14319,7 @@
           <p:cNvPr id="22" name="Straight Connector 21">
             <a:extLst>
               <a:ext uri="{FF2B5EF4-FFF2-40B4-BE49-F238E27FC236}">
-                <a16:creationId xmlns:a16="http://schemas.microsoft.com/office/drawing/2014/main" id="{E6DFC719-6260-1696-1138-922152749AD2}"/>
+                <a16:creationId xmlns:a16="http://schemas.microsoft.com/office/drawing/2014/main" id="{B803EB03-BDF1-152B-142A-DC28EFB8FBBC}"/>
               </a:ext>
             </a:extLst>
           </p:cNvPr>
@@ -14349,7 +14360,7 @@
           <p:cNvPr id="23" name="TextBox 22">
             <a:extLst>
               <a:ext uri="{FF2B5EF4-FFF2-40B4-BE49-F238E27FC236}">
-                <a16:creationId xmlns:a16="http://schemas.microsoft.com/office/drawing/2014/main" id="{44773A8A-05D5-57EC-28DD-05FA10A6C7BF}"/>
+                <a16:creationId xmlns:a16="http://schemas.microsoft.com/office/drawing/2014/main" id="{1947491D-C3E5-DA6B-7924-86C349BB6840}"/>
               </a:ext>
             </a:extLst>
           </p:cNvPr>
@@ -14390,7 +14401,7 @@
           <p:cNvPr id="24" name="Oval 23">
             <a:extLst>
               <a:ext uri="{FF2B5EF4-FFF2-40B4-BE49-F238E27FC236}">
-                <a16:creationId xmlns:a16="http://schemas.microsoft.com/office/drawing/2014/main" id="{46C4D923-37E9-6006-38BA-27203B8DA9CE}"/>
+                <a16:creationId xmlns:a16="http://schemas.microsoft.com/office/drawing/2014/main" id="{9683C9E0-6151-E5D7-141D-E697B4BE0E95}"/>
               </a:ext>
             </a:extLst>
           </p:cNvPr>
@@ -14451,7 +14462,7 @@
           <p:cNvPr id="25" name="TextBox 24">
             <a:extLst>
               <a:ext uri="{FF2B5EF4-FFF2-40B4-BE49-F238E27FC236}">
-                <a16:creationId xmlns:a16="http://schemas.microsoft.com/office/drawing/2014/main" id="{9D7F419D-BFA0-ECBF-B465-F74E31B0A03C}"/>
+                <a16:creationId xmlns:a16="http://schemas.microsoft.com/office/drawing/2014/main" id="{8509AE7D-16FA-BE81-908C-B40B1F4FE139}"/>
               </a:ext>
             </a:extLst>
           </p:cNvPr>
@@ -14492,7 +14503,7 @@
           <p:cNvPr id="26" name="TextBox 25">
             <a:extLst>
               <a:ext uri="{FF2B5EF4-FFF2-40B4-BE49-F238E27FC236}">
-                <a16:creationId xmlns:a16="http://schemas.microsoft.com/office/drawing/2014/main" id="{1288E3E2-27C1-CD73-3EC3-7868C079B49F}"/>
+                <a16:creationId xmlns:a16="http://schemas.microsoft.com/office/drawing/2014/main" id="{30B2C573-B8CE-3C3C-27AD-D59B6FA240AC}"/>
               </a:ext>
             </a:extLst>
           </p:cNvPr>
@@ -14533,7 +14544,7 @@
           <p:cNvPr id="27" name="Rectangle: Rounded Corners 26">
             <a:extLst>
               <a:ext uri="{FF2B5EF4-FFF2-40B4-BE49-F238E27FC236}">
-                <a16:creationId xmlns:a16="http://schemas.microsoft.com/office/drawing/2014/main" id="{CFB89B74-ADBE-C1BF-5DC4-8FC39E25DF0B}"/>
+                <a16:creationId xmlns:a16="http://schemas.microsoft.com/office/drawing/2014/main" id="{8B37420E-3D58-80CD-4B42-87E2621B89CF}"/>
               </a:ext>
             </a:extLst>
           </p:cNvPr>
@@ -14593,7 +14604,7 @@
           <p:cNvPr id="28" name="TextBox 27">
             <a:extLst>
               <a:ext uri="{FF2B5EF4-FFF2-40B4-BE49-F238E27FC236}">
-                <a16:creationId xmlns:a16="http://schemas.microsoft.com/office/drawing/2014/main" id="{194BE535-84CC-2858-9117-61FDBCFCA622}"/>
+                <a16:creationId xmlns:a16="http://schemas.microsoft.com/office/drawing/2014/main" id="{78CEDA69-EC76-0DB3-022E-569FE9EF0241}"/>
               </a:ext>
             </a:extLst>
           </p:cNvPr>
@@ -14603,7 +14614,7 @@
         <p:spPr>
           <a:xfrm>
             <a:off x="1676400" y="4343400"/>
-            <a:ext cx="4191000" cy="276999"/>
+            <a:ext cx="6350000" cy="276999"/>
           </a:xfrm>
           <a:prstGeom prst="rect">
             <a:avLst/>
@@ -14623,7 +14634,7 @@
                 </a:solidFill>
                 <a:latin typeface="Aptos" panose="020B0004020202020204" pitchFamily="34" charset="0"/>
               </a:rPr>
-              <a:t>Not "Copilot writes Rust."</a:t>
+              <a:t>The opportunity is governed native change.</a:t>
             </a:r>
           </a:p>
         </p:txBody>
@@ -14633,7 +14644,7 @@
           <p:cNvPr id="29" name="TextBox 28">
             <a:extLst>
               <a:ext uri="{FF2B5EF4-FFF2-40B4-BE49-F238E27FC236}">
-                <a16:creationId xmlns:a16="http://schemas.microsoft.com/office/drawing/2014/main" id="{ADE59712-B702-A2DD-DB72-48063C3D2F48}"/>
+                <a16:creationId xmlns:a16="http://schemas.microsoft.com/office/drawing/2014/main" id="{6853418B-B00D-546B-52C4-75DE780EF206}"/>
               </a:ext>
             </a:extLst>
           </p:cNvPr>
@@ -14657,13 +14668,13 @@
           <a:lstStyle/>
           <a:p>
             <a:r>
-              <a:rPr lang="en-US" sz="2000" b="1">
+              <a:rPr lang="en-US" sz="1900" b="1">
                 <a:solidFill>
                   <a:srgbClr val="FFFFFF"/>
                 </a:solidFill>
                 <a:latin typeface="Aptos Display" panose="020B0004020202020204" pitchFamily="34" charset="0"/>
               </a:rPr>
-              <a:t>Copilot changes native systems with compiler-grounded, application-aware evidence.</a:t>
+              <a:t>Record revision, model action, commands, results, and human approval.</a:t>
             </a:r>
           </a:p>
         </p:txBody>
@@ -14673,7 +14684,7 @@
           <p:cNvPr id="30" name="TextBox 29">
             <a:extLst>
               <a:ext uri="{FF2B5EF4-FFF2-40B4-BE49-F238E27FC236}">
-                <a16:creationId xmlns:a16="http://schemas.microsoft.com/office/drawing/2014/main" id="{81D194B0-C6C5-6CBD-3150-2BF09D4FD0D6}"/>
+                <a16:creationId xmlns:a16="http://schemas.microsoft.com/office/drawing/2014/main" id="{8AB756A2-494D-EAEB-5B48-AB3A18434E0F}"/>
               </a:ext>
             </a:extLst>
           </p:cNvPr>
@@ -14703,7 +14714,7 @@
                 </a:solidFill>
                 <a:latin typeface="Aptos" panose="020B0004020202020204" pitchFamily="34" charset="0"/>
               </a:rPr>
-              <a:t>AI may propose scope. Deterministic policy controls narrowing; unknowns widen safely.</a:t>
+              <a:t>Target only. Ferris has no GitHub, Azure, Copilot, or MCP integration today.</a:t>
             </a:r>
           </a:p>
         </p:txBody>
@@ -14713,7 +14724,7 @@
           <p:cNvPr id="31" name="TextBox 30">
             <a:extLst>
               <a:ext uri="{FF2B5EF4-FFF2-40B4-BE49-F238E27FC236}">
-                <a16:creationId xmlns:a16="http://schemas.microsoft.com/office/drawing/2014/main" id="{B2DC06D3-458A-3B52-50F8-2BEC7A5669E3}"/>
+                <a16:creationId xmlns:a16="http://schemas.microsoft.com/office/drawing/2014/main" id="{10933B76-D679-FFBB-9C6F-288EA72BEA6D}"/>
               </a:ext>
             </a:extLst>
           </p:cNvPr>
@@ -14752,7 +14763,7 @@
     </p:spTree>
     <p:extLst>
       <p:ext uri="{BB962C8B-B14F-4D97-AF65-F5344CB8AC3E}">
-        <p14:creationId xmlns:p14="http://schemas.microsoft.com/office/powerpoint/2010/main" val="1765777944"/>
+        <p14:creationId xmlns:p14="http://schemas.microsoft.com/office/powerpoint/2010/main" val="1702796973"/>
       </p:ext>
     </p:extLst>
   </p:cSld>
@@ -14784,7 +14795,7 @@
           <p:cNvPr id="2" name="TextBox 1">
             <a:extLst>
               <a:ext uri="{FF2B5EF4-FFF2-40B4-BE49-F238E27FC236}">
-                <a16:creationId xmlns:a16="http://schemas.microsoft.com/office/drawing/2014/main" id="{4B913FE5-7B1C-49CA-C3C4-8AF7F1D934A8}"/>
+                <a16:creationId xmlns:a16="http://schemas.microsoft.com/office/drawing/2014/main" id="{7B524970-2502-E6DE-8E1E-8FACFDE0C905}"/>
               </a:ext>
             </a:extLst>
           </p:cNvPr>
@@ -14824,7 +14835,7 @@
           <p:cNvPr id="3" name="TextBox 2">
             <a:extLst>
               <a:ext uri="{FF2B5EF4-FFF2-40B4-BE49-F238E27FC236}">
-                <a16:creationId xmlns:a16="http://schemas.microsoft.com/office/drawing/2014/main" id="{E52E3F29-A390-4E9C-914C-924C991548CF}"/>
+                <a16:creationId xmlns:a16="http://schemas.microsoft.com/office/drawing/2014/main" id="{0EDE04FB-285C-1C4E-4829-99C6573BA7E6}"/>
               </a:ext>
             </a:extLst>
           </p:cNvPr>
@@ -14864,7 +14875,7 @@
           <p:cNvPr id="4" name="Rectangle: Rounded Corners 3">
             <a:extLst>
               <a:ext uri="{FF2B5EF4-FFF2-40B4-BE49-F238E27FC236}">
-                <a16:creationId xmlns:a16="http://schemas.microsoft.com/office/drawing/2014/main" id="{DC22F5A3-CCF7-CC52-B99E-EE7800E44B18}"/>
+                <a16:creationId xmlns:a16="http://schemas.microsoft.com/office/drawing/2014/main" id="{12F0D811-535F-0BFB-C209-89FCF146D5D5}"/>
               </a:ext>
             </a:extLst>
           </p:cNvPr>
@@ -14922,7 +14933,7 @@
           <p:cNvPr id="5" name="Rectangle: Rounded Corners 4">
             <a:extLst>
               <a:ext uri="{FF2B5EF4-FFF2-40B4-BE49-F238E27FC236}">
-                <a16:creationId xmlns:a16="http://schemas.microsoft.com/office/drawing/2014/main" id="{532303F5-995B-E07C-9E59-6B6378E7656B}"/>
+                <a16:creationId xmlns:a16="http://schemas.microsoft.com/office/drawing/2014/main" id="{5157B317-EE1A-B1B6-58A1-1E75BC29DA80}"/>
               </a:ext>
             </a:extLst>
           </p:cNvPr>
@@ -14980,7 +14991,7 @@
           <p:cNvPr id="6" name="TextBox 5">
             <a:extLst>
               <a:ext uri="{FF2B5EF4-FFF2-40B4-BE49-F238E27FC236}">
-                <a16:creationId xmlns:a16="http://schemas.microsoft.com/office/drawing/2014/main" id="{950B4A96-0777-B3B6-55A9-66F98F718D1D}"/>
+                <a16:creationId xmlns:a16="http://schemas.microsoft.com/office/drawing/2014/main" id="{264FC996-8736-4EEE-8FC2-D5BBF5176C97}"/>
               </a:ext>
             </a:extLst>
           </p:cNvPr>
@@ -15020,7 +15031,7 @@
           <p:cNvPr id="7" name="TextBox 6">
             <a:extLst>
               <a:ext uri="{FF2B5EF4-FFF2-40B4-BE49-F238E27FC236}">
-                <a16:creationId xmlns:a16="http://schemas.microsoft.com/office/drawing/2014/main" id="{C1564C85-62F6-1B34-2E92-76DDE18AFB62}"/>
+                <a16:creationId xmlns:a16="http://schemas.microsoft.com/office/drawing/2014/main" id="{6AADAB4D-343E-9A68-DAC5-698DAE6BD0BA}"/>
               </a:ext>
             </a:extLst>
           </p:cNvPr>
@@ -15060,7 +15071,7 @@
           <p:cNvPr id="8" name="TextBox 7">
             <a:extLst>
               <a:ext uri="{FF2B5EF4-FFF2-40B4-BE49-F238E27FC236}">
-                <a16:creationId xmlns:a16="http://schemas.microsoft.com/office/drawing/2014/main" id="{D81FEDEA-600A-C379-AF2D-A52F9F03F587}"/>
+                <a16:creationId xmlns:a16="http://schemas.microsoft.com/office/drawing/2014/main" id="{C3DC656D-C35F-8D94-F87C-247C9A8B968F}"/>
               </a:ext>
             </a:extLst>
           </p:cNvPr>
@@ -15106,7 +15117,7 @@
           <p:cNvPr id="9" name="TextBox 8">
             <a:extLst>
               <a:ext uri="{FF2B5EF4-FFF2-40B4-BE49-F238E27FC236}">
-                <a16:creationId xmlns:a16="http://schemas.microsoft.com/office/drawing/2014/main" id="{448D1AB1-568B-CB3E-C1B9-C3051933A243}"/>
+                <a16:creationId xmlns:a16="http://schemas.microsoft.com/office/drawing/2014/main" id="{06799F08-5836-AA74-D689-BA421FCA62B9}"/>
               </a:ext>
             </a:extLst>
           </p:cNvPr>
@@ -15146,7 +15157,7 @@
           <p:cNvPr id="10" name="TextBox 9">
             <a:extLst>
               <a:ext uri="{FF2B5EF4-FFF2-40B4-BE49-F238E27FC236}">
-                <a16:creationId xmlns:a16="http://schemas.microsoft.com/office/drawing/2014/main" id="{4BE10F50-E462-AE5C-44C8-AB56FC95DC38}"/>
+                <a16:creationId xmlns:a16="http://schemas.microsoft.com/office/drawing/2014/main" id="{010517B3-AE89-7F32-E2BF-3E2F1942A0A5}"/>
               </a:ext>
             </a:extLst>
           </p:cNvPr>
@@ -15186,7 +15197,7 @@
           <p:cNvPr id="11" name="TextBox 10">
             <a:extLst>
               <a:ext uri="{FF2B5EF4-FFF2-40B4-BE49-F238E27FC236}">
-                <a16:creationId xmlns:a16="http://schemas.microsoft.com/office/drawing/2014/main" id="{A566E2A9-5B22-E2A5-DD82-074EE93D9170}"/>
+                <a16:creationId xmlns:a16="http://schemas.microsoft.com/office/drawing/2014/main" id="{C0D8E8B5-287B-4CAE-24A5-0EA5348A1CC9}"/>
               </a:ext>
             </a:extLst>
           </p:cNvPr>
@@ -15232,7 +15243,7 @@
           <p:cNvPr id="12" name="TextBox 11">
             <a:extLst>
               <a:ext uri="{FF2B5EF4-FFF2-40B4-BE49-F238E27FC236}">
-                <a16:creationId xmlns:a16="http://schemas.microsoft.com/office/drawing/2014/main" id="{A10C879C-986C-BAC4-0529-6FBAA437BF9A}"/>
+                <a16:creationId xmlns:a16="http://schemas.microsoft.com/office/drawing/2014/main" id="{87734C04-F767-9EB2-9B8B-4D432AB7CBBC}"/>
               </a:ext>
             </a:extLst>
           </p:cNvPr>
@@ -15272,7 +15283,7 @@
           <p:cNvPr id="13" name="TextBox 12">
             <a:extLst>
               <a:ext uri="{FF2B5EF4-FFF2-40B4-BE49-F238E27FC236}">
-                <a16:creationId xmlns:a16="http://schemas.microsoft.com/office/drawing/2014/main" id="{BC5D901F-5F7A-232E-4F46-E4A9B3738197}"/>
+                <a16:creationId xmlns:a16="http://schemas.microsoft.com/office/drawing/2014/main" id="{171FE720-8B5B-C19A-4AC9-5BB2761E5685}"/>
               </a:ext>
             </a:extLst>
           </p:cNvPr>
@@ -15311,7 +15322,7 @@
     </p:spTree>
     <p:extLst>
       <p:ext uri="{BB962C8B-B14F-4D97-AF65-F5344CB8AC3E}">
-        <p14:creationId xmlns:p14="http://schemas.microsoft.com/office/powerpoint/2010/main" val="2901759577"/>
+        <p14:creationId xmlns:p14="http://schemas.microsoft.com/office/powerpoint/2010/main" val="1843425799"/>
       </p:ext>
     </p:extLst>
   </p:cSld>
@@ -15343,7 +15354,7 @@
           <p:cNvPr id="2" name="TextBox 1">
             <a:extLst>
               <a:ext uri="{FF2B5EF4-FFF2-40B4-BE49-F238E27FC236}">
-                <a16:creationId xmlns:a16="http://schemas.microsoft.com/office/drawing/2014/main" id="{284DA727-936D-C035-E338-75E1DD393AF3}"/>
+                <a16:creationId xmlns:a16="http://schemas.microsoft.com/office/drawing/2014/main" id="{C96C748D-AE5B-8CE1-E6AD-FC3DEB9851D7}"/>
               </a:ext>
             </a:extLst>
           </p:cNvPr>
@@ -15383,7 +15394,7 @@
           <p:cNvPr id="3" name="TextBox 2">
             <a:extLst>
               <a:ext uri="{FF2B5EF4-FFF2-40B4-BE49-F238E27FC236}">
-                <a16:creationId xmlns:a16="http://schemas.microsoft.com/office/drawing/2014/main" id="{BD1DB7FB-261A-99FB-1D57-FC6C1A284C85}"/>
+                <a16:creationId xmlns:a16="http://schemas.microsoft.com/office/drawing/2014/main" id="{73AE6C67-3510-9AFC-6543-E138F3876D35}"/>
               </a:ext>
             </a:extLst>
           </p:cNvPr>
@@ -15423,7 +15434,7 @@
           <p:cNvPr id="4" name="Rectangle: Rounded Corners 3">
             <a:extLst>
               <a:ext uri="{FF2B5EF4-FFF2-40B4-BE49-F238E27FC236}">
-                <a16:creationId xmlns:a16="http://schemas.microsoft.com/office/drawing/2014/main" id="{B199D7F6-1A49-6CD5-5B05-6B92DC8FC3B5}"/>
+                <a16:creationId xmlns:a16="http://schemas.microsoft.com/office/drawing/2014/main" id="{9809DA09-7AE6-6CF8-D74B-4ADE175A9132}"/>
               </a:ext>
             </a:extLst>
           </p:cNvPr>
@@ -15483,7 +15494,7 @@
           <p:cNvPr id="5" name="TextBox 4">
             <a:extLst>
               <a:ext uri="{FF2B5EF4-FFF2-40B4-BE49-F238E27FC236}">
-                <a16:creationId xmlns:a16="http://schemas.microsoft.com/office/drawing/2014/main" id="{3213F7AC-6298-35EB-D0CB-91C5012DBAA0}"/>
+                <a16:creationId xmlns:a16="http://schemas.microsoft.com/office/drawing/2014/main" id="{8C82D906-4960-B345-F680-C87EC7DFCC61}"/>
               </a:ext>
             </a:extLst>
           </p:cNvPr>
@@ -15523,7 +15534,7 @@
           <p:cNvPr id="6" name="TextBox 5">
             <a:extLst>
               <a:ext uri="{FF2B5EF4-FFF2-40B4-BE49-F238E27FC236}">
-                <a16:creationId xmlns:a16="http://schemas.microsoft.com/office/drawing/2014/main" id="{7115AAA5-4E24-3E88-00B6-105318ECC9BD}"/>
+                <a16:creationId xmlns:a16="http://schemas.microsoft.com/office/drawing/2014/main" id="{0765491F-33A0-9834-36D0-266B71F0814C}"/>
               </a:ext>
             </a:extLst>
           </p:cNvPr>
@@ -15563,7 +15574,7 @@
           <p:cNvPr id="7" name="Rectangle: Rounded Corners 6">
             <a:extLst>
               <a:ext uri="{FF2B5EF4-FFF2-40B4-BE49-F238E27FC236}">
-                <a16:creationId xmlns:a16="http://schemas.microsoft.com/office/drawing/2014/main" id="{3F301EF2-0DAC-033E-487B-8CA3DE559A36}"/>
+                <a16:creationId xmlns:a16="http://schemas.microsoft.com/office/drawing/2014/main" id="{DDFB152C-CEAE-D0D7-0A51-8D648FBFA960}"/>
               </a:ext>
             </a:extLst>
           </p:cNvPr>
@@ -15623,7 +15634,7 @@
           <p:cNvPr id="8" name="TextBox 7">
             <a:extLst>
               <a:ext uri="{FF2B5EF4-FFF2-40B4-BE49-F238E27FC236}">
-                <a16:creationId xmlns:a16="http://schemas.microsoft.com/office/drawing/2014/main" id="{C8B2E152-AFD5-F842-A4C0-28A5D28BB251}"/>
+                <a16:creationId xmlns:a16="http://schemas.microsoft.com/office/drawing/2014/main" id="{BA26F315-0B5F-5C5E-152C-B0ED96834445}"/>
               </a:ext>
             </a:extLst>
           </p:cNvPr>
@@ -15663,7 +15674,7 @@
           <p:cNvPr id="9" name="TextBox 8">
             <a:extLst>
               <a:ext uri="{FF2B5EF4-FFF2-40B4-BE49-F238E27FC236}">
-                <a16:creationId xmlns:a16="http://schemas.microsoft.com/office/drawing/2014/main" id="{936D0199-37FB-3765-AAF2-5E05FCA95935}"/>
+                <a16:creationId xmlns:a16="http://schemas.microsoft.com/office/drawing/2014/main" id="{E0989ACF-5639-6051-4177-B40E9C7DBE43}"/>
               </a:ext>
             </a:extLst>
           </p:cNvPr>
@@ -15703,7 +15714,7 @@
           <p:cNvPr id="10" name="Rectangle: Rounded Corners 9">
             <a:extLst>
               <a:ext uri="{FF2B5EF4-FFF2-40B4-BE49-F238E27FC236}">
-                <a16:creationId xmlns:a16="http://schemas.microsoft.com/office/drawing/2014/main" id="{384AC63A-ED9F-4E61-5F17-124375798BF2}"/>
+                <a16:creationId xmlns:a16="http://schemas.microsoft.com/office/drawing/2014/main" id="{3548C982-00DD-4F51-B42B-8C714EE6DE09}"/>
               </a:ext>
             </a:extLst>
           </p:cNvPr>
@@ -15763,7 +15774,7 @@
           <p:cNvPr id="11" name="TextBox 10">
             <a:extLst>
               <a:ext uri="{FF2B5EF4-FFF2-40B4-BE49-F238E27FC236}">
-                <a16:creationId xmlns:a16="http://schemas.microsoft.com/office/drawing/2014/main" id="{1C115339-2077-4B2A-167C-BC686EB61804}"/>
+                <a16:creationId xmlns:a16="http://schemas.microsoft.com/office/drawing/2014/main" id="{A6B23707-BCCC-9E30-75FD-AF73AB061131}"/>
               </a:ext>
             </a:extLst>
           </p:cNvPr>
@@ -15803,7 +15814,7 @@
           <p:cNvPr id="12" name="TextBox 11">
             <a:extLst>
               <a:ext uri="{FF2B5EF4-FFF2-40B4-BE49-F238E27FC236}">
-                <a16:creationId xmlns:a16="http://schemas.microsoft.com/office/drawing/2014/main" id="{C66DAD02-93EF-5CC7-5CF6-70BE7BE51CFA}"/>
+                <a16:creationId xmlns:a16="http://schemas.microsoft.com/office/drawing/2014/main" id="{1004C3FE-E661-1B41-55B3-C3C4368A8604}"/>
               </a:ext>
             </a:extLst>
           </p:cNvPr>
@@ -15843,7 +15854,7 @@
           <p:cNvPr id="13" name="Rectangle: Rounded Corners 12">
             <a:extLst>
               <a:ext uri="{FF2B5EF4-FFF2-40B4-BE49-F238E27FC236}">
-                <a16:creationId xmlns:a16="http://schemas.microsoft.com/office/drawing/2014/main" id="{FE7E784A-9584-13FB-CC1D-DCC66E24EDF3}"/>
+                <a16:creationId xmlns:a16="http://schemas.microsoft.com/office/drawing/2014/main" id="{BC396716-6481-1FB0-3A42-108AB35B279C}"/>
               </a:ext>
             </a:extLst>
           </p:cNvPr>
@@ -15903,7 +15914,7 @@
           <p:cNvPr id="14" name="TextBox 13">
             <a:extLst>
               <a:ext uri="{FF2B5EF4-FFF2-40B4-BE49-F238E27FC236}">
-                <a16:creationId xmlns:a16="http://schemas.microsoft.com/office/drawing/2014/main" id="{C25AACFA-800A-B988-0345-AEAEDAAFC263}"/>
+                <a16:creationId xmlns:a16="http://schemas.microsoft.com/office/drawing/2014/main" id="{0884513B-9C53-5A89-681B-42C295EAC3B8}"/>
               </a:ext>
             </a:extLst>
           </p:cNvPr>
@@ -15943,7 +15954,7 @@
           <p:cNvPr id="15" name="TextBox 14">
             <a:extLst>
               <a:ext uri="{FF2B5EF4-FFF2-40B4-BE49-F238E27FC236}">
-                <a16:creationId xmlns:a16="http://schemas.microsoft.com/office/drawing/2014/main" id="{FDD5EB42-48B7-2F2A-57A6-88164999C2E3}"/>
+                <a16:creationId xmlns:a16="http://schemas.microsoft.com/office/drawing/2014/main" id="{714B8DA3-2B93-B6B5-8E68-38A16D5CF222}"/>
               </a:ext>
             </a:extLst>
           </p:cNvPr>
@@ -15983,7 +15994,7 @@
           <p:cNvPr id="16" name="Rectangle: Rounded Corners 15">
             <a:extLst>
               <a:ext uri="{FF2B5EF4-FFF2-40B4-BE49-F238E27FC236}">
-                <a16:creationId xmlns:a16="http://schemas.microsoft.com/office/drawing/2014/main" id="{7D36FAA0-CDED-F5EA-9D5E-FC5AB78D42B4}"/>
+                <a16:creationId xmlns:a16="http://schemas.microsoft.com/office/drawing/2014/main" id="{5E97BE8C-DA67-8490-B5F8-5F75D3742487}"/>
               </a:ext>
             </a:extLst>
           </p:cNvPr>
@@ -16043,7 +16054,7 @@
           <p:cNvPr id="17" name="TextBox 16">
             <a:extLst>
               <a:ext uri="{FF2B5EF4-FFF2-40B4-BE49-F238E27FC236}">
-                <a16:creationId xmlns:a16="http://schemas.microsoft.com/office/drawing/2014/main" id="{21521833-5F85-9C6B-D229-3F0EAD56ACE8}"/>
+                <a16:creationId xmlns:a16="http://schemas.microsoft.com/office/drawing/2014/main" id="{3013CDF6-68A8-2260-84FD-C98A741E4EEE}"/>
               </a:ext>
             </a:extLst>
           </p:cNvPr>
@@ -16083,7 +16094,7 @@
           <p:cNvPr id="18" name="TextBox 17">
             <a:extLst>
               <a:ext uri="{FF2B5EF4-FFF2-40B4-BE49-F238E27FC236}">
-                <a16:creationId xmlns:a16="http://schemas.microsoft.com/office/drawing/2014/main" id="{08F4D525-D223-2A6F-DBD7-32BACFF486FE}"/>
+                <a16:creationId xmlns:a16="http://schemas.microsoft.com/office/drawing/2014/main" id="{0EEA9CA3-2EE3-5B79-11A1-FA8F332B066A}"/>
               </a:ext>
             </a:extLst>
           </p:cNvPr>
@@ -16123,7 +16134,7 @@
           <p:cNvPr id="19" name="TextBox 18">
             <a:extLst>
               <a:ext uri="{FF2B5EF4-FFF2-40B4-BE49-F238E27FC236}">
-                <a16:creationId xmlns:a16="http://schemas.microsoft.com/office/drawing/2014/main" id="{53A7B887-F1B0-3484-23C1-8CBA3976A654}"/>
+                <a16:creationId xmlns:a16="http://schemas.microsoft.com/office/drawing/2014/main" id="{325E8F01-C9D6-5ABC-3787-6825F428FAC0}"/>
               </a:ext>
             </a:extLst>
           </p:cNvPr>
@@ -16164,7 +16175,7 @@
           <p:cNvPr id="20" name="TextBox 19">
             <a:extLst>
               <a:ext uri="{FF2B5EF4-FFF2-40B4-BE49-F238E27FC236}">
-                <a16:creationId xmlns:a16="http://schemas.microsoft.com/office/drawing/2014/main" id="{92A611E9-26E0-1ED0-18EE-0A70892A224C}"/>
+                <a16:creationId xmlns:a16="http://schemas.microsoft.com/office/drawing/2014/main" id="{081AE342-29D9-129E-8A87-A390CEDF5F58}"/>
               </a:ext>
             </a:extLst>
           </p:cNvPr>
@@ -16194,7 +16205,7 @@
                 </a:solidFill>
                 <a:latin typeface="Aptos" panose="020B0004020202020204" pitchFamily="34" charset="0"/>
               </a:rPr>
-              <a:t>Initial targets: rustc-perf RDR benchmark, Cargo evidence, Windows tooling, generated-boundary provenance.</a:t>
+              <a:t>Candidate areas only. Select after maintainer alignment, a named consumer, and a build-versus-contribute review.</a:t>
             </a:r>
           </a:p>
         </p:txBody>
@@ -16204,7 +16215,7 @@
           <p:cNvPr id="21" name="TextBox 20">
             <a:extLst>
               <a:ext uri="{FF2B5EF4-FFF2-40B4-BE49-F238E27FC236}">
-                <a16:creationId xmlns:a16="http://schemas.microsoft.com/office/drawing/2014/main" id="{D24AE2B5-1384-57BD-1B2E-3A7560EB00F2}"/>
+                <a16:creationId xmlns:a16="http://schemas.microsoft.com/office/drawing/2014/main" id="{99CE46C3-F526-A24F-CC6D-AED78F0993BD}"/>
               </a:ext>
             </a:extLst>
           </p:cNvPr>
@@ -16243,7 +16254,7 @@
     </p:spTree>
     <p:extLst>
       <p:ext uri="{BB962C8B-B14F-4D97-AF65-F5344CB8AC3E}">
-        <p14:creationId xmlns:p14="http://schemas.microsoft.com/office/powerpoint/2010/main" val="1173582889"/>
+        <p14:creationId xmlns:p14="http://schemas.microsoft.com/office/powerpoint/2010/main" val="64103713"/>
       </p:ext>
     </p:extLst>
   </p:cSld>

</xml_diff>